<commit_message>
Apply dark executive theme to native PPTX generation
</commit_message>
<xml_diff>
--- a/The_AI_Progress_Blueprint.pptx
+++ b/The_AI_Progress_Blueprint.pptx
@@ -3096,6 +3096,14 @@
 <file path=ppt/slides/slide1.xml><?xml version="1.0" encoding="utf-8"?>
 <p:sld xmlns:a="http://schemas.openxmlformats.org/drawingml/2006/main" xmlns:p="http://schemas.openxmlformats.org/presentationml/2006/main" xmlns:r="http://schemas.openxmlformats.org/officeDocument/2006/relationships">
   <p:cSld>
+    <p:bg>
+      <p:bgPr>
+        <a:solidFill>
+          <a:srgbClr val="141E30"/>
+        </a:solidFill>
+        <a:effectLst/>
+      </p:bgPr>
+    </p:bg>
     <p:spTree>
       <p:nvGrpSpPr>
         <p:cNvPr id="1" name=""/>
@@ -3118,8 +3126,16 @@
           <a:bodyPr/>
           <a:lstStyle/>
           <a:p>
-            <a:r>
-              <a:t>The Architecture of AI Progress: Synthesizing the Formal Foundations and Empirical Drivers of Artificial Intelligence</a:t>
+            <a:pPr>
+              <a:defRPr b="1" sz="4000">
+                <a:solidFill>
+                  <a:srgbClr val="FFD700"/>
+                </a:solidFill>
+                <a:latin typeface="Arial"/>
+              </a:defRPr>
+            </a:pPr>
+            <a:r>
+              <a:t>The Architecture of AI Progress</a:t>
             </a:r>
           </a:p>
         </p:txBody>
@@ -3136,28 +3152,69 @@
         </p:nvSpPr>
         <p:spPr/>
         <p:txBody>
-          <a:bodyPr/>
-          <a:lstStyle/>
-          <a:p>
-            <a:pPr/>
+          <a:bodyPr wrap="square"/>
+          <a:lstStyle/>
+          <a:p>
+            <a:pPr>
+              <a:defRPr sz="2800">
+                <a:solidFill>
+                  <a:srgbClr val="F0F0F0"/>
+                </a:solidFill>
+                <a:latin typeface="Arial"/>
+              </a:defRPr>
+            </a:pPr>
+            <a:r>
+              <a:t>Synthesizing the Formal Foundations and Empirical Drivers of Artificial Intelligence</a:t>
+            </a:r>
+          </a:p>
+          <a:p>
+            <a:pPr>
+              <a:defRPr sz="2800">
+                <a:solidFill>
+                  <a:srgbClr val="F0F0F0"/>
+                </a:solidFill>
+                <a:latin typeface="Arial"/>
+              </a:defRPr>
+            </a:pPr>
             <a:r>
               <a:t>A Unified Theoretical Framework: Presenting a cohesive research program that bridges theoretical limits and engineering realities</a:t>
             </a:r>
           </a:p>
           <a:p>
-            <a:pPr/>
+            <a:pPr>
+              <a:defRPr sz="2800">
+                <a:solidFill>
+                  <a:srgbClr val="F0F0F0"/>
+                </a:solidFill>
+                <a:latin typeface="Arial"/>
+              </a:defRPr>
+            </a:pPr>
             <a:r>
               <a:t>Two Connected Pairs:</a:t>
             </a:r>
           </a:p>
           <a:p>
-            <a:pPr lvl="1"/>
+            <a:pPr lvl="1">
+              <a:defRPr sz="2400">
+                <a:solidFill>
+                  <a:srgbClr val="F0F0F0"/>
+                </a:solidFill>
+                <a:latin typeface="Arial"/>
+              </a:defRPr>
+            </a:pPr>
             <a:r>
               <a:t>Pair 1 (The Formal Foundation): Intelligence defined by its outer boundary of computability and inner boundary of polynomial-time feasibility</a:t>
             </a:r>
           </a:p>
           <a:p>
-            <a:pPr lvl="1"/>
+            <a:pPr lvl="1">
+              <a:defRPr sz="2400">
+                <a:solidFill>
+                  <a:srgbClr val="F0F0F0"/>
+                </a:solidFill>
+                <a:latin typeface="Arial"/>
+              </a:defRPr>
+            </a:pPr>
             <a:r>
               <a:t>Pair 2 (The Practical Bridge): The empirical driver of scaling laws and the architectural consequences of hardware allocation</a:t>
             </a:r>
@@ -3175,6 +3232,14 @@
 <file path=ppt/slides/slide10.xml><?xml version="1.0" encoding="utf-8"?>
 <p:sld xmlns:a="http://schemas.openxmlformats.org/drawingml/2006/main" xmlns:p="http://schemas.openxmlformats.org/presentationml/2006/main" xmlns:r="http://schemas.openxmlformats.org/officeDocument/2006/relationships">
   <p:cSld>
+    <p:bg>
+      <p:bgPr>
+        <a:solidFill>
+          <a:srgbClr val="141E30"/>
+        </a:solidFill>
+        <a:effectLst/>
+      </p:bgPr>
+    </p:bg>
     <p:spTree>
       <p:nvGrpSpPr>
         <p:cNvPr id="1" name=""/>
@@ -3197,6 +3262,14 @@
           <a:bodyPr/>
           <a:lstStyle/>
           <a:p>
+            <a:pPr>
+              <a:defRPr b="1" sz="4000">
+                <a:solidFill>
+                  <a:srgbClr val="FFD700"/>
+                </a:solidFill>
+                <a:latin typeface="Arial"/>
+              </a:defRPr>
+            </a:pPr>
             <a:r>
               <a:t>Paper 3: Scaling Laws and Logical Compute</a:t>
             </a:r>
@@ -3215,22 +3288,43 @@
         </p:nvSpPr>
         <p:spPr/>
         <p:txBody>
-          <a:bodyPr/>
-          <a:lstStyle/>
-          <a:p>
-            <a:pPr/>
+          <a:bodyPr wrap="square"/>
+          <a:lstStyle/>
+          <a:p>
+            <a:pPr>
+              <a:defRPr sz="2800">
+                <a:solidFill>
+                  <a:srgbClr val="F0F0F0"/>
+                </a:solidFill>
+                <a:latin typeface="Arial"/>
+              </a:defRPr>
+            </a:pPr>
             <a:r>
               <a:t>The Power of Abstraction: Scaling laws are unreasonably effective precisely because they abstract over realization details</a:t>
             </a:r>
           </a:p>
           <a:p>
-            <a:pPr/>
+            <a:pPr>
+              <a:defRPr sz="2800">
+                <a:solidFill>
+                  <a:srgbClr val="F0F0F0"/>
+                </a:solidFill>
+                <a:latin typeface="Arial"/>
+              </a:defRPr>
+            </a:pPr>
             <a:r>
               <a:t>Logical vs. Physical Compute: The "compute" variable actually represents logical compute (abstract model-side work), independent of the efficiency of the physical hardware</a:t>
             </a:r>
           </a:p>
           <a:p>
-            <a:pPr/>
+            <a:pPr>
+              <a:defRPr sz="2800">
+                <a:solidFill>
+                  <a:srgbClr val="F0F0F0"/>
+                </a:solidFill>
+                <a:latin typeface="Arial"/>
+              </a:defRPr>
+            </a:pPr>
             <a:r>
               <a:t>The Real Meaning of Diminishing Returns: A flattening scaling curve does not just mean slower progress; it represents a rapidly escalating physical and operational burden to achieve the next step of value</a:t>
             </a:r>
@@ -3248,6 +3342,14 @@
 <file path=ppt/slides/slide11.xml><?xml version="1.0" encoding="utf-8"?>
 <p:sld xmlns:a="http://schemas.openxmlformats.org/drawingml/2006/main" xmlns:p="http://schemas.openxmlformats.org/presentationml/2006/main" xmlns:r="http://schemas.openxmlformats.org/officeDocument/2006/relationships">
   <p:cSld>
+    <p:bg>
+      <p:bgPr>
+        <a:solidFill>
+          <a:srgbClr val="141E30"/>
+        </a:solidFill>
+        <a:effectLst/>
+      </p:bgPr>
+    </p:bg>
     <p:spTree>
       <p:nvGrpSpPr>
         <p:cNvPr id="1" name=""/>
@@ -3270,6 +3372,14 @@
           <a:bodyPr/>
           <a:lstStyle/>
           <a:p>
+            <a:pPr>
+              <a:defRPr b="1" sz="4000">
+                <a:solidFill>
+                  <a:srgbClr val="FFD700"/>
+                </a:solidFill>
+                <a:latin typeface="Arial"/>
+              </a:defRPr>
+            </a:pPr>
             <a:r>
               <a:t>Paper 3: The Dynamic Implication of Hidden Efficiency</a:t>
             </a:r>
@@ -3288,22 +3398,43 @@
         </p:nvSpPr>
         <p:spPr/>
         <p:txBody>
-          <a:bodyPr/>
-          <a:lstStyle/>
-          <a:p>
-            <a:pPr lvl="1"/>
+          <a:bodyPr wrap="square"/>
+          <a:lstStyle/>
+          <a:p>
+            <a:pPr lvl="1">
+              <a:defRPr i="1" sz="2000">
+                <a:solidFill>
+                  <a:srgbClr val="6496FF"/>
+                </a:solidFill>
+                <a:latin typeface="Arial"/>
+              </a:defRPr>
+            </a:pPr>
             <a:r>
               <a:t>[Visual Concept: A pressure-conversion loop showing logical compute demand driving efficiency optimization across the stack]</a:t>
             </a:r>
           </a:p>
           <a:p>
-            <a:pPr/>
+            <a:pPr>
+              <a:defRPr sz="2800">
+                <a:solidFill>
+                  <a:srgbClr val="F0F0F0"/>
+                </a:solidFill>
+                <a:latin typeface="Arial"/>
+              </a:defRPr>
+            </a:pPr>
             <a:r>
               <a:t>The Efficiency Race: Progress persists because of repeated, compounding efficiency gains in algorithms, low-precision software, systems, and hardware</a:t>
             </a:r>
           </a:p>
           <a:p>
-            <a:pPr/>
+            <a:pPr>
+              <a:defRPr sz="2800">
+                <a:solidFill>
+                  <a:srgbClr val="F0F0F0"/>
+                </a:solidFill>
+                <a:latin typeface="Arial"/>
+              </a:defRPr>
+            </a:pPr>
             <a:r>
               <a:t>Changing the Cost: The empirical scaling law dictates what logical compute buys; the compounding efficiency stack constantly changes what that compute costs</a:t>
             </a:r>
@@ -3321,6 +3452,14 @@
 <file path=ppt/slides/slide12.xml><?xml version="1.0" encoding="utf-8"?>
 <p:sld xmlns:a="http://schemas.openxmlformats.org/drawingml/2006/main" xmlns:p="http://schemas.openxmlformats.org/presentationml/2006/main" xmlns:r="http://schemas.openxmlformats.org/officeDocument/2006/relationships">
   <p:cSld>
+    <p:bg>
+      <p:bgPr>
+        <a:solidFill>
+          <a:srgbClr val="141E30"/>
+        </a:solidFill>
+        <a:effectLst/>
+      </p:bgPr>
+    </p:bg>
     <p:spTree>
       <p:nvGrpSpPr>
         <p:cNvPr id="1" name=""/>
@@ -3343,6 +3482,14 @@
           <a:bodyPr/>
           <a:lstStyle/>
           <a:p>
+            <a:pPr>
+              <a:defRPr b="1" sz="4000">
+                <a:solidFill>
+                  <a:srgbClr val="FFD700"/>
+                </a:solidFill>
+                <a:latin typeface="Arial"/>
+              </a:defRPr>
+            </a:pPr>
             <a:r>
               <a:t>Paper 4: Modernizing Amdahl’s Law</a:t>
             </a:r>
@@ -3361,22 +3508,43 @@
         </p:nvSpPr>
         <p:spPr/>
         <p:txBody>
-          <a:bodyPr/>
-          <a:lstStyle/>
-          <a:p>
-            <a:pPr/>
+          <a:bodyPr wrap="square"/>
+          <a:lstStyle/>
+          <a:p>
+            <a:pPr>
+              <a:defRPr sz="2800">
+                <a:solidFill>
+                  <a:srgbClr val="F0F0F0"/>
+                </a:solidFill>
+                <a:latin typeface="Arial"/>
+              </a:defRPr>
+            </a:pPr>
             <a:r>
               <a:t>Beyond Core Counts: Classical Amdahl’s Law (fixed serial/parallel fraction) fails to describe modern heterogeneous AI architectures</a:t>
             </a:r>
           </a:p>
           <a:p>
-            <a:pPr/>
+            <a:pPr>
+              <a:defRPr sz="2800">
+                <a:solidFill>
+                  <a:srgbClr val="F0F0F0"/>
+                </a:solidFill>
+                <a:latin typeface="Arial"/>
+              </a:defRPr>
+            </a:pPr>
             <a:r>
               <a:t>Constrained Hardware Allocation: The modern design question is how to allocate a constrained hardware budget between specialized logic and programmable compute</a:t>
             </a:r>
           </a:p>
           <a:p>
-            <a:pPr/>
+            <a:pPr>
+              <a:defRPr sz="2800">
+                <a:solidFill>
+                  <a:srgbClr val="F0F0F0"/>
+                </a:solidFill>
+                <a:latin typeface="Arial"/>
+              </a:defRPr>
+            </a:pPr>
             <a:r>
               <a:t>The Value-Scalable Fraction (S): The portion of the workload where injecting additional compute continues to create meaningful, end-to-end task value</a:t>
             </a:r>
@@ -3394,6 +3562,14 @@
 <file path=ppt/slides/slide13.xml><?xml version="1.0" encoding="utf-8"?>
 <p:sld xmlns:a="http://schemas.openxmlformats.org/drawingml/2006/main" xmlns:p="http://schemas.openxmlformats.org/presentationml/2006/main" xmlns:r="http://schemas.openxmlformats.org/officeDocument/2006/relationships">
   <p:cSld>
+    <p:bg>
+      <p:bgPr>
+        <a:solidFill>
+          <a:srgbClr val="141E30"/>
+        </a:solidFill>
+        <a:effectLst/>
+      </p:bgPr>
+    </p:bg>
     <p:spTree>
       <p:nvGrpSpPr>
         <p:cNvPr id="1" name=""/>
@@ -3416,6 +3592,14 @@
           <a:bodyPr/>
           <a:lstStyle/>
           <a:p>
+            <a:pPr>
+              <a:defRPr b="1" sz="4000">
+                <a:solidFill>
+                  <a:srgbClr val="FFD700"/>
+                </a:solidFill>
+                <a:latin typeface="Arial"/>
+              </a:defRPr>
+            </a:pPr>
             <a:r>
               <a:t>Paper 4: The Collapse Threshold of Specialization</a:t>
             </a:r>
@@ -3434,28 +3618,56 @@
         </p:nvSpPr>
         <p:spPr/>
         <p:txBody>
-          <a:bodyPr/>
-          <a:lstStyle/>
-          <a:p>
-            <a:pPr lvl="1"/>
+          <a:bodyPr wrap="square"/>
+          <a:lstStyle/>
+          <a:p>
+            <a:pPr lvl="1">
+              <a:defRPr i="1" sz="2000">
+                <a:solidFill>
+                  <a:srgbClr val="6496FF"/>
+                </a:solidFill>
+                <a:latin typeface="Arial"/>
+              </a:defRPr>
+            </a:pPr>
             <a:r>
               <a:t>[Visual Concept: A phase-boundary graph showing the race between Specialization Efficiency (R) and Scalable Fraction (S)]</a:t>
             </a:r>
           </a:p>
           <a:p>
-            <a:pPr/>
+            <a:pPr>
+              <a:defRPr sz="2800">
+                <a:solidFill>
+                  <a:srgbClr val="F0F0F0"/>
+                </a:solidFill>
+                <a:latin typeface="Arial"/>
+              </a:defRPr>
+            </a:pPr>
             <a:r>
               <a:t>The Rising Bar: As the value-scalable workload (S) grows, fixed-function specialization faces a strict collapse threshold</a:t>
             </a:r>
           </a:p>
           <a:p>
-            <a:pPr/>
+            <a:pPr>
+              <a:defRPr sz="2800">
+                <a:solidFill>
+                  <a:srgbClr val="F0F0F0"/>
+                </a:solidFill>
+                <a:latin typeface="Arial"/>
+              </a:defRPr>
+            </a:pPr>
             <a:r>
               <a:t>The Key Equation: For a given scalable fraction S, specialized hardware must achieve a relative efficiency ratio of R_c = 1/(1−S) to justify its inclusion</a:t>
             </a:r>
           </a:p>
           <a:p>
-            <a:pPr/>
+            <a:pPr>
+              <a:defRPr sz="2800">
+                <a:solidFill>
+                  <a:srgbClr val="F0F0F0"/>
+                </a:solidFill>
+                <a:latin typeface="Arial"/>
+              </a:defRPr>
+            </a:pPr>
             <a:r>
               <a:t>Specialization must constantly re-earn its silicon</a:t>
             </a:r>
@@ -3473,6 +3685,14 @@
 <file path=ppt/slides/slide14.xml><?xml version="1.0" encoding="utf-8"?>
 <p:sld xmlns:a="http://schemas.openxmlformats.org/drawingml/2006/main" xmlns:p="http://schemas.openxmlformats.org/presentationml/2006/main" xmlns:r="http://schemas.openxmlformats.org/officeDocument/2006/relationships">
   <p:cSld>
+    <p:bg>
+      <p:bgPr>
+        <a:solidFill>
+          <a:srgbClr val="141E30"/>
+        </a:solidFill>
+        <a:effectLst/>
+      </p:bgPr>
+    </p:bg>
     <p:spTree>
       <p:nvGrpSpPr>
         <p:cNvPr id="1" name=""/>
@@ -3495,6 +3715,14 @@
           <a:bodyPr/>
           <a:lstStyle/>
           <a:p>
+            <a:pPr>
+              <a:defRPr b="1" sz="4000">
+                <a:solidFill>
+                  <a:srgbClr val="FFD700"/>
+                </a:solidFill>
+                <a:latin typeface="Arial"/>
+              </a:defRPr>
+            </a:pPr>
             <a:r>
               <a:t>Architectural Consequence: The Pressure for Programmability</a:t>
             </a:r>
@@ -3513,22 +3741,43 @@
         </p:nvSpPr>
         <p:spPr/>
         <p:txBody>
-          <a:bodyPr/>
-          <a:lstStyle/>
-          <a:p>
-            <a:pPr/>
+          <a:bodyPr wrap="square"/>
+          <a:lstStyle/>
+          <a:p>
+            <a:pPr>
+              <a:defRPr sz="2800">
+                <a:solidFill>
+                  <a:srgbClr val="F0F0F0"/>
+                </a:solidFill>
+                <a:latin typeface="Arial"/>
+              </a:defRPr>
+            </a:pPr>
             <a:r>
               <a:t>Shifting Value: AI scaling pushes value-generation away from early fixed pipelines toward learned, late-stage computation (e.g., neural reconstruction, massive rerankers)</a:t>
             </a:r>
           </a:p>
           <a:p>
-            <a:pPr/>
+            <a:pPr>
+              <a:defRPr sz="2800">
+                <a:solidFill>
+                  <a:srgbClr val="F0F0F0"/>
+                </a:solidFill>
+                <a:latin typeface="Arial"/>
+              </a:defRPr>
+            </a:pPr>
             <a:r>
               <a:t>Why GPUs Become More Programmable: As S rises, the optimal hardware locus shifts toward generalized, tensor-heavy programmable compute</a:t>
             </a:r>
           </a:p>
           <a:p>
-            <a:pPr/>
+            <a:pPr>
+              <a:defRPr sz="2800">
+                <a:solidFill>
+                  <a:srgbClr val="F0F0F0"/>
+                </a:solidFill>
+                <a:latin typeface="Arial"/>
+              </a:defRPr>
+            </a:pPr>
             <a:r>
               <a:t>The Accelerator Dynamic: AI domain-specific accelerators matter, but they do not simply displace the GPU; they must continually adapt as the dominant value-producing workload evolves</a:t>
             </a:r>
@@ -3546,6 +3795,14 @@
 <file path=ppt/slides/slide15.xml><?xml version="1.0" encoding="utf-8"?>
 <p:sld xmlns:a="http://schemas.openxmlformats.org/drawingml/2006/main" xmlns:p="http://schemas.openxmlformats.org/presentationml/2006/main" xmlns:r="http://schemas.openxmlformats.org/officeDocument/2006/relationships">
   <p:cSld>
+    <p:bg>
+      <p:bgPr>
+        <a:solidFill>
+          <a:srgbClr val="141E30"/>
+        </a:solidFill>
+        <a:effectLst/>
+      </p:bgPr>
+    </p:bg>
     <p:spTree>
       <p:nvGrpSpPr>
         <p:cNvPr id="1" name=""/>
@@ -3568,6 +3825,14 @@
           <a:bodyPr/>
           <a:lstStyle/>
           <a:p>
+            <a:pPr>
+              <a:defRPr b="1" sz="4000">
+                <a:solidFill>
+                  <a:srgbClr val="FFD700"/>
+                </a:solidFill>
+                <a:latin typeface="Arial"/>
+              </a:defRPr>
+            </a:pPr>
             <a:r>
               <a:t>Final Synthesis: The Unified Picture</a:t>
             </a:r>
@@ -3586,34 +3851,69 @@
         </p:nvSpPr>
         <p:spPr/>
         <p:txBody>
-          <a:bodyPr/>
-          <a:lstStyle/>
-          <a:p>
-            <a:pPr lvl="1"/>
+          <a:bodyPr wrap="square"/>
+          <a:lstStyle/>
+          <a:p>
+            <a:pPr lvl="1">
+              <a:defRPr i="1" sz="2000">
+                <a:solidFill>
+                  <a:srgbClr val="6496FF"/>
+                </a:solidFill>
+                <a:latin typeface="Arial"/>
+              </a:defRPr>
+            </a:pPr>
             <a:r>
               <a:t>[Visual Concept: A single clean structural diagram linking formal limits, bounded feasibility, empirical scaling, and hardware architecture]</a:t>
             </a:r>
           </a:p>
           <a:p>
-            <a:pPr lvl="1"/>
+            <a:pPr lvl="1">
+              <a:defRPr sz="2400">
+                <a:solidFill>
+                  <a:srgbClr val="F0F0F0"/>
+                </a:solidFill>
+                <a:latin typeface="Arial"/>
+              </a:defRPr>
+            </a:pPr>
             <a:r>
               <a:t>1. Computability: Open-ended ascent across relative boundaries</a:t>
             </a:r>
           </a:p>
           <a:p>
-            <a:pPr lvl="1"/>
+            <a:pPr lvl="1">
+              <a:defRPr sz="2400">
+                <a:solidFill>
+                  <a:srgbClr val="F0F0F0"/>
+                </a:solidFill>
+                <a:latin typeface="Arial"/>
+              </a:defRPr>
+            </a:pPr>
             <a:r>
               <a:t>2. Feasibility: Staged reachability through polynomial-time verification</a:t>
             </a:r>
           </a:p>
           <a:p>
-            <a:pPr lvl="1"/>
+            <a:pPr lvl="1">
+              <a:defRPr sz="2400">
+                <a:solidFill>
+                  <a:srgbClr val="F0F0F0"/>
+                </a:solidFill>
+                <a:latin typeface="Arial"/>
+              </a:defRPr>
+            </a:pPr>
             <a:r>
               <a:t>3. Empirical Drivers: Logical scaling sustained by compounding hidden efficiency</a:t>
             </a:r>
           </a:p>
           <a:p>
-            <a:pPr lvl="1"/>
+            <a:pPr lvl="1">
+              <a:defRPr sz="2400">
+                <a:solidFill>
+                  <a:srgbClr val="F0F0F0"/>
+                </a:solidFill>
+                <a:latin typeface="Arial"/>
+              </a:defRPr>
+            </a:pPr>
             <a:r>
               <a:t>4. Architectural Response: Rising scalable workloads driving hardware toward programmable compute</a:t>
             </a:r>
@@ -3631,6 +3931,14 @@
 <file path=ppt/slides/slide16.xml><?xml version="1.0" encoding="utf-8"?>
 <p:sld xmlns:a="http://schemas.openxmlformats.org/drawingml/2006/main" xmlns:p="http://schemas.openxmlformats.org/presentationml/2006/main" xmlns:r="http://schemas.openxmlformats.org/officeDocument/2006/relationships">
   <p:cSld>
+    <p:bg>
+      <p:bgPr>
+        <a:solidFill>
+          <a:srgbClr val="141E30"/>
+        </a:solidFill>
+        <a:effectLst/>
+      </p:bgPr>
+    </p:bg>
     <p:spTree>
       <p:nvGrpSpPr>
         <p:cNvPr id="1" name=""/>
@@ -3653,6 +3961,14 @@
           <a:bodyPr/>
           <a:lstStyle/>
           <a:p>
+            <a:pPr>
+              <a:defRPr b="1" sz="4000">
+                <a:solidFill>
+                  <a:srgbClr val="FFD700"/>
+                </a:solidFill>
+                <a:latin typeface="Arial"/>
+              </a:defRPr>
+            </a:pPr>
             <a:r>
               <a:t>Closing Takeaways</a:t>
             </a:r>
@@ -3671,16 +3987,30 @@
         </p:nvSpPr>
         <p:spPr/>
         <p:txBody>
-          <a:bodyPr/>
-          <a:lstStyle/>
-          <a:p>
-            <a:pPr/>
+          <a:bodyPr wrap="square"/>
+          <a:lstStyle/>
+          <a:p>
+            <a:pPr>
+              <a:defRPr sz="2800">
+                <a:solidFill>
+                  <a:srgbClr val="F0F0F0"/>
+                </a:solidFill>
+                <a:latin typeface="Arial"/>
+              </a:defRPr>
+            </a:pPr>
             <a:r>
               <a:t>A Structured Phenomenon: AI progress is neither pure hype nor a contradiction of theoretical limits</a:t>
             </a:r>
           </a:p>
           <a:p>
-            <a:pPr/>
+            <a:pPr>
+              <a:defRPr sz="2800">
+                <a:solidFill>
+                  <a:srgbClr val="F0F0F0"/>
+                </a:solidFill>
+                <a:latin typeface="Arial"/>
+              </a:defRPr>
+            </a:pPr>
             <a:r>
               <a:t>The Unified Program: Intelligence emerges as a structured, open-ended process bounded by formal limits, propelled by empirical scaling drivers, and fundamentally reshaping system-level hardware consequences</a:t>
             </a:r>
@@ -3698,6 +4028,14 @@
 <file path=ppt/slides/slide2.xml><?xml version="1.0" encoding="utf-8"?>
 <p:sld xmlns:a="http://schemas.openxmlformats.org/drawingml/2006/main" xmlns:p="http://schemas.openxmlformats.org/presentationml/2006/main" xmlns:r="http://schemas.openxmlformats.org/officeDocument/2006/relationships">
   <p:cSld>
+    <p:bg>
+      <p:bgPr>
+        <a:solidFill>
+          <a:srgbClr val="141E30"/>
+        </a:solidFill>
+        <a:effectLst/>
+      </p:bgPr>
+    </p:bg>
     <p:spTree>
       <p:nvGrpSpPr>
         <p:cNvPr id="1" name=""/>
@@ -3720,6 +4058,14 @@
           <a:bodyPr/>
           <a:lstStyle/>
           <a:p>
+            <a:pPr>
+              <a:defRPr b="1" sz="4000">
+                <a:solidFill>
+                  <a:srgbClr val="FFD700"/>
+                </a:solidFill>
+                <a:latin typeface="Arial"/>
+              </a:defRPr>
+            </a:pPr>
             <a:r>
               <a:t>The Discourse Gap: Why This Program Exists</a:t>
             </a:r>
@@ -3738,22 +4084,43 @@
         </p:nvSpPr>
         <p:spPr/>
         <p:txBody>
-          <a:bodyPr/>
-          <a:lstStyle/>
-          <a:p>
-            <a:pPr/>
+          <a:bodyPr wrap="square"/>
+          <a:lstStyle/>
+          <a:p>
+            <a:pPr>
+              <a:defRPr sz="2800">
+                <a:solidFill>
+                  <a:srgbClr val="F0F0F0"/>
+                </a:solidFill>
+                <a:latin typeface="Arial"/>
+              </a:defRPr>
+            </a:pPr>
             <a:r>
               <a:t>The Hype: Empirical AI discourse often focuses on capability scaling and scaling laws without a rigorous formal theory of progress</a:t>
             </a:r>
           </a:p>
           <a:p>
-            <a:pPr/>
+            <a:pPr>
+              <a:defRPr sz="2800">
+                <a:solidFill>
+                  <a:srgbClr val="F0F0F0"/>
+                </a:solidFill>
+                <a:latin typeface="Arial"/>
+              </a:defRPr>
+            </a:pPr>
             <a:r>
               <a:t>The Limits: Theoretical discourse frequently emphasizes strict mathematical limits without explaining how relentless practical progress continues to appear</a:t>
             </a:r>
           </a:p>
           <a:p>
-            <a:pPr/>
+            <a:pPr>
+              <a:defRPr sz="2800">
+                <a:solidFill>
+                  <a:srgbClr val="F0F0F0"/>
+                </a:solidFill>
+                <a:latin typeface="Arial"/>
+              </a:defRPr>
+            </a:pPr>
             <a:r>
               <a:t>The Missing Link: We require a single, unified model that explains how formal boundaries, empirical drivers, and system-level architectural consequences interact</a:t>
             </a:r>
@@ -3771,6 +4138,14 @@
 <file path=ppt/slides/slide3.xml><?xml version="1.0" encoding="utf-8"?>
 <p:sld xmlns:a="http://schemas.openxmlformats.org/drawingml/2006/main" xmlns:p="http://schemas.openxmlformats.org/presentationml/2006/main" xmlns:r="http://schemas.openxmlformats.org/officeDocument/2006/relationships">
   <p:cSld>
+    <p:bg>
+      <p:bgPr>
+        <a:solidFill>
+          <a:srgbClr val="141E30"/>
+        </a:solidFill>
+        <a:effectLst/>
+      </p:bgPr>
+    </p:bg>
     <p:spTree>
       <p:nvGrpSpPr>
         <p:cNvPr id="1" name=""/>
@@ -3793,6 +4168,14 @@
           <a:bodyPr/>
           <a:lstStyle/>
           <a:p>
+            <a:pPr>
+              <a:defRPr b="1" sz="4000">
+                <a:solidFill>
+                  <a:srgbClr val="FFD700"/>
+                </a:solidFill>
+                <a:latin typeface="Arial"/>
+              </a:defRPr>
+            </a:pPr>
             <a:r>
               <a:t>The Two-Pair Structure of AI Progress</a:t>
             </a:r>
@@ -3811,40 +4194,82 @@
         </p:nvSpPr>
         <p:spPr/>
         <p:txBody>
-          <a:bodyPr/>
-          <a:lstStyle/>
-          <a:p>
-            <a:pPr/>
+          <a:bodyPr wrap="square"/>
+          <a:lstStyle/>
+          <a:p>
+            <a:pPr>
+              <a:defRPr sz="2800">
+                <a:solidFill>
+                  <a:srgbClr val="F0F0F0"/>
+                </a:solidFill>
+                <a:latin typeface="Arial"/>
+              </a:defRPr>
+            </a:pPr>
             <a:r>
               <a:t>Pair 1: The Formal Foundation</a:t>
             </a:r>
           </a:p>
           <a:p>
-            <a:pPr lvl="1"/>
+            <a:pPr lvl="1">
+              <a:defRPr sz="2400">
+                <a:solidFill>
+                  <a:srgbClr val="F0F0F0"/>
+                </a:solidFill>
+                <a:latin typeface="Arial"/>
+              </a:defRPr>
+            </a:pPr>
             <a:r>
               <a:t>Paper 1 (Computability): Intelligence as an open-ended limiting process at the outer boundary of what can be mechanized</a:t>
             </a:r>
           </a:p>
           <a:p>
-            <a:pPr lvl="1"/>
+            <a:pPr lvl="1">
+              <a:defRPr sz="2400">
+                <a:solidFill>
+                  <a:srgbClr val="F0F0F0"/>
+                </a:solidFill>
+                <a:latin typeface="Arial"/>
+              </a:defRPr>
+            </a:pPr>
             <a:r>
               <a:t>Paper 2 (Complexity): Intelligence as a staged bounded ascent at the inner boundary of polynomial-time reachability</a:t>
             </a:r>
           </a:p>
           <a:p>
-            <a:pPr/>
+            <a:pPr>
+              <a:defRPr sz="2800">
+                <a:solidFill>
+                  <a:srgbClr val="F0F0F0"/>
+                </a:solidFill>
+                <a:latin typeface="Arial"/>
+              </a:defRPr>
+            </a:pPr>
             <a:r>
               <a:t>Pair 2: The Empirical and Architectural Bridge</a:t>
             </a:r>
           </a:p>
           <a:p>
-            <a:pPr lvl="1"/>
+            <a:pPr lvl="1">
+              <a:defRPr sz="2400">
+                <a:solidFill>
+                  <a:srgbClr val="F0F0F0"/>
+                </a:solidFill>
+                <a:latin typeface="Arial"/>
+              </a:defRPr>
+            </a:pPr>
             <a:r>
               <a:t>Paper 3 (Scaling Laws): How abstract scaling drives progress and enforces a race for hidden efficiency</a:t>
             </a:r>
           </a:p>
           <a:p>
-            <a:pPr lvl="1"/>
+            <a:pPr lvl="1">
+              <a:defRPr sz="2400">
+                <a:solidFill>
+                  <a:srgbClr val="F0F0F0"/>
+                </a:solidFill>
+                <a:latin typeface="Arial"/>
+              </a:defRPr>
+            </a:pPr>
             <a:r>
               <a:t>Paper 4 (Modernized Amdahl): How the pressure of scaling reshapes the hardware allocation between specialized and programmable compute</a:t>
             </a:r>
@@ -3862,6 +4287,14 @@
 <file path=ppt/slides/slide4.xml><?xml version="1.0" encoding="utf-8"?>
 <p:sld xmlns:a="http://schemas.openxmlformats.org/drawingml/2006/main" xmlns:p="http://schemas.openxmlformats.org/presentationml/2006/main" xmlns:r="http://schemas.openxmlformats.org/officeDocument/2006/relationships">
   <p:cSld>
+    <p:bg>
+      <p:bgPr>
+        <a:solidFill>
+          <a:srgbClr val="141E30"/>
+        </a:solidFill>
+        <a:effectLst/>
+      </p:bgPr>
+    </p:bg>
     <p:spTree>
       <p:nvGrpSpPr>
         <p:cNvPr id="1" name=""/>
@@ -3884,6 +4317,14 @@
           <a:bodyPr/>
           <a:lstStyle/>
           <a:p>
+            <a:pPr>
+              <a:defRPr b="1" sz="4000">
+                <a:solidFill>
+                  <a:srgbClr val="FFD700"/>
+                </a:solidFill>
+                <a:latin typeface="Arial"/>
+              </a:defRPr>
+            </a:pPr>
             <a:r>
               <a:t>Paper 1: The Computability Boundary</a:t>
             </a:r>
@@ -3902,22 +4343,43 @@
         </p:nvSpPr>
         <p:spPr/>
         <p:txBody>
-          <a:bodyPr/>
-          <a:lstStyle/>
-          <a:p>
-            <a:pPr/>
+          <a:bodyPr wrap="square"/>
+          <a:lstStyle/>
+          <a:p>
+            <a:pPr>
+              <a:defRPr sz="2800">
+                <a:solidFill>
+                  <a:srgbClr val="F0F0F0"/>
+                </a:solidFill>
+                <a:latin typeface="Arial"/>
+              </a:defRPr>
+            </a:pPr>
             <a:r>
               <a:t>Beyond a Fixed Closure: Intelligence is not one finitely specifiable, fixed rule-governed procedure</a:t>
             </a:r>
           </a:p>
           <a:p>
-            <a:pPr/>
+            <a:pPr>
+              <a:defRPr sz="2800">
+                <a:solidFill>
+                  <a:srgbClr val="F0F0F0"/>
+                </a:solidFill>
+                <a:latin typeface="Arial"/>
+              </a:defRPr>
+            </a:pPr>
             <a:r>
               <a:t>The Limiting-Process Structure: When a process is mechanized, the higher-order task of guiding, specifying, and evaluating that mechanization is displaced upward to a new level</a:t>
             </a:r>
           </a:p>
           <a:p>
-            <a:pPr/>
+            <a:pPr>
+              <a:defRPr sz="2800">
+                <a:solidFill>
+                  <a:srgbClr val="F0F0F0"/>
+                </a:solidFill>
+                <a:latin typeface="Arial"/>
+              </a:defRPr>
+            </a:pPr>
             <a:r>
               <a:t>Local Mechanization vs. Open Boundary: Every established, mechanized computational layer possesses a canonical, relatively uncomputable open boundary</a:t>
             </a:r>
@@ -3935,6 +4397,14 @@
 <file path=ppt/slides/slide5.xml><?xml version="1.0" encoding="utf-8"?>
 <p:sld xmlns:a="http://schemas.openxmlformats.org/drawingml/2006/main" xmlns:p="http://schemas.openxmlformats.org/presentationml/2006/main" xmlns:r="http://schemas.openxmlformats.org/officeDocument/2006/relationships">
   <p:cSld>
+    <p:bg>
+      <p:bgPr>
+        <a:solidFill>
+          <a:srgbClr val="141E30"/>
+        </a:solidFill>
+        <a:effectLst/>
+      </p:bgPr>
+    </p:bg>
     <p:spTree>
       <p:nvGrpSpPr>
         <p:cNvPr id="1" name=""/>
@@ -3957,6 +4427,14 @@
           <a:bodyPr/>
           <a:lstStyle/>
           <a:p>
+            <a:pPr>
+              <a:defRPr b="1" sz="4000">
+                <a:solidFill>
+                  <a:srgbClr val="FFD700"/>
+                </a:solidFill>
+                <a:latin typeface="Arial"/>
+              </a:defRPr>
+            </a:pPr>
             <a:r>
               <a:t>Paper 1: The Mechanics of Ascent</a:t>
             </a:r>
@@ -3975,28 +4453,56 @@
         </p:nvSpPr>
         <p:spPr/>
         <p:txBody>
-          <a:bodyPr/>
-          <a:lstStyle/>
-          <a:p>
-            <a:pPr lvl="1"/>
+          <a:bodyPr wrap="square"/>
+          <a:lstStyle/>
+          <a:p>
+            <a:pPr lvl="1">
+              <a:defRPr i="1" sz="2000">
+                <a:solidFill>
+                  <a:srgbClr val="6496FF"/>
+                </a:solidFill>
+                <a:latin typeface="Arial"/>
+              </a:defRPr>
+            </a:pPr>
             <a:r>
               <a:t>[Visual Concept: A blueprint-style diagram showing a foundational layer A_n, ascending through an intermediate step, toward an open ceiling A'_n]</a:t>
             </a:r>
           </a:p>
           <a:p>
-            <a:pPr/>
+            <a:pPr>
+              <a:defRPr sz="2800">
+                <a:solidFill>
+                  <a:srgbClr val="F0F0F0"/>
+                </a:solidFill>
+                <a:latin typeface="Arial"/>
+              </a:defRPr>
+            </a:pPr>
             <a:r>
               <a:t>The Turing Jump as a Ceiling: The absolute boundary of any mechanized layer is its Turing jump (A')</a:t>
             </a:r>
           </a:p>
           <a:p>
-            <a:pPr/>
+            <a:pPr>
+              <a:defRPr sz="2800">
+                <a:solidFill>
+                  <a:srgbClr val="F0F0F0"/>
+                </a:solidFill>
+                <a:latin typeface="Arial"/>
+              </a:defRPr>
+            </a:pPr>
             <a:r>
               <a:t>Progressive Layers: Real progress occurs through intermediate strengthenings (A &lt;_T B &lt;_T A'), mechanizing steps strictly below the absolute jump</a:t>
             </a:r>
           </a:p>
           <a:p>
-            <a:pPr/>
+            <a:pPr>
+              <a:defRPr sz="2800">
+                <a:solidFill>
+                  <a:srgbClr val="F0F0F0"/>
+                </a:solidFill>
+                <a:latin typeface="Arial"/>
+              </a:defRPr>
+            </a:pPr>
             <a:r>
               <a:t>Non-Capture: No single settled layer captures the entire open-ended process of intelligence</a:t>
             </a:r>
@@ -4014,6 +4520,14 @@
 <file path=ppt/slides/slide6.xml><?xml version="1.0" encoding="utf-8"?>
 <p:sld xmlns:a="http://schemas.openxmlformats.org/drawingml/2006/main" xmlns:p="http://schemas.openxmlformats.org/presentationml/2006/main" xmlns:r="http://schemas.openxmlformats.org/officeDocument/2006/relationships">
   <p:cSld>
+    <p:bg>
+      <p:bgPr>
+        <a:solidFill>
+          <a:srgbClr val="141E30"/>
+        </a:solidFill>
+        <a:effectLst/>
+      </p:bgPr>
+    </p:bg>
     <p:spTree>
       <p:nvGrpSpPr>
         <p:cNvPr id="1" name=""/>
@@ -4036,6 +4550,14 @@
           <a:bodyPr/>
           <a:lstStyle/>
           <a:p>
+            <a:pPr>
+              <a:defRPr b="1" sz="4000">
+                <a:solidFill>
+                  <a:srgbClr val="FFD700"/>
+                </a:solidFill>
+                <a:latin typeface="Arial"/>
+              </a:defRPr>
+            </a:pPr>
             <a:r>
               <a:t>Paper 2: The Feasibility Boundary</a:t>
             </a:r>
@@ -4054,22 +4576,43 @@
         </p:nvSpPr>
         <p:spPr/>
         <p:txBody>
-          <a:bodyPr/>
-          <a:lstStyle/>
-          <a:p>
-            <a:pPr/>
+          <a:bodyPr wrap="square"/>
+          <a:lstStyle/>
+          <a:p>
+            <a:pPr>
+              <a:defRPr sz="2800">
+                <a:solidFill>
+                  <a:srgbClr val="F0F0F0"/>
+                </a:solidFill>
+                <a:latin typeface="Arial"/>
+              </a:defRPr>
+            </a:pPr>
             <a:r>
               <a:t>Redefining Feasibility: The practical reach of intelligence is not a binary “P = NP or nothing” scenario</a:t>
             </a:r>
           </a:p>
           <a:p>
-            <a:pPr/>
+            <a:pPr>
+              <a:defRPr sz="2800">
+                <a:solidFill>
+                  <a:srgbClr val="F0F0F0"/>
+                </a:solidFill>
+                <a:latin typeface="Arial"/>
+              </a:defRPr>
+            </a:pPr>
             <a:r>
               <a:t>Expanding Reachability: Progress manifests as progressively wider polynomial-time reach across difficult search tasks</a:t>
             </a:r>
           </a:p>
           <a:p>
-            <a:pPr/>
+            <a:pPr>
+              <a:defRPr sz="2800">
+                <a:solidFill>
+                  <a:srgbClr val="F0F0F0"/>
+                </a:solidFill>
+                <a:latin typeface="Arial"/>
+              </a:defRPr>
+            </a:pPr>
             <a:r>
               <a:t>Staged Bounded Ascent: Moving upward by internalizing richer structures of guided search while remaining feasible under strict polynomial-time constraints</a:t>
             </a:r>
@@ -4087,6 +4630,14 @@
 <file path=ppt/slides/slide7.xml><?xml version="1.0" encoding="utf-8"?>
 <p:sld xmlns:a="http://schemas.openxmlformats.org/drawingml/2006/main" xmlns:p="http://schemas.openxmlformats.org/presentationml/2006/main" xmlns:r="http://schemas.openxmlformats.org/officeDocument/2006/relationships">
   <p:cSld>
+    <p:bg>
+      <p:bgPr>
+        <a:solidFill>
+          <a:srgbClr val="141E30"/>
+        </a:solidFill>
+        <a:effectLst/>
+      </p:bgPr>
+    </p:bg>
     <p:spTree>
       <p:nvGrpSpPr>
         <p:cNvPr id="1" name=""/>
@@ -4109,6 +4660,14 @@
           <a:bodyPr/>
           <a:lstStyle/>
           <a:p>
+            <a:pPr>
+              <a:defRPr b="1" sz="4000">
+                <a:solidFill>
+                  <a:srgbClr val="FFD700"/>
+                </a:solidFill>
+                <a:latin typeface="Arial"/>
+              </a:defRPr>
+            </a:pPr>
             <a:r>
               <a:t>Paper 2: The Polynomial Hierarchy as Limiting Process</a:t>
             </a:r>
@@ -4127,22 +4686,43 @@
         </p:nvSpPr>
         <p:spPr/>
         <p:txBody>
-          <a:bodyPr/>
-          <a:lstStyle/>
-          <a:p>
-            <a:pPr lvl="1"/>
+          <a:bodyPr wrap="square"/>
+          <a:lstStyle/>
+          <a:p>
+            <a:pPr lvl="1">
+              <a:defRPr i="1" sz="2000">
+                <a:solidFill>
+                  <a:srgbClr val="6496FF"/>
+                </a:solidFill>
+                <a:latin typeface="Arial"/>
+              </a:defRPr>
+            </a:pPr>
             <a:r>
               <a:t>[Visual Concept: A finite-depth ladder expanding upward, showing P→NP→PH]</a:t>
             </a:r>
           </a:p>
           <a:p>
-            <a:pPr/>
+            <a:pPr>
+              <a:defRPr sz="2800">
+                <a:solidFill>
+                  <a:srgbClr val="F0F0F0"/>
+                </a:solidFill>
+                <a:latin typeface="Arial"/>
+              </a:defRPr>
+            </a:pPr>
             <a:r>
               <a:t>Bounded Verification Games: The Polynomial Hierarchy provides a finite-depth ladder of structured proposal, challenge, and repair</a:t>
             </a:r>
           </a:p>
           <a:p>
-            <a:pPr/>
+            <a:pPr>
+              <a:defRPr sz="2800">
+                <a:solidFill>
+                  <a:srgbClr val="F0F0F0"/>
+                </a:solidFill>
+                <a:latin typeface="Arial"/>
+              </a:defRPr>
+            </a:pPr>
             <a:r>
               <a:t>Internalizing Search: Moving up the hierarchy allows a system to absorb what was previously external search into a stronger—but still explicitly bounded—verification framework</a:t>
             </a:r>
@@ -4160,6 +4740,14 @@
 <file path=ppt/slides/slide8.xml><?xml version="1.0" encoding="utf-8"?>
 <p:sld xmlns:a="http://schemas.openxmlformats.org/drawingml/2006/main" xmlns:p="http://schemas.openxmlformats.org/presentationml/2006/main" xmlns:r="http://schemas.openxmlformats.org/officeDocument/2006/relationships">
   <p:cSld>
+    <p:bg>
+      <p:bgPr>
+        <a:solidFill>
+          <a:srgbClr val="141E30"/>
+        </a:solidFill>
+        <a:effectLst/>
+      </p:bgPr>
+    </p:bg>
     <p:spTree>
       <p:nvGrpSpPr>
         <p:cNvPr id="1" name=""/>
@@ -4182,6 +4770,14 @@
           <a:bodyPr/>
           <a:lstStyle/>
           <a:p>
+            <a:pPr>
+              <a:defRPr b="1" sz="4000">
+                <a:solidFill>
+                  <a:srgbClr val="FFD700"/>
+                </a:solidFill>
+                <a:latin typeface="Arial"/>
+              </a:defRPr>
+            </a:pPr>
             <a:r>
               <a:t>Synthesis of Pair 1: The Map of Formal Boundaries</a:t>
             </a:r>
@@ -4200,22 +4796,43 @@
         </p:nvSpPr>
         <p:spPr/>
         <p:txBody>
-          <a:bodyPr/>
-          <a:lstStyle/>
-          <a:p>
-            <a:pPr lvl="1"/>
+          <a:bodyPr wrap="square"/>
+          <a:lstStyle/>
+          <a:p>
+            <a:pPr lvl="1">
+              <a:defRPr i="1" sz="2000">
+                <a:solidFill>
+                  <a:srgbClr val="6496FF"/>
+                </a:solidFill>
+                <a:latin typeface="Arial"/>
+              </a:defRPr>
+            </a:pPr>
             <a:r>
               <a:t>[Visual Concept: A nested boundary map showing Well-defined tasks → Computable tasks → Polynomial-time tasks]</a:t>
             </a:r>
           </a:p>
           <a:p>
-            <a:pPr/>
+            <a:pPr>
+              <a:defRPr sz="2800">
+                <a:solidFill>
+                  <a:srgbClr val="F0F0F0"/>
+                </a:solidFill>
+                <a:latin typeface="Arial"/>
+              </a:defRPr>
+            </a:pPr>
             <a:r>
               <a:t>The Outer Boundary (Computability): The divide between computable tasks and uncomputable, open-ended well-defined tasks</a:t>
             </a:r>
           </a:p>
           <a:p>
-            <a:pPr/>
+            <a:pPr>
+              <a:defRPr sz="2800">
+                <a:solidFill>
+                  <a:srgbClr val="F0F0F0"/>
+                </a:solidFill>
+                <a:latin typeface="Arial"/>
+              </a:defRPr>
+            </a:pPr>
             <a:r>
               <a:t>The Inner Boundary (Feasibility): The divide between what is merely computable in principle and what is polynomial-time reachable in practice</a:t>
             </a:r>
@@ -4233,6 +4850,14 @@
 <file path=ppt/slides/slide9.xml><?xml version="1.0" encoding="utf-8"?>
 <p:sld xmlns:a="http://schemas.openxmlformats.org/drawingml/2006/main" xmlns:p="http://schemas.openxmlformats.org/presentationml/2006/main" xmlns:r="http://schemas.openxmlformats.org/officeDocument/2006/relationships">
   <p:cSld>
+    <p:bg>
+      <p:bgPr>
+        <a:solidFill>
+          <a:srgbClr val="141E30"/>
+        </a:solidFill>
+        <a:effectLst/>
+      </p:bgPr>
+    </p:bg>
     <p:spTree>
       <p:nvGrpSpPr>
         <p:cNvPr id="1" name=""/>
@@ -4255,6 +4880,14 @@
           <a:bodyPr/>
           <a:lstStyle/>
           <a:p>
+            <a:pPr>
+              <a:defRPr b="1" sz="4000">
+                <a:solidFill>
+                  <a:srgbClr val="FFD700"/>
+                </a:solidFill>
+                <a:latin typeface="Arial"/>
+              </a:defRPr>
+            </a:pPr>
             <a:r>
               <a:t>The Empirical Gap: Why Pair 1 is Not Enough</a:t>
             </a:r>
@@ -4273,22 +4906,43 @@
         </p:nvSpPr>
         <p:spPr/>
         <p:txBody>
-          <a:bodyPr/>
-          <a:lstStyle/>
-          <a:p>
-            <a:pPr/>
+          <a:bodyPr wrap="square"/>
+          <a:lstStyle/>
+          <a:p>
+            <a:pPr>
+              <a:defRPr sz="2800">
+                <a:solidFill>
+                  <a:srgbClr val="F0F0F0"/>
+                </a:solidFill>
+                <a:latin typeface="Arial"/>
+              </a:defRPr>
+            </a:pPr>
             <a:r>
               <a:t>The Transition: Pair 1 provides the formal structure, explaining exactly what progress means mathematically</a:t>
             </a:r>
           </a:p>
           <a:p>
-            <a:pPr/>
+            <a:pPr>
+              <a:defRPr sz="2800">
+                <a:solidFill>
+                  <a:srgbClr val="F0F0F0"/>
+                </a:solidFill>
+                <a:latin typeface="Arial"/>
+              </a:defRPr>
+            </a:pPr>
             <a:r>
               <a:t>The Missing Engine: Formal limits alone do not explain why progress continually appears in real-world systems</a:t>
             </a:r>
           </a:p>
           <a:p>
-            <a:pPr/>
+            <a:pPr>
+              <a:defRPr sz="2800">
+                <a:solidFill>
+                  <a:srgbClr val="F0F0F0"/>
+                </a:solidFill>
+                <a:latin typeface="Arial"/>
+              </a:defRPr>
+            </a:pPr>
             <a:r>
               <a:t>We must bridge the gap between formal structure and empirical hardware realities</a:t>
             </a:r>

</xml_diff>

<commit_message>
Refactor generation script to use custom absolute bounds
</commit_message>
<xml_diff>
--- a/The_AI_Progress_Blueprint.pptx
+++ b/The_AI_Progress_Blueprint.pptx
@@ -22,7 +22,7 @@
     <p:sldId id="270" r:id="rId21"/>
     <p:sldId id="271" r:id="rId22"/>
   </p:sldIdLst>
-  <p:sldSz cx="12191695" cy="6858000" type="screen4x3"/>
+  <p:sldSz cx="12188952" cy="6858000" type="screen4x3"/>
   <p:notesSz cx="6858000" cy="9144000"/>
   <p:defaultTextStyle>
     <a:defPPr>
@@ -3099,7 +3099,7 @@
     <p:bg>
       <p:bgPr>
         <a:solidFill>
-          <a:srgbClr val="141E30"/>
+          <a:srgbClr val="0A1929"/>
         </a:solidFill>
         <a:effectLst/>
       </p:bgPr>
@@ -3113,23 +3113,30 @@
       <p:grpSpPr/>
       <p:sp>
         <p:nvSpPr>
-          <p:cNvPr id="2" name="Title 1"/>
-          <p:cNvSpPr>
-            <a:spLocks noGrp="1"/>
-          </p:cNvSpPr>
-          <p:nvPr>
-            <p:ph type="title"/>
-          </p:nvPr>
-        </p:nvSpPr>
-        <p:spPr/>
-        <p:txBody>
-          <a:bodyPr/>
-          <a:lstStyle/>
-          <a:p>
-            <a:pPr>
-              <a:defRPr b="1" sz="4000">
-                <a:solidFill>
-                  <a:srgbClr val="FFD700"/>
+          <p:cNvPr id="2" name="TextBox 1"/>
+          <p:cNvSpPr txBox="1"/>
+          <p:nvPr/>
+        </p:nvSpPr>
+        <p:spPr>
+          <a:xfrm>
+            <a:off x="914400" y="1828800"/>
+            <a:ext cx="10360152" cy="1371600"/>
+          </a:xfrm>
+          <a:prstGeom prst="rect">
+            <a:avLst/>
+          </a:prstGeom>
+          <a:noFill/>
+        </p:spPr>
+        <p:txBody>
+          <a:bodyPr wrap="square">
+            <a:spAutoFit/>
+          </a:bodyPr>
+          <a:lstStyle/>
+          <a:p>
+            <a:pPr algn="ctr">
+              <a:defRPr sz="5400" b="1">
+                <a:solidFill>
+                  <a:srgbClr val="00FFFF"/>
                 </a:solidFill>
                 <a:latin typeface="Arial"/>
               </a:defRPr>
@@ -3142,21 +3149,28 @@
       </p:sp>
       <p:sp>
         <p:nvSpPr>
-          <p:cNvPr id="3" name="Content Placeholder 2"/>
-          <p:cNvSpPr>
-            <a:spLocks noGrp="1"/>
-          </p:cNvSpPr>
-          <p:nvPr>
-            <p:ph idx="1"/>
-          </p:nvPr>
-        </p:nvSpPr>
-        <p:spPr/>
-        <p:txBody>
-          <a:bodyPr wrap="square"/>
-          <a:lstStyle/>
-          <a:p>
-            <a:pPr>
-              <a:defRPr sz="2800">
+          <p:cNvPr id="3" name="TextBox 2"/>
+          <p:cNvSpPr txBox="1"/>
+          <p:nvPr/>
+        </p:nvSpPr>
+        <p:spPr>
+          <a:xfrm>
+            <a:off x="914400" y="3657600"/>
+            <a:ext cx="10360152" cy="914400"/>
+          </a:xfrm>
+          <a:prstGeom prst="rect">
+            <a:avLst/>
+          </a:prstGeom>
+          <a:noFill/>
+        </p:spPr>
+        <p:txBody>
+          <a:bodyPr wrap="square">
+            <a:spAutoFit/>
+          </a:bodyPr>
+          <a:lstStyle/>
+          <a:p>
+            <a:pPr algn="ctr">
+              <a:defRPr sz="2400" b="0">
                 <a:solidFill>
                   <a:srgbClr val="F0F0F0"/>
                 </a:solidFill>
@@ -3165,58 +3179,6 @@
             </a:pPr>
             <a:r>
               <a:t>Synthesizing the Formal Foundations and Empirical Drivers of Artificial Intelligence</a:t>
-            </a:r>
-          </a:p>
-          <a:p>
-            <a:pPr>
-              <a:defRPr sz="2800">
-                <a:solidFill>
-                  <a:srgbClr val="F0F0F0"/>
-                </a:solidFill>
-                <a:latin typeface="Arial"/>
-              </a:defRPr>
-            </a:pPr>
-            <a:r>
-              <a:t>A Unified Theoretical Framework: Presenting a cohesive research program that bridges theoretical limits and engineering realities</a:t>
-            </a:r>
-          </a:p>
-          <a:p>
-            <a:pPr>
-              <a:defRPr sz="2800">
-                <a:solidFill>
-                  <a:srgbClr val="F0F0F0"/>
-                </a:solidFill>
-                <a:latin typeface="Arial"/>
-              </a:defRPr>
-            </a:pPr>
-            <a:r>
-              <a:t>Two Connected Pairs:</a:t>
-            </a:r>
-          </a:p>
-          <a:p>
-            <a:pPr lvl="1">
-              <a:defRPr sz="2400">
-                <a:solidFill>
-                  <a:srgbClr val="F0F0F0"/>
-                </a:solidFill>
-                <a:latin typeface="Arial"/>
-              </a:defRPr>
-            </a:pPr>
-            <a:r>
-              <a:t>Pair 1 (The Formal Foundation): Intelligence defined by its outer boundary of computability and inner boundary of polynomial-time feasibility</a:t>
-            </a:r>
-          </a:p>
-          <a:p>
-            <a:pPr lvl="1">
-              <a:defRPr sz="2400">
-                <a:solidFill>
-                  <a:srgbClr val="F0F0F0"/>
-                </a:solidFill>
-                <a:latin typeface="Arial"/>
-              </a:defRPr>
-            </a:pPr>
-            <a:r>
-              <a:t>Pair 2 (The Practical Bridge): The empirical driver of scaling laws and the architectural consequences of hardware allocation</a:t>
             </a:r>
           </a:p>
         </p:txBody>
@@ -3235,7 +3197,7 @@
     <p:bg>
       <p:bgPr>
         <a:solidFill>
-          <a:srgbClr val="141E30"/>
+          <a:srgbClr val="0A1929"/>
         </a:solidFill>
         <a:effectLst/>
       </p:bgPr>
@@ -3249,23 +3211,30 @@
       <p:grpSpPr/>
       <p:sp>
         <p:nvSpPr>
-          <p:cNvPr id="2" name="Title 1"/>
-          <p:cNvSpPr>
-            <a:spLocks noGrp="1"/>
-          </p:cNvSpPr>
-          <p:nvPr>
-            <p:ph type="title"/>
-          </p:nvPr>
-        </p:nvSpPr>
-        <p:spPr/>
-        <p:txBody>
-          <a:bodyPr/>
-          <a:lstStyle/>
-          <a:p>
-            <a:pPr>
-              <a:defRPr b="1" sz="4000">
-                <a:solidFill>
-                  <a:srgbClr val="FFD700"/>
+          <p:cNvPr id="2" name="TextBox 1"/>
+          <p:cNvSpPr txBox="1"/>
+          <p:nvPr/>
+        </p:nvSpPr>
+        <p:spPr>
+          <a:xfrm>
+            <a:off x="731520" y="457200"/>
+            <a:ext cx="10725912" cy="914400"/>
+          </a:xfrm>
+          <a:prstGeom prst="rect">
+            <a:avLst/>
+          </a:prstGeom>
+          <a:noFill/>
+        </p:spPr>
+        <p:txBody>
+          <a:bodyPr wrap="square">
+            <a:spAutoFit/>
+          </a:bodyPr>
+          <a:lstStyle/>
+          <a:p>
+            <a:pPr algn="l">
+              <a:defRPr sz="3600" b="1">
+                <a:solidFill>
+                  <a:srgbClr val="00FFFF"/>
                 </a:solidFill>
                 <a:latin typeface="Arial"/>
               </a:defRPr>
@@ -3278,21 +3247,28 @@
       </p:sp>
       <p:sp>
         <p:nvSpPr>
-          <p:cNvPr id="3" name="Content Placeholder 2"/>
-          <p:cNvSpPr>
-            <a:spLocks noGrp="1"/>
-          </p:cNvSpPr>
-          <p:nvPr>
-            <p:ph idx="1"/>
-          </p:nvPr>
-        </p:nvSpPr>
-        <p:spPr/>
-        <p:txBody>
-          <a:bodyPr wrap="square"/>
-          <a:lstStyle/>
-          <a:p>
-            <a:pPr>
-              <a:defRPr sz="2800">
+          <p:cNvPr id="3" name="TextBox 2"/>
+          <p:cNvSpPr txBox="1"/>
+          <p:nvPr/>
+        </p:nvSpPr>
+        <p:spPr>
+          <a:xfrm>
+            <a:off x="1097280" y="1645920"/>
+            <a:ext cx="10177272" cy="1005840"/>
+          </a:xfrm>
+          <a:prstGeom prst="rect">
+            <a:avLst/>
+          </a:prstGeom>
+          <a:noFill/>
+        </p:spPr>
+        <p:txBody>
+          <a:bodyPr wrap="square">
+            <a:spAutoFit/>
+          </a:bodyPr>
+          <a:lstStyle/>
+          <a:p>
+            <a:pPr algn="l">
+              <a:defRPr sz="2400" b="0">
                 <a:solidFill>
                   <a:srgbClr val="F0F0F0"/>
                 </a:solidFill>
@@ -3300,12 +3276,35 @@
               </a:defRPr>
             </a:pPr>
             <a:r>
-              <a:t>The Power of Abstraction: Scaling laws are unreasonably effective precisely because they abstract over realization details</a:t>
-            </a:r>
-          </a:p>
-          <a:p>
-            <a:pPr>
-              <a:defRPr sz="2800">
+              <a:t>• The Power of Abstraction: Scaling laws are unreasonably effective precisely because they abstract over realization details</a:t>
+            </a:r>
+          </a:p>
+        </p:txBody>
+      </p:sp>
+      <p:sp>
+        <p:nvSpPr>
+          <p:cNvPr id="4" name="TextBox 3"/>
+          <p:cNvSpPr txBox="1"/>
+          <p:nvPr/>
+        </p:nvSpPr>
+        <p:spPr>
+          <a:xfrm>
+            <a:off x="1097280" y="2743200"/>
+            <a:ext cx="10177272" cy="1417320"/>
+          </a:xfrm>
+          <a:prstGeom prst="rect">
+            <a:avLst/>
+          </a:prstGeom>
+          <a:noFill/>
+        </p:spPr>
+        <p:txBody>
+          <a:bodyPr wrap="square">
+            <a:spAutoFit/>
+          </a:bodyPr>
+          <a:lstStyle/>
+          <a:p>
+            <a:pPr algn="l">
+              <a:defRPr sz="2400" b="0">
                 <a:solidFill>
                   <a:srgbClr val="F0F0F0"/>
                 </a:solidFill>
@@ -3313,12 +3312,35 @@
               </a:defRPr>
             </a:pPr>
             <a:r>
-              <a:t>Logical vs. Physical Compute: The "compute" variable actually represents logical compute (abstract model-side work), independent of the efficiency of the physical hardware</a:t>
-            </a:r>
-          </a:p>
-          <a:p>
-            <a:pPr>
-              <a:defRPr sz="2800">
+              <a:t>• Logical vs. Physical Compute: The "compute" variable actually represents logical compute (abstract model-side work), independent of the efficiency of the physical hardware</a:t>
+            </a:r>
+          </a:p>
+        </p:txBody>
+      </p:sp>
+      <p:sp>
+        <p:nvSpPr>
+          <p:cNvPr id="5" name="TextBox 4"/>
+          <p:cNvSpPr txBox="1"/>
+          <p:nvPr/>
+        </p:nvSpPr>
+        <p:spPr>
+          <a:xfrm>
+            <a:off x="1097280" y="4251960"/>
+            <a:ext cx="10177272" cy="1417320"/>
+          </a:xfrm>
+          <a:prstGeom prst="rect">
+            <a:avLst/>
+          </a:prstGeom>
+          <a:noFill/>
+        </p:spPr>
+        <p:txBody>
+          <a:bodyPr wrap="square">
+            <a:spAutoFit/>
+          </a:bodyPr>
+          <a:lstStyle/>
+          <a:p>
+            <a:pPr algn="l">
+              <a:defRPr sz="2400" b="0">
                 <a:solidFill>
                   <a:srgbClr val="F0F0F0"/>
                 </a:solidFill>
@@ -3326,7 +3348,7 @@
               </a:defRPr>
             </a:pPr>
             <a:r>
-              <a:t>The Real Meaning of Diminishing Returns: A flattening scaling curve does not just mean slower progress; it represents a rapidly escalating physical and operational burden to achieve the next step of value</a:t>
+              <a:t>• The Real Meaning of Diminishing Returns: A flattening scaling curve does not just mean slower progress; it represents a rapidly escalating physical and operational burden to achieve the next step of value</a:t>
             </a:r>
           </a:p>
         </p:txBody>
@@ -3345,7 +3367,7 @@
     <p:bg>
       <p:bgPr>
         <a:solidFill>
-          <a:srgbClr val="141E30"/>
+          <a:srgbClr val="0A1929"/>
         </a:solidFill>
         <a:effectLst/>
       </p:bgPr>
@@ -3359,21 +3381,64 @@
       <p:grpSpPr/>
       <p:sp>
         <p:nvSpPr>
-          <p:cNvPr id="2" name="Title 1"/>
-          <p:cNvSpPr>
-            <a:spLocks noGrp="1"/>
-          </p:cNvSpPr>
-          <p:nvPr>
-            <p:ph type="title"/>
-          </p:nvPr>
-        </p:nvSpPr>
-        <p:spPr/>
-        <p:txBody>
-          <a:bodyPr/>
-          <a:lstStyle/>
-          <a:p>
-            <a:pPr>
-              <a:defRPr b="1" sz="4000">
+          <p:cNvPr id="2" name="TextBox 1"/>
+          <p:cNvSpPr txBox="1"/>
+          <p:nvPr/>
+        </p:nvSpPr>
+        <p:spPr>
+          <a:xfrm>
+            <a:off x="731520" y="457200"/>
+            <a:ext cx="10725912" cy="914400"/>
+          </a:xfrm>
+          <a:prstGeom prst="rect">
+            <a:avLst/>
+          </a:prstGeom>
+          <a:noFill/>
+        </p:spPr>
+        <p:txBody>
+          <a:bodyPr wrap="square">
+            <a:spAutoFit/>
+          </a:bodyPr>
+          <a:lstStyle/>
+          <a:p>
+            <a:pPr algn="l">
+              <a:defRPr sz="3600" b="1">
+                <a:solidFill>
+                  <a:srgbClr val="00FFFF"/>
+                </a:solidFill>
+                <a:latin typeface="Arial"/>
+              </a:defRPr>
+            </a:pPr>
+            <a:r>
+              <a:t>Paper 3: The Dynamic Implication of Hidden Efficiency</a:t>
+            </a:r>
+          </a:p>
+        </p:txBody>
+      </p:sp>
+      <p:sp>
+        <p:nvSpPr>
+          <p:cNvPr id="3" name="TextBox 2"/>
+          <p:cNvSpPr txBox="1"/>
+          <p:nvPr/>
+        </p:nvSpPr>
+        <p:spPr>
+          <a:xfrm>
+            <a:off x="914400" y="1645920"/>
+            <a:ext cx="10360152" cy="914400"/>
+          </a:xfrm>
+          <a:prstGeom prst="rect">
+            <a:avLst/>
+          </a:prstGeom>
+          <a:noFill/>
+        </p:spPr>
+        <p:txBody>
+          <a:bodyPr wrap="square">
+            <a:spAutoFit/>
+          </a:bodyPr>
+          <a:lstStyle/>
+          <a:p>
+            <a:pPr algn="l">
+              <a:defRPr sz="2000" b="1">
                 <a:solidFill>
                   <a:srgbClr val="FFD700"/>
                 </a:solidFill>
@@ -3381,41 +3446,35 @@
               </a:defRPr>
             </a:pPr>
             <a:r>
-              <a:t>Paper 3: The Dynamic Implication of Hidden Efficiency</a:t>
-            </a:r>
-          </a:p>
-        </p:txBody>
-      </p:sp>
-      <p:sp>
-        <p:nvSpPr>
-          <p:cNvPr id="3" name="Content Placeholder 2"/>
-          <p:cNvSpPr>
-            <a:spLocks noGrp="1"/>
-          </p:cNvSpPr>
-          <p:nvPr>
-            <p:ph idx="1"/>
-          </p:nvPr>
-        </p:nvSpPr>
-        <p:spPr/>
-        <p:txBody>
-          <a:bodyPr wrap="square"/>
-          <a:lstStyle/>
-          <a:p>
-            <a:pPr lvl="1">
-              <a:defRPr i="1" sz="2000">
-                <a:solidFill>
-                  <a:srgbClr val="6496FF"/>
-                </a:solidFill>
-                <a:latin typeface="Arial"/>
-              </a:defRPr>
-            </a:pPr>
-            <a:r>
               <a:t>[Visual Concept: A pressure-conversion loop showing logical compute demand driving efficiency optimization across the stack]</a:t>
             </a:r>
           </a:p>
-          <a:p>
-            <a:pPr>
-              <a:defRPr sz="2800">
+        </p:txBody>
+      </p:sp>
+      <p:sp>
+        <p:nvSpPr>
+          <p:cNvPr id="4" name="TextBox 3"/>
+          <p:cNvSpPr txBox="1"/>
+          <p:nvPr/>
+        </p:nvSpPr>
+        <p:spPr>
+          <a:xfrm>
+            <a:off x="1097280" y="2651760"/>
+            <a:ext cx="10177272" cy="1417320"/>
+          </a:xfrm>
+          <a:prstGeom prst="rect">
+            <a:avLst/>
+          </a:prstGeom>
+          <a:noFill/>
+        </p:spPr>
+        <p:txBody>
+          <a:bodyPr wrap="square">
+            <a:spAutoFit/>
+          </a:bodyPr>
+          <a:lstStyle/>
+          <a:p>
+            <a:pPr algn="l">
+              <a:defRPr sz="2400" b="0">
                 <a:solidFill>
                   <a:srgbClr val="F0F0F0"/>
                 </a:solidFill>
@@ -3423,12 +3482,35 @@
               </a:defRPr>
             </a:pPr>
             <a:r>
-              <a:t>The Efficiency Race: Progress persists because of repeated, compounding efficiency gains in algorithms, low-precision software, systems, and hardware</a:t>
-            </a:r>
-          </a:p>
-          <a:p>
-            <a:pPr>
-              <a:defRPr sz="2800">
+              <a:t>• The Efficiency Race: Progress persists because of repeated, compounding efficiency gains in algorithms, low-precision software, systems, and hardware</a:t>
+            </a:r>
+          </a:p>
+        </p:txBody>
+      </p:sp>
+      <p:sp>
+        <p:nvSpPr>
+          <p:cNvPr id="5" name="TextBox 4"/>
+          <p:cNvSpPr txBox="1"/>
+          <p:nvPr/>
+        </p:nvSpPr>
+        <p:spPr>
+          <a:xfrm>
+            <a:off x="1097280" y="4160520"/>
+            <a:ext cx="10177272" cy="1417320"/>
+          </a:xfrm>
+          <a:prstGeom prst="rect">
+            <a:avLst/>
+          </a:prstGeom>
+          <a:noFill/>
+        </p:spPr>
+        <p:txBody>
+          <a:bodyPr wrap="square">
+            <a:spAutoFit/>
+          </a:bodyPr>
+          <a:lstStyle/>
+          <a:p>
+            <a:pPr algn="l">
+              <a:defRPr sz="2400" b="0">
                 <a:solidFill>
                   <a:srgbClr val="F0F0F0"/>
                 </a:solidFill>
@@ -3436,7 +3518,7 @@
               </a:defRPr>
             </a:pPr>
             <a:r>
-              <a:t>Changing the Cost: The empirical scaling law dictates what logical compute buys; the compounding efficiency stack constantly changes what that compute costs</a:t>
+              <a:t>• Changing the Cost: The empirical scaling law dictates what logical compute buys; the compounding efficiency stack constantly changes what that compute costs</a:t>
             </a:r>
           </a:p>
         </p:txBody>
@@ -3455,7 +3537,7 @@
     <p:bg>
       <p:bgPr>
         <a:solidFill>
-          <a:srgbClr val="141E30"/>
+          <a:srgbClr val="0A1929"/>
         </a:solidFill>
         <a:effectLst/>
       </p:bgPr>
@@ -3469,23 +3551,30 @@
       <p:grpSpPr/>
       <p:sp>
         <p:nvSpPr>
-          <p:cNvPr id="2" name="Title 1"/>
-          <p:cNvSpPr>
-            <a:spLocks noGrp="1"/>
-          </p:cNvSpPr>
-          <p:nvPr>
-            <p:ph type="title"/>
-          </p:nvPr>
-        </p:nvSpPr>
-        <p:spPr/>
-        <p:txBody>
-          <a:bodyPr/>
-          <a:lstStyle/>
-          <a:p>
-            <a:pPr>
-              <a:defRPr b="1" sz="4000">
-                <a:solidFill>
-                  <a:srgbClr val="FFD700"/>
+          <p:cNvPr id="2" name="TextBox 1"/>
+          <p:cNvSpPr txBox="1"/>
+          <p:nvPr/>
+        </p:nvSpPr>
+        <p:spPr>
+          <a:xfrm>
+            <a:off x="731520" y="457200"/>
+            <a:ext cx="10725912" cy="914400"/>
+          </a:xfrm>
+          <a:prstGeom prst="rect">
+            <a:avLst/>
+          </a:prstGeom>
+          <a:noFill/>
+        </p:spPr>
+        <p:txBody>
+          <a:bodyPr wrap="square">
+            <a:spAutoFit/>
+          </a:bodyPr>
+          <a:lstStyle/>
+          <a:p>
+            <a:pPr algn="l">
+              <a:defRPr sz="3600" b="1">
+                <a:solidFill>
+                  <a:srgbClr val="00FFFF"/>
                 </a:solidFill>
                 <a:latin typeface="Arial"/>
               </a:defRPr>
@@ -3498,21 +3587,28 @@
       </p:sp>
       <p:sp>
         <p:nvSpPr>
-          <p:cNvPr id="3" name="Content Placeholder 2"/>
-          <p:cNvSpPr>
-            <a:spLocks noGrp="1"/>
-          </p:cNvSpPr>
-          <p:nvPr>
-            <p:ph idx="1"/>
-          </p:nvPr>
-        </p:nvSpPr>
-        <p:spPr/>
-        <p:txBody>
-          <a:bodyPr wrap="square"/>
-          <a:lstStyle/>
-          <a:p>
-            <a:pPr>
-              <a:defRPr sz="2800">
+          <p:cNvPr id="3" name="TextBox 2"/>
+          <p:cNvSpPr txBox="1"/>
+          <p:nvPr/>
+        </p:nvSpPr>
+        <p:spPr>
+          <a:xfrm>
+            <a:off x="1097280" y="1645920"/>
+            <a:ext cx="10177272" cy="1005840"/>
+          </a:xfrm>
+          <a:prstGeom prst="rect">
+            <a:avLst/>
+          </a:prstGeom>
+          <a:noFill/>
+        </p:spPr>
+        <p:txBody>
+          <a:bodyPr wrap="square">
+            <a:spAutoFit/>
+          </a:bodyPr>
+          <a:lstStyle/>
+          <a:p>
+            <a:pPr algn="l">
+              <a:defRPr sz="2400" b="0">
                 <a:solidFill>
                   <a:srgbClr val="F0F0F0"/>
                 </a:solidFill>
@@ -3520,12 +3616,35 @@
               </a:defRPr>
             </a:pPr>
             <a:r>
-              <a:t>Beyond Core Counts: Classical Amdahl’s Law (fixed serial/parallel fraction) fails to describe modern heterogeneous AI architectures</a:t>
-            </a:r>
-          </a:p>
-          <a:p>
-            <a:pPr>
-              <a:defRPr sz="2800">
+              <a:t>• Beyond Core Counts: Classical Amdahl’s Law (fixed serial/parallel fraction) fails to describe modern heterogeneous AI architectures</a:t>
+            </a:r>
+          </a:p>
+        </p:txBody>
+      </p:sp>
+      <p:sp>
+        <p:nvSpPr>
+          <p:cNvPr id="4" name="TextBox 3"/>
+          <p:cNvSpPr txBox="1"/>
+          <p:nvPr/>
+        </p:nvSpPr>
+        <p:spPr>
+          <a:xfrm>
+            <a:off x="1097280" y="2743200"/>
+            <a:ext cx="10177272" cy="1417320"/>
+          </a:xfrm>
+          <a:prstGeom prst="rect">
+            <a:avLst/>
+          </a:prstGeom>
+          <a:noFill/>
+        </p:spPr>
+        <p:txBody>
+          <a:bodyPr wrap="square">
+            <a:spAutoFit/>
+          </a:bodyPr>
+          <a:lstStyle/>
+          <a:p>
+            <a:pPr algn="l">
+              <a:defRPr sz="2400" b="0">
                 <a:solidFill>
                   <a:srgbClr val="F0F0F0"/>
                 </a:solidFill>
@@ -3533,12 +3652,35 @@
               </a:defRPr>
             </a:pPr>
             <a:r>
-              <a:t>Constrained Hardware Allocation: The modern design question is how to allocate a constrained hardware budget between specialized logic and programmable compute</a:t>
-            </a:r>
-          </a:p>
-          <a:p>
-            <a:pPr>
-              <a:defRPr sz="2800">
+              <a:t>• Constrained Hardware Allocation: The modern design question is how to allocate a constrained hardware budget between specialized logic and programmable compute</a:t>
+            </a:r>
+          </a:p>
+        </p:txBody>
+      </p:sp>
+      <p:sp>
+        <p:nvSpPr>
+          <p:cNvPr id="5" name="TextBox 4"/>
+          <p:cNvSpPr txBox="1"/>
+          <p:nvPr/>
+        </p:nvSpPr>
+        <p:spPr>
+          <a:xfrm>
+            <a:off x="1097280" y="4251960"/>
+            <a:ext cx="10177272" cy="1417320"/>
+          </a:xfrm>
+          <a:prstGeom prst="rect">
+            <a:avLst/>
+          </a:prstGeom>
+          <a:noFill/>
+        </p:spPr>
+        <p:txBody>
+          <a:bodyPr wrap="square">
+            <a:spAutoFit/>
+          </a:bodyPr>
+          <a:lstStyle/>
+          <a:p>
+            <a:pPr algn="l">
+              <a:defRPr sz="2400" b="0">
                 <a:solidFill>
                   <a:srgbClr val="F0F0F0"/>
                 </a:solidFill>
@@ -3546,7 +3688,7 @@
               </a:defRPr>
             </a:pPr>
             <a:r>
-              <a:t>The Value-Scalable Fraction (S): The portion of the workload where injecting additional compute continues to create meaningful, end-to-end task value</a:t>
+              <a:t>• The Value-Scalable Fraction (S): The portion of the workload where injecting additional compute continues to create meaningful, end-to-end task value</a:t>
             </a:r>
           </a:p>
         </p:txBody>
@@ -3565,7 +3707,7 @@
     <p:bg>
       <p:bgPr>
         <a:solidFill>
-          <a:srgbClr val="141E30"/>
+          <a:srgbClr val="0A1929"/>
         </a:solidFill>
         <a:effectLst/>
       </p:bgPr>
@@ -3579,21 +3721,64 @@
       <p:grpSpPr/>
       <p:sp>
         <p:nvSpPr>
-          <p:cNvPr id="2" name="Title 1"/>
-          <p:cNvSpPr>
-            <a:spLocks noGrp="1"/>
-          </p:cNvSpPr>
-          <p:nvPr>
-            <p:ph type="title"/>
-          </p:nvPr>
-        </p:nvSpPr>
-        <p:spPr/>
-        <p:txBody>
-          <a:bodyPr/>
-          <a:lstStyle/>
-          <a:p>
-            <a:pPr>
-              <a:defRPr b="1" sz="4000">
+          <p:cNvPr id="2" name="TextBox 1"/>
+          <p:cNvSpPr txBox="1"/>
+          <p:nvPr/>
+        </p:nvSpPr>
+        <p:spPr>
+          <a:xfrm>
+            <a:off x="731520" y="457200"/>
+            <a:ext cx="10725912" cy="914400"/>
+          </a:xfrm>
+          <a:prstGeom prst="rect">
+            <a:avLst/>
+          </a:prstGeom>
+          <a:noFill/>
+        </p:spPr>
+        <p:txBody>
+          <a:bodyPr wrap="square">
+            <a:spAutoFit/>
+          </a:bodyPr>
+          <a:lstStyle/>
+          <a:p>
+            <a:pPr algn="l">
+              <a:defRPr sz="3600" b="1">
+                <a:solidFill>
+                  <a:srgbClr val="00FFFF"/>
+                </a:solidFill>
+                <a:latin typeface="Arial"/>
+              </a:defRPr>
+            </a:pPr>
+            <a:r>
+              <a:t>Paper 4: The Collapse Threshold of Specialization</a:t>
+            </a:r>
+          </a:p>
+        </p:txBody>
+      </p:sp>
+      <p:sp>
+        <p:nvSpPr>
+          <p:cNvPr id="3" name="TextBox 2"/>
+          <p:cNvSpPr txBox="1"/>
+          <p:nvPr/>
+        </p:nvSpPr>
+        <p:spPr>
+          <a:xfrm>
+            <a:off x="914400" y="1645920"/>
+            <a:ext cx="10360152" cy="914400"/>
+          </a:xfrm>
+          <a:prstGeom prst="rect">
+            <a:avLst/>
+          </a:prstGeom>
+          <a:noFill/>
+        </p:spPr>
+        <p:txBody>
+          <a:bodyPr wrap="square">
+            <a:spAutoFit/>
+          </a:bodyPr>
+          <a:lstStyle/>
+          <a:p>
+            <a:pPr algn="l">
+              <a:defRPr sz="2000" b="1">
                 <a:solidFill>
                   <a:srgbClr val="FFD700"/>
                 </a:solidFill>
@@ -3601,41 +3786,35 @@
               </a:defRPr>
             </a:pPr>
             <a:r>
-              <a:t>Paper 4: The Collapse Threshold of Specialization</a:t>
-            </a:r>
-          </a:p>
-        </p:txBody>
-      </p:sp>
-      <p:sp>
-        <p:nvSpPr>
-          <p:cNvPr id="3" name="Content Placeholder 2"/>
-          <p:cNvSpPr>
-            <a:spLocks noGrp="1"/>
-          </p:cNvSpPr>
-          <p:nvPr>
-            <p:ph idx="1"/>
-          </p:nvPr>
-        </p:nvSpPr>
-        <p:spPr/>
-        <p:txBody>
-          <a:bodyPr wrap="square"/>
-          <a:lstStyle/>
-          <a:p>
-            <a:pPr lvl="1">
-              <a:defRPr i="1" sz="2000">
-                <a:solidFill>
-                  <a:srgbClr val="6496FF"/>
-                </a:solidFill>
-                <a:latin typeface="Arial"/>
-              </a:defRPr>
-            </a:pPr>
-            <a:r>
               <a:t>[Visual Concept: A phase-boundary graph showing the race between Specialization Efficiency (R) and Scalable Fraction (S)]</a:t>
             </a:r>
           </a:p>
-          <a:p>
-            <a:pPr>
-              <a:defRPr sz="2800">
+        </p:txBody>
+      </p:sp>
+      <p:sp>
+        <p:nvSpPr>
+          <p:cNvPr id="4" name="TextBox 3"/>
+          <p:cNvSpPr txBox="1"/>
+          <p:nvPr/>
+        </p:nvSpPr>
+        <p:spPr>
+          <a:xfrm>
+            <a:off x="1097280" y="2651760"/>
+            <a:ext cx="10177272" cy="1005840"/>
+          </a:xfrm>
+          <a:prstGeom prst="rect">
+            <a:avLst/>
+          </a:prstGeom>
+          <a:noFill/>
+        </p:spPr>
+        <p:txBody>
+          <a:bodyPr wrap="square">
+            <a:spAutoFit/>
+          </a:bodyPr>
+          <a:lstStyle/>
+          <a:p>
+            <a:pPr algn="l">
+              <a:defRPr sz="2400" b="0">
                 <a:solidFill>
                   <a:srgbClr val="F0F0F0"/>
                 </a:solidFill>
@@ -3643,12 +3822,35 @@
               </a:defRPr>
             </a:pPr>
             <a:r>
-              <a:t>The Rising Bar: As the value-scalable workload (S) grows, fixed-function specialization faces a strict collapse threshold</a:t>
-            </a:r>
-          </a:p>
-          <a:p>
-            <a:pPr>
-              <a:defRPr sz="2800">
+              <a:t>• The Rising Bar: As the value-scalable workload (S) grows, fixed-function specialization faces a strict collapse threshold</a:t>
+            </a:r>
+          </a:p>
+        </p:txBody>
+      </p:sp>
+      <p:sp>
+        <p:nvSpPr>
+          <p:cNvPr id="5" name="TextBox 4"/>
+          <p:cNvSpPr txBox="1"/>
+          <p:nvPr/>
+        </p:nvSpPr>
+        <p:spPr>
+          <a:xfrm>
+            <a:off x="1097280" y="3749040"/>
+            <a:ext cx="10177272" cy="1417320"/>
+          </a:xfrm>
+          <a:prstGeom prst="rect">
+            <a:avLst/>
+          </a:prstGeom>
+          <a:noFill/>
+        </p:spPr>
+        <p:txBody>
+          <a:bodyPr wrap="square">
+            <a:spAutoFit/>
+          </a:bodyPr>
+          <a:lstStyle/>
+          <a:p>
+            <a:pPr algn="l">
+              <a:defRPr sz="2400" b="0">
                 <a:solidFill>
                   <a:srgbClr val="F0F0F0"/>
                 </a:solidFill>
@@ -3656,12 +3858,35 @@
               </a:defRPr>
             </a:pPr>
             <a:r>
-              <a:t>The Key Equation: For a given scalable fraction S, specialized hardware must achieve a relative efficiency ratio of R_c = 1/(1−S) to justify its inclusion</a:t>
-            </a:r>
-          </a:p>
-          <a:p>
-            <a:pPr>
-              <a:defRPr sz="2800">
+              <a:t>• The Key Equation: For a given scalable fraction S, specialized hardware must achieve a relative efficiency ratio of R_c = 1/(1−S) to justify its inclusion</a:t>
+            </a:r>
+          </a:p>
+        </p:txBody>
+      </p:sp>
+      <p:sp>
+        <p:nvSpPr>
+          <p:cNvPr id="6" name="TextBox 5"/>
+          <p:cNvSpPr txBox="1"/>
+          <p:nvPr/>
+        </p:nvSpPr>
+        <p:spPr>
+          <a:xfrm>
+            <a:off x="1097280" y="5257800"/>
+            <a:ext cx="10177272" cy="502920"/>
+          </a:xfrm>
+          <a:prstGeom prst="rect">
+            <a:avLst/>
+          </a:prstGeom>
+          <a:noFill/>
+        </p:spPr>
+        <p:txBody>
+          <a:bodyPr wrap="square">
+            <a:spAutoFit/>
+          </a:bodyPr>
+          <a:lstStyle/>
+          <a:p>
+            <a:pPr algn="l">
+              <a:defRPr sz="2400" b="0">
                 <a:solidFill>
                   <a:srgbClr val="F0F0F0"/>
                 </a:solidFill>
@@ -3669,7 +3894,7 @@
               </a:defRPr>
             </a:pPr>
             <a:r>
-              <a:t>Specialization must constantly re-earn its silicon</a:t>
+              <a:t>• Specialization must constantly re-earn its silicon</a:t>
             </a:r>
           </a:p>
         </p:txBody>
@@ -3688,7 +3913,7 @@
     <p:bg>
       <p:bgPr>
         <a:solidFill>
-          <a:srgbClr val="141E30"/>
+          <a:srgbClr val="0A1929"/>
         </a:solidFill>
         <a:effectLst/>
       </p:bgPr>
@@ -3702,23 +3927,30 @@
       <p:grpSpPr/>
       <p:sp>
         <p:nvSpPr>
-          <p:cNvPr id="2" name="Title 1"/>
-          <p:cNvSpPr>
-            <a:spLocks noGrp="1"/>
-          </p:cNvSpPr>
-          <p:nvPr>
-            <p:ph type="title"/>
-          </p:nvPr>
-        </p:nvSpPr>
-        <p:spPr/>
-        <p:txBody>
-          <a:bodyPr/>
-          <a:lstStyle/>
-          <a:p>
-            <a:pPr>
-              <a:defRPr b="1" sz="4000">
-                <a:solidFill>
-                  <a:srgbClr val="FFD700"/>
+          <p:cNvPr id="2" name="TextBox 1"/>
+          <p:cNvSpPr txBox="1"/>
+          <p:nvPr/>
+        </p:nvSpPr>
+        <p:spPr>
+          <a:xfrm>
+            <a:off x="731520" y="457200"/>
+            <a:ext cx="10725912" cy="914400"/>
+          </a:xfrm>
+          <a:prstGeom prst="rect">
+            <a:avLst/>
+          </a:prstGeom>
+          <a:noFill/>
+        </p:spPr>
+        <p:txBody>
+          <a:bodyPr wrap="square">
+            <a:spAutoFit/>
+          </a:bodyPr>
+          <a:lstStyle/>
+          <a:p>
+            <a:pPr algn="l">
+              <a:defRPr sz="3600" b="1">
+                <a:solidFill>
+                  <a:srgbClr val="00FFFF"/>
                 </a:solidFill>
                 <a:latin typeface="Arial"/>
               </a:defRPr>
@@ -3731,21 +3963,28 @@
       </p:sp>
       <p:sp>
         <p:nvSpPr>
-          <p:cNvPr id="3" name="Content Placeholder 2"/>
-          <p:cNvSpPr>
-            <a:spLocks noGrp="1"/>
-          </p:cNvSpPr>
-          <p:nvPr>
-            <p:ph idx="1"/>
-          </p:nvPr>
-        </p:nvSpPr>
-        <p:spPr/>
-        <p:txBody>
-          <a:bodyPr wrap="square"/>
-          <a:lstStyle/>
-          <a:p>
-            <a:pPr>
-              <a:defRPr sz="2800">
+          <p:cNvPr id="3" name="TextBox 2"/>
+          <p:cNvSpPr txBox="1"/>
+          <p:nvPr/>
+        </p:nvSpPr>
+        <p:spPr>
+          <a:xfrm>
+            <a:off x="1097280" y="1645920"/>
+            <a:ext cx="10177272" cy="1417320"/>
+          </a:xfrm>
+          <a:prstGeom prst="rect">
+            <a:avLst/>
+          </a:prstGeom>
+          <a:noFill/>
+        </p:spPr>
+        <p:txBody>
+          <a:bodyPr wrap="square">
+            <a:spAutoFit/>
+          </a:bodyPr>
+          <a:lstStyle/>
+          <a:p>
+            <a:pPr algn="l">
+              <a:defRPr sz="2400" b="0">
                 <a:solidFill>
                   <a:srgbClr val="F0F0F0"/>
                 </a:solidFill>
@@ -3753,12 +3992,35 @@
               </a:defRPr>
             </a:pPr>
             <a:r>
-              <a:t>Shifting Value: AI scaling pushes value-generation away from early fixed pipelines toward learned, late-stage computation (e.g., neural reconstruction, massive rerankers)</a:t>
-            </a:r>
-          </a:p>
-          <a:p>
-            <a:pPr>
-              <a:defRPr sz="2800">
+              <a:t>• Shifting Value: AI scaling pushes value-generation away from early fixed pipelines toward learned, late-stage computation (e.g., neural reconstruction, massive rerankers)</a:t>
+            </a:r>
+          </a:p>
+        </p:txBody>
+      </p:sp>
+      <p:sp>
+        <p:nvSpPr>
+          <p:cNvPr id="4" name="TextBox 3"/>
+          <p:cNvSpPr txBox="1"/>
+          <p:nvPr/>
+        </p:nvSpPr>
+        <p:spPr>
+          <a:xfrm>
+            <a:off x="1097280" y="3154680"/>
+            <a:ext cx="10177272" cy="1005840"/>
+          </a:xfrm>
+          <a:prstGeom prst="rect">
+            <a:avLst/>
+          </a:prstGeom>
+          <a:noFill/>
+        </p:spPr>
+        <p:txBody>
+          <a:bodyPr wrap="square">
+            <a:spAutoFit/>
+          </a:bodyPr>
+          <a:lstStyle/>
+          <a:p>
+            <a:pPr algn="l">
+              <a:defRPr sz="2400" b="0">
                 <a:solidFill>
                   <a:srgbClr val="F0F0F0"/>
                 </a:solidFill>
@@ -3766,12 +4028,35 @@
               </a:defRPr>
             </a:pPr>
             <a:r>
-              <a:t>Why GPUs Become More Programmable: As S rises, the optimal hardware locus shifts toward generalized, tensor-heavy programmable compute</a:t>
-            </a:r>
-          </a:p>
-          <a:p>
-            <a:pPr>
-              <a:defRPr sz="2800">
+              <a:t>• Why GPUs Become More Programmable: As S rises, the optimal hardware locus shifts toward generalized, tensor-heavy programmable compute</a:t>
+            </a:r>
+          </a:p>
+        </p:txBody>
+      </p:sp>
+      <p:sp>
+        <p:nvSpPr>
+          <p:cNvPr id="5" name="TextBox 4"/>
+          <p:cNvSpPr txBox="1"/>
+          <p:nvPr/>
+        </p:nvSpPr>
+        <p:spPr>
+          <a:xfrm>
+            <a:off x="1097280" y="4251960"/>
+            <a:ext cx="10177272" cy="1417320"/>
+          </a:xfrm>
+          <a:prstGeom prst="rect">
+            <a:avLst/>
+          </a:prstGeom>
+          <a:noFill/>
+        </p:spPr>
+        <p:txBody>
+          <a:bodyPr wrap="square">
+            <a:spAutoFit/>
+          </a:bodyPr>
+          <a:lstStyle/>
+          <a:p>
+            <a:pPr algn="l">
+              <a:defRPr sz="2400" b="0">
                 <a:solidFill>
                   <a:srgbClr val="F0F0F0"/>
                 </a:solidFill>
@@ -3779,7 +4064,7 @@
               </a:defRPr>
             </a:pPr>
             <a:r>
-              <a:t>The Accelerator Dynamic: AI domain-specific accelerators matter, but they do not simply displace the GPU; they must continually adapt as the dominant value-producing workload evolves</a:t>
+              <a:t>• The Accelerator Dynamic: AI domain-specific accelerators matter, but they do not simply displace the GPU; they must continually displace as the dominant value-producing workload evolves</a:t>
             </a:r>
           </a:p>
         </p:txBody>
@@ -3798,7 +4083,7 @@
     <p:bg>
       <p:bgPr>
         <a:solidFill>
-          <a:srgbClr val="141E30"/>
+          <a:srgbClr val="0A1929"/>
         </a:solidFill>
         <a:effectLst/>
       </p:bgPr>
@@ -3812,21 +4097,64 @@
       <p:grpSpPr/>
       <p:sp>
         <p:nvSpPr>
-          <p:cNvPr id="2" name="Title 1"/>
-          <p:cNvSpPr>
-            <a:spLocks noGrp="1"/>
-          </p:cNvSpPr>
-          <p:nvPr>
-            <p:ph type="title"/>
-          </p:nvPr>
-        </p:nvSpPr>
-        <p:spPr/>
-        <p:txBody>
-          <a:bodyPr/>
-          <a:lstStyle/>
-          <a:p>
-            <a:pPr>
-              <a:defRPr b="1" sz="4000">
+          <p:cNvPr id="2" name="TextBox 1"/>
+          <p:cNvSpPr txBox="1"/>
+          <p:nvPr/>
+        </p:nvSpPr>
+        <p:spPr>
+          <a:xfrm>
+            <a:off x="731520" y="457200"/>
+            <a:ext cx="10725912" cy="914400"/>
+          </a:xfrm>
+          <a:prstGeom prst="rect">
+            <a:avLst/>
+          </a:prstGeom>
+          <a:noFill/>
+        </p:spPr>
+        <p:txBody>
+          <a:bodyPr wrap="square">
+            <a:spAutoFit/>
+          </a:bodyPr>
+          <a:lstStyle/>
+          <a:p>
+            <a:pPr algn="l">
+              <a:defRPr sz="3600" b="1">
+                <a:solidFill>
+                  <a:srgbClr val="00FFFF"/>
+                </a:solidFill>
+                <a:latin typeface="Arial"/>
+              </a:defRPr>
+            </a:pPr>
+            <a:r>
+              <a:t>Final Synthesis: The Unified Picture</a:t>
+            </a:r>
+          </a:p>
+        </p:txBody>
+      </p:sp>
+      <p:sp>
+        <p:nvSpPr>
+          <p:cNvPr id="3" name="TextBox 2"/>
+          <p:cNvSpPr txBox="1"/>
+          <p:nvPr/>
+        </p:nvSpPr>
+        <p:spPr>
+          <a:xfrm>
+            <a:off x="914400" y="1645920"/>
+            <a:ext cx="10360152" cy="1325880"/>
+          </a:xfrm>
+          <a:prstGeom prst="rect">
+            <a:avLst/>
+          </a:prstGeom>
+          <a:noFill/>
+        </p:spPr>
+        <p:txBody>
+          <a:bodyPr wrap="square">
+            <a:spAutoFit/>
+          </a:bodyPr>
+          <a:lstStyle/>
+          <a:p>
+            <a:pPr algn="l">
+              <a:defRPr sz="2000" b="1">
                 <a:solidFill>
                   <a:srgbClr val="FFD700"/>
                 </a:solidFill>
@@ -3834,41 +4162,35 @@
               </a:defRPr>
             </a:pPr>
             <a:r>
-              <a:t>Final Synthesis: The Unified Picture</a:t>
-            </a:r>
-          </a:p>
-        </p:txBody>
-      </p:sp>
-      <p:sp>
-        <p:nvSpPr>
-          <p:cNvPr id="3" name="Content Placeholder 2"/>
-          <p:cNvSpPr>
-            <a:spLocks noGrp="1"/>
-          </p:cNvSpPr>
-          <p:nvPr>
-            <p:ph idx="1"/>
-          </p:nvPr>
-        </p:nvSpPr>
-        <p:spPr/>
-        <p:txBody>
-          <a:bodyPr wrap="square"/>
-          <a:lstStyle/>
-          <a:p>
-            <a:pPr lvl="1">
-              <a:defRPr i="1" sz="2000">
-                <a:solidFill>
-                  <a:srgbClr val="6496FF"/>
-                </a:solidFill>
-                <a:latin typeface="Arial"/>
-              </a:defRPr>
-            </a:pPr>
-            <a:r>
               <a:t>[Visual Concept: A single clean structural diagram linking formal limits, bounded feasibility, empirical scaling, and hardware architecture]</a:t>
             </a:r>
           </a:p>
-          <a:p>
-            <a:pPr lvl="1">
-              <a:defRPr sz="2400">
+        </p:txBody>
+      </p:sp>
+      <p:sp>
+        <p:nvSpPr>
+          <p:cNvPr id="4" name="TextBox 3"/>
+          <p:cNvSpPr txBox="1"/>
+          <p:nvPr/>
+        </p:nvSpPr>
+        <p:spPr>
+          <a:xfrm>
+            <a:off x="1097280" y="3063240"/>
+            <a:ext cx="10177272" cy="594360"/>
+          </a:xfrm>
+          <a:prstGeom prst="rect">
+            <a:avLst/>
+          </a:prstGeom>
+          <a:noFill/>
+        </p:spPr>
+        <p:txBody>
+          <a:bodyPr wrap="square">
+            <a:spAutoFit/>
+          </a:bodyPr>
+          <a:lstStyle/>
+          <a:p>
+            <a:pPr algn="l">
+              <a:defRPr sz="2400" b="0">
                 <a:solidFill>
                   <a:srgbClr val="F0F0F0"/>
                 </a:solidFill>
@@ -3876,12 +4198,35 @@
               </a:defRPr>
             </a:pPr>
             <a:r>
-              <a:t>1. Computability: Open-ended ascent across relative boundaries</a:t>
-            </a:r>
-          </a:p>
-          <a:p>
-            <a:pPr lvl="1">
-              <a:defRPr sz="2400">
+              <a:t>• 1. Computability: Open-ended ascent across relative boundaries</a:t>
+            </a:r>
+          </a:p>
+        </p:txBody>
+      </p:sp>
+      <p:sp>
+        <p:nvSpPr>
+          <p:cNvPr id="5" name="TextBox 4"/>
+          <p:cNvSpPr txBox="1"/>
+          <p:nvPr/>
+        </p:nvSpPr>
+        <p:spPr>
+          <a:xfrm>
+            <a:off x="1097280" y="3749040"/>
+            <a:ext cx="10177272" cy="1005840"/>
+          </a:xfrm>
+          <a:prstGeom prst="rect">
+            <a:avLst/>
+          </a:prstGeom>
+          <a:noFill/>
+        </p:spPr>
+        <p:txBody>
+          <a:bodyPr wrap="square">
+            <a:spAutoFit/>
+          </a:bodyPr>
+          <a:lstStyle/>
+          <a:p>
+            <a:pPr algn="l">
+              <a:defRPr sz="2400" b="0">
                 <a:solidFill>
                   <a:srgbClr val="F0F0F0"/>
                 </a:solidFill>
@@ -3889,12 +4234,35 @@
               </a:defRPr>
             </a:pPr>
             <a:r>
-              <a:t>2. Feasibility: Staged reachability through polynomial-time verification</a:t>
-            </a:r>
-          </a:p>
-          <a:p>
-            <a:pPr lvl="1">
-              <a:defRPr sz="2400">
+              <a:t>• 2. Feasibility: Staged reachability through polynomial-time verification</a:t>
+            </a:r>
+          </a:p>
+        </p:txBody>
+      </p:sp>
+      <p:sp>
+        <p:nvSpPr>
+          <p:cNvPr id="6" name="TextBox 5"/>
+          <p:cNvSpPr txBox="1"/>
+          <p:nvPr/>
+        </p:nvSpPr>
+        <p:spPr>
+          <a:xfrm>
+            <a:off x="1097280" y="4846320"/>
+            <a:ext cx="10177272" cy="1005840"/>
+          </a:xfrm>
+          <a:prstGeom prst="rect">
+            <a:avLst/>
+          </a:prstGeom>
+          <a:noFill/>
+        </p:spPr>
+        <p:txBody>
+          <a:bodyPr wrap="square">
+            <a:spAutoFit/>
+          </a:bodyPr>
+          <a:lstStyle/>
+          <a:p>
+            <a:pPr algn="l">
+              <a:defRPr sz="2400" b="0">
                 <a:solidFill>
                   <a:srgbClr val="F0F0F0"/>
                 </a:solidFill>
@@ -3902,12 +4270,35 @@
               </a:defRPr>
             </a:pPr>
             <a:r>
-              <a:t>3. Empirical Drivers: Logical scaling sustained by compounding hidden efficiency</a:t>
-            </a:r>
-          </a:p>
-          <a:p>
-            <a:pPr lvl="1">
-              <a:defRPr sz="2400">
+              <a:t>• 3. Empirical Drivers: Logical scaling sustained by compounding hidden efficiency</a:t>
+            </a:r>
+          </a:p>
+        </p:txBody>
+      </p:sp>
+      <p:sp>
+        <p:nvSpPr>
+          <p:cNvPr id="7" name="TextBox 6"/>
+          <p:cNvSpPr txBox="1"/>
+          <p:nvPr/>
+        </p:nvSpPr>
+        <p:spPr>
+          <a:xfrm>
+            <a:off x="1097280" y="5943600"/>
+            <a:ext cx="10177272" cy="1005840"/>
+          </a:xfrm>
+          <a:prstGeom prst="rect">
+            <a:avLst/>
+          </a:prstGeom>
+          <a:noFill/>
+        </p:spPr>
+        <p:txBody>
+          <a:bodyPr wrap="square">
+            <a:spAutoFit/>
+          </a:bodyPr>
+          <a:lstStyle/>
+          <a:p>
+            <a:pPr algn="l">
+              <a:defRPr sz="2400" b="0">
                 <a:solidFill>
                   <a:srgbClr val="F0F0F0"/>
                 </a:solidFill>
@@ -3915,7 +4306,7 @@
               </a:defRPr>
             </a:pPr>
             <a:r>
-              <a:t>4. Architectural Response: Rising scalable workloads driving hardware toward programmable compute</a:t>
+              <a:t>• 4. Architectural Response: Rising scalable workloads driving hardware toward programmable compute</a:t>
             </a:r>
           </a:p>
         </p:txBody>
@@ -3934,7 +4325,7 @@
     <p:bg>
       <p:bgPr>
         <a:solidFill>
-          <a:srgbClr val="141E30"/>
+          <a:srgbClr val="0A1929"/>
         </a:solidFill>
         <a:effectLst/>
       </p:bgPr>
@@ -3948,23 +4339,30 @@
       <p:grpSpPr/>
       <p:sp>
         <p:nvSpPr>
-          <p:cNvPr id="2" name="Title 1"/>
-          <p:cNvSpPr>
-            <a:spLocks noGrp="1"/>
-          </p:cNvSpPr>
-          <p:nvPr>
-            <p:ph type="title"/>
-          </p:nvPr>
-        </p:nvSpPr>
-        <p:spPr/>
-        <p:txBody>
-          <a:bodyPr/>
-          <a:lstStyle/>
-          <a:p>
-            <a:pPr>
-              <a:defRPr b="1" sz="4000">
-                <a:solidFill>
-                  <a:srgbClr val="FFD700"/>
+          <p:cNvPr id="2" name="TextBox 1"/>
+          <p:cNvSpPr txBox="1"/>
+          <p:nvPr/>
+        </p:nvSpPr>
+        <p:spPr>
+          <a:xfrm>
+            <a:off x="731520" y="457200"/>
+            <a:ext cx="10725912" cy="914400"/>
+          </a:xfrm>
+          <a:prstGeom prst="rect">
+            <a:avLst/>
+          </a:prstGeom>
+          <a:noFill/>
+        </p:spPr>
+        <p:txBody>
+          <a:bodyPr wrap="square">
+            <a:spAutoFit/>
+          </a:bodyPr>
+          <a:lstStyle/>
+          <a:p>
+            <a:pPr algn="l">
+              <a:defRPr sz="3600" b="1">
+                <a:solidFill>
+                  <a:srgbClr val="00FFFF"/>
                 </a:solidFill>
                 <a:latin typeface="Arial"/>
               </a:defRPr>
@@ -3977,21 +4375,28 @@
       </p:sp>
       <p:sp>
         <p:nvSpPr>
-          <p:cNvPr id="3" name="Content Placeholder 2"/>
-          <p:cNvSpPr>
-            <a:spLocks noGrp="1"/>
-          </p:cNvSpPr>
-          <p:nvPr>
-            <p:ph idx="1"/>
-          </p:nvPr>
-        </p:nvSpPr>
-        <p:spPr/>
-        <p:txBody>
-          <a:bodyPr wrap="square"/>
-          <a:lstStyle/>
-          <a:p>
-            <a:pPr>
-              <a:defRPr sz="2800">
+          <p:cNvPr id="3" name="TextBox 2"/>
+          <p:cNvSpPr txBox="1"/>
+          <p:nvPr/>
+        </p:nvSpPr>
+        <p:spPr>
+          <a:xfrm>
+            <a:off x="1097280" y="1645920"/>
+            <a:ext cx="10177272" cy="1005840"/>
+          </a:xfrm>
+          <a:prstGeom prst="rect">
+            <a:avLst/>
+          </a:prstGeom>
+          <a:noFill/>
+        </p:spPr>
+        <p:txBody>
+          <a:bodyPr wrap="square">
+            <a:spAutoFit/>
+          </a:bodyPr>
+          <a:lstStyle/>
+          <a:p>
+            <a:pPr algn="l">
+              <a:defRPr sz="2400" b="0">
                 <a:solidFill>
                   <a:srgbClr val="F0F0F0"/>
                 </a:solidFill>
@@ -3999,12 +4404,35 @@
               </a:defRPr>
             </a:pPr>
             <a:r>
-              <a:t>A Structured Phenomenon: AI progress is neither pure hype nor a contradiction of theoretical limits</a:t>
-            </a:r>
-          </a:p>
-          <a:p>
-            <a:pPr>
-              <a:defRPr sz="2800">
+              <a:t>• A Structured Phenomenon: AI progress is neither pure hype nor a contradiction of theoretical limits</a:t>
+            </a:r>
+          </a:p>
+        </p:txBody>
+      </p:sp>
+      <p:sp>
+        <p:nvSpPr>
+          <p:cNvPr id="4" name="TextBox 3"/>
+          <p:cNvSpPr txBox="1"/>
+          <p:nvPr/>
+        </p:nvSpPr>
+        <p:spPr>
+          <a:xfrm>
+            <a:off x="1097280" y="2743200"/>
+            <a:ext cx="10177272" cy="1417320"/>
+          </a:xfrm>
+          <a:prstGeom prst="rect">
+            <a:avLst/>
+          </a:prstGeom>
+          <a:noFill/>
+        </p:spPr>
+        <p:txBody>
+          <a:bodyPr wrap="square">
+            <a:spAutoFit/>
+          </a:bodyPr>
+          <a:lstStyle/>
+          <a:p>
+            <a:pPr algn="l">
+              <a:defRPr sz="2400" b="0">
                 <a:solidFill>
                   <a:srgbClr val="F0F0F0"/>
                 </a:solidFill>
@@ -4012,7 +4440,7 @@
               </a:defRPr>
             </a:pPr>
             <a:r>
-              <a:t>The Unified Program: Intelligence emerges as a structured, open-ended process bounded by formal limits, propelled by empirical scaling drivers, and fundamentally reshaping system-level hardware consequences</a:t>
+              <a:t>• The Unified Program: Intelligence emerges as a structured, open-ended process bounded by formal limits, propelled by empirical scaling drivers, and fundamentally reshaping system-level hardware consequences</a:t>
             </a:r>
           </a:p>
         </p:txBody>
@@ -4031,7 +4459,7 @@
     <p:bg>
       <p:bgPr>
         <a:solidFill>
-          <a:srgbClr val="141E30"/>
+          <a:srgbClr val="0A1929"/>
         </a:solidFill>
         <a:effectLst/>
       </p:bgPr>
@@ -4045,23 +4473,30 @@
       <p:grpSpPr/>
       <p:sp>
         <p:nvSpPr>
-          <p:cNvPr id="2" name="Title 1"/>
-          <p:cNvSpPr>
-            <a:spLocks noGrp="1"/>
-          </p:cNvSpPr>
-          <p:nvPr>
-            <p:ph type="title"/>
-          </p:nvPr>
-        </p:nvSpPr>
-        <p:spPr/>
-        <p:txBody>
-          <a:bodyPr/>
-          <a:lstStyle/>
-          <a:p>
-            <a:pPr>
-              <a:defRPr b="1" sz="4000">
-                <a:solidFill>
-                  <a:srgbClr val="FFD700"/>
+          <p:cNvPr id="2" name="TextBox 1"/>
+          <p:cNvSpPr txBox="1"/>
+          <p:nvPr/>
+        </p:nvSpPr>
+        <p:spPr>
+          <a:xfrm>
+            <a:off x="731520" y="457200"/>
+            <a:ext cx="10725912" cy="914400"/>
+          </a:xfrm>
+          <a:prstGeom prst="rect">
+            <a:avLst/>
+          </a:prstGeom>
+          <a:noFill/>
+        </p:spPr>
+        <p:txBody>
+          <a:bodyPr wrap="square">
+            <a:spAutoFit/>
+          </a:bodyPr>
+          <a:lstStyle/>
+          <a:p>
+            <a:pPr algn="l">
+              <a:defRPr sz="3600" b="1">
+                <a:solidFill>
+                  <a:srgbClr val="00FFFF"/>
                 </a:solidFill>
                 <a:latin typeface="Arial"/>
               </a:defRPr>
@@ -4074,21 +4509,28 @@
       </p:sp>
       <p:sp>
         <p:nvSpPr>
-          <p:cNvPr id="3" name="Content Placeholder 2"/>
-          <p:cNvSpPr>
-            <a:spLocks noGrp="1"/>
-          </p:cNvSpPr>
-          <p:nvPr>
-            <p:ph idx="1"/>
-          </p:nvPr>
-        </p:nvSpPr>
-        <p:spPr/>
-        <p:txBody>
-          <a:bodyPr wrap="square"/>
-          <a:lstStyle/>
-          <a:p>
-            <a:pPr>
-              <a:defRPr sz="2800">
+          <p:cNvPr id="3" name="TextBox 2"/>
+          <p:cNvSpPr txBox="1"/>
+          <p:nvPr/>
+        </p:nvSpPr>
+        <p:spPr>
+          <a:xfrm>
+            <a:off x="1097280" y="1645920"/>
+            <a:ext cx="10177272" cy="1005840"/>
+          </a:xfrm>
+          <a:prstGeom prst="rect">
+            <a:avLst/>
+          </a:prstGeom>
+          <a:noFill/>
+        </p:spPr>
+        <p:txBody>
+          <a:bodyPr wrap="square">
+            <a:spAutoFit/>
+          </a:bodyPr>
+          <a:lstStyle/>
+          <a:p>
+            <a:pPr algn="l">
+              <a:defRPr sz="2400" b="0">
                 <a:solidFill>
                   <a:srgbClr val="F0F0F0"/>
                 </a:solidFill>
@@ -4096,12 +4538,35 @@
               </a:defRPr>
             </a:pPr>
             <a:r>
-              <a:t>The Hype: Empirical AI discourse often focuses on capability scaling and scaling laws without a rigorous formal theory of progress</a:t>
-            </a:r>
-          </a:p>
-          <a:p>
-            <a:pPr>
-              <a:defRPr sz="2800">
+              <a:t>• The Hype: Empirical AI discourse often focuses on capability scaling and scaling laws without a rigorous formal theory of progress</a:t>
+            </a:r>
+          </a:p>
+        </p:txBody>
+      </p:sp>
+      <p:sp>
+        <p:nvSpPr>
+          <p:cNvPr id="4" name="TextBox 3"/>
+          <p:cNvSpPr txBox="1"/>
+          <p:nvPr/>
+        </p:nvSpPr>
+        <p:spPr>
+          <a:xfrm>
+            <a:off x="1097280" y="2743200"/>
+            <a:ext cx="10177272" cy="1417320"/>
+          </a:xfrm>
+          <a:prstGeom prst="rect">
+            <a:avLst/>
+          </a:prstGeom>
+          <a:noFill/>
+        </p:spPr>
+        <p:txBody>
+          <a:bodyPr wrap="square">
+            <a:spAutoFit/>
+          </a:bodyPr>
+          <a:lstStyle/>
+          <a:p>
+            <a:pPr algn="l">
+              <a:defRPr sz="2400" b="0">
                 <a:solidFill>
                   <a:srgbClr val="F0F0F0"/>
                 </a:solidFill>
@@ -4109,12 +4574,35 @@
               </a:defRPr>
             </a:pPr>
             <a:r>
-              <a:t>The Limits: Theoretical discourse frequently emphasizes strict mathematical limits without explaining how relentless practical progress continues to appear</a:t>
-            </a:r>
-          </a:p>
-          <a:p>
-            <a:pPr>
-              <a:defRPr sz="2800">
+              <a:t>• The Limits: Theoretical discourse frequently emphasizes strict mathematical limits without explaining how relentless practical progress continues to appear</a:t>
+            </a:r>
+          </a:p>
+        </p:txBody>
+      </p:sp>
+      <p:sp>
+        <p:nvSpPr>
+          <p:cNvPr id="5" name="TextBox 4"/>
+          <p:cNvSpPr txBox="1"/>
+          <p:nvPr/>
+        </p:nvSpPr>
+        <p:spPr>
+          <a:xfrm>
+            <a:off x="1097280" y="4251960"/>
+            <a:ext cx="10177272" cy="1417320"/>
+          </a:xfrm>
+          <a:prstGeom prst="rect">
+            <a:avLst/>
+          </a:prstGeom>
+          <a:noFill/>
+        </p:spPr>
+        <p:txBody>
+          <a:bodyPr wrap="square">
+            <a:spAutoFit/>
+          </a:bodyPr>
+          <a:lstStyle/>
+          <a:p>
+            <a:pPr algn="l">
+              <a:defRPr sz="2400" b="0">
                 <a:solidFill>
                   <a:srgbClr val="F0F0F0"/>
                 </a:solidFill>
@@ -4122,7 +4610,7 @@
               </a:defRPr>
             </a:pPr>
             <a:r>
-              <a:t>The Missing Link: We require a single, unified model that explains how formal boundaries, empirical drivers, and system-level architectural consequences interact</a:t>
+              <a:t>• The Missing Link: We require a single, unified model that explains how formal boundaries, empirical drivers, and system-level architectural consequences interact</a:t>
             </a:r>
           </a:p>
         </p:txBody>
@@ -4141,7 +4629,7 @@
     <p:bg>
       <p:bgPr>
         <a:solidFill>
-          <a:srgbClr val="141E30"/>
+          <a:srgbClr val="0A1929"/>
         </a:solidFill>
         <a:effectLst/>
       </p:bgPr>
@@ -4155,21 +4643,64 @@
       <p:grpSpPr/>
       <p:sp>
         <p:nvSpPr>
-          <p:cNvPr id="2" name="Title 1"/>
-          <p:cNvSpPr>
-            <a:spLocks noGrp="1"/>
-          </p:cNvSpPr>
-          <p:nvPr>
-            <p:ph type="title"/>
-          </p:nvPr>
-        </p:nvSpPr>
-        <p:spPr/>
-        <p:txBody>
-          <a:bodyPr/>
-          <a:lstStyle/>
-          <a:p>
-            <a:pPr>
-              <a:defRPr b="1" sz="4000">
+          <p:cNvPr id="2" name="TextBox 1"/>
+          <p:cNvSpPr txBox="1"/>
+          <p:nvPr/>
+        </p:nvSpPr>
+        <p:spPr>
+          <a:xfrm>
+            <a:off x="731520" y="457200"/>
+            <a:ext cx="10725912" cy="914400"/>
+          </a:xfrm>
+          <a:prstGeom prst="rect">
+            <a:avLst/>
+          </a:prstGeom>
+          <a:noFill/>
+        </p:spPr>
+        <p:txBody>
+          <a:bodyPr wrap="square">
+            <a:spAutoFit/>
+          </a:bodyPr>
+          <a:lstStyle/>
+          <a:p>
+            <a:pPr algn="l">
+              <a:defRPr sz="3600" b="1">
+                <a:solidFill>
+                  <a:srgbClr val="00FFFF"/>
+                </a:solidFill>
+                <a:latin typeface="Arial"/>
+              </a:defRPr>
+            </a:pPr>
+            <a:r>
+              <a:t>The Two-Pair Structure of AI Progress</a:t>
+            </a:r>
+          </a:p>
+        </p:txBody>
+      </p:sp>
+      <p:sp>
+        <p:nvSpPr>
+          <p:cNvPr id="3" name="TextBox 2"/>
+          <p:cNvSpPr txBox="1"/>
+          <p:nvPr/>
+        </p:nvSpPr>
+        <p:spPr>
+          <a:xfrm>
+            <a:off x="731520" y="1645920"/>
+            <a:ext cx="10543032" cy="777240"/>
+          </a:xfrm>
+          <a:prstGeom prst="rect">
+            <a:avLst/>
+          </a:prstGeom>
+          <a:noFill/>
+        </p:spPr>
+        <p:txBody>
+          <a:bodyPr wrap="square">
+            <a:spAutoFit/>
+          </a:bodyPr>
+          <a:lstStyle/>
+          <a:p>
+            <a:pPr algn="l">
+              <a:defRPr sz="2600" b="1">
                 <a:solidFill>
                   <a:srgbClr val="FFD700"/>
                 </a:solidFill>
@@ -4177,28 +4708,35 @@
               </a:defRPr>
             </a:pPr>
             <a:r>
-              <a:t>The Two-Pair Structure of AI Progress</a:t>
-            </a:r>
-          </a:p>
-        </p:txBody>
-      </p:sp>
-      <p:sp>
-        <p:nvSpPr>
-          <p:cNvPr id="3" name="Content Placeholder 2"/>
-          <p:cNvSpPr>
-            <a:spLocks noGrp="1"/>
-          </p:cNvSpPr>
-          <p:nvPr>
-            <p:ph idx="1"/>
-          </p:nvPr>
-        </p:nvSpPr>
-        <p:spPr/>
-        <p:txBody>
-          <a:bodyPr wrap="square"/>
-          <a:lstStyle/>
-          <a:p>
-            <a:pPr>
-              <a:defRPr sz="2800">
+              <a:t>Pair 1: The Formal Foundation</a:t>
+            </a:r>
+          </a:p>
+        </p:txBody>
+      </p:sp>
+      <p:sp>
+        <p:nvSpPr>
+          <p:cNvPr id="4" name="TextBox 3"/>
+          <p:cNvSpPr txBox="1"/>
+          <p:nvPr/>
+        </p:nvSpPr>
+        <p:spPr>
+          <a:xfrm>
+            <a:off x="1371600" y="2514600"/>
+            <a:ext cx="9902952" cy="1005840"/>
+          </a:xfrm>
+          <a:prstGeom prst="rect">
+            <a:avLst/>
+          </a:prstGeom>
+          <a:noFill/>
+        </p:spPr>
+        <p:txBody>
+          <a:bodyPr wrap="square">
+            <a:spAutoFit/>
+          </a:bodyPr>
+          <a:lstStyle/>
+          <a:p>
+            <a:pPr algn="l">
+              <a:defRPr sz="2200" b="0">
                 <a:solidFill>
                   <a:srgbClr val="F0F0F0"/>
                 </a:solidFill>
@@ -4206,12 +4744,35 @@
               </a:defRPr>
             </a:pPr>
             <a:r>
-              <a:t>Pair 1: The Formal Foundation</a:t>
-            </a:r>
-          </a:p>
-          <a:p>
-            <a:pPr lvl="1">
-              <a:defRPr sz="2400">
+              <a:t>• Paper 1 (Computability): Intelligence as an open-ended limiting process at the outer boundary of what can be mechanized</a:t>
+            </a:r>
+          </a:p>
+        </p:txBody>
+      </p:sp>
+      <p:sp>
+        <p:nvSpPr>
+          <p:cNvPr id="5" name="TextBox 4"/>
+          <p:cNvSpPr txBox="1"/>
+          <p:nvPr/>
+        </p:nvSpPr>
+        <p:spPr>
+          <a:xfrm>
+            <a:off x="1371600" y="3611880"/>
+            <a:ext cx="9902952" cy="1005840"/>
+          </a:xfrm>
+          <a:prstGeom prst="rect">
+            <a:avLst/>
+          </a:prstGeom>
+          <a:noFill/>
+        </p:spPr>
+        <p:txBody>
+          <a:bodyPr wrap="square">
+            <a:spAutoFit/>
+          </a:bodyPr>
+          <a:lstStyle/>
+          <a:p>
+            <a:pPr algn="l">
+              <a:defRPr sz="2200" b="0">
                 <a:solidFill>
                   <a:srgbClr val="F0F0F0"/>
                 </a:solidFill>
@@ -4219,12 +4780,71 @@
               </a:defRPr>
             </a:pPr>
             <a:r>
-              <a:t>Paper 1 (Computability): Intelligence as an open-ended limiting process at the outer boundary of what can be mechanized</a:t>
-            </a:r>
-          </a:p>
-          <a:p>
-            <a:pPr lvl="1">
-              <a:defRPr sz="2400">
+              <a:t>• Paper 2 (Complexity): Intelligence as a staged bounded ascent at the inner boundary of polynomial-time reachability</a:t>
+            </a:r>
+          </a:p>
+        </p:txBody>
+      </p:sp>
+      <p:sp>
+        <p:nvSpPr>
+          <p:cNvPr id="6" name="TextBox 5"/>
+          <p:cNvSpPr txBox="1"/>
+          <p:nvPr/>
+        </p:nvSpPr>
+        <p:spPr>
+          <a:xfrm>
+            <a:off x="731520" y="4709160"/>
+            <a:ext cx="10543032" cy="777240"/>
+          </a:xfrm>
+          <a:prstGeom prst="rect">
+            <a:avLst/>
+          </a:prstGeom>
+          <a:noFill/>
+        </p:spPr>
+        <p:txBody>
+          <a:bodyPr wrap="square">
+            <a:spAutoFit/>
+          </a:bodyPr>
+          <a:lstStyle/>
+          <a:p>
+            <a:pPr algn="l">
+              <a:defRPr sz="2600" b="1">
+                <a:solidFill>
+                  <a:srgbClr val="FFD700"/>
+                </a:solidFill>
+                <a:latin typeface="Arial"/>
+              </a:defRPr>
+            </a:pPr>
+            <a:r>
+              <a:t>Pair 2: The Empirical and Architectural Bridge</a:t>
+            </a:r>
+          </a:p>
+        </p:txBody>
+      </p:sp>
+      <p:sp>
+        <p:nvSpPr>
+          <p:cNvPr id="7" name="TextBox 6"/>
+          <p:cNvSpPr txBox="1"/>
+          <p:nvPr/>
+        </p:nvSpPr>
+        <p:spPr>
+          <a:xfrm>
+            <a:off x="1371600" y="5577840"/>
+            <a:ext cx="9902952" cy="1005840"/>
+          </a:xfrm>
+          <a:prstGeom prst="rect">
+            <a:avLst/>
+          </a:prstGeom>
+          <a:noFill/>
+        </p:spPr>
+        <p:txBody>
+          <a:bodyPr wrap="square">
+            <a:spAutoFit/>
+          </a:bodyPr>
+          <a:lstStyle/>
+          <a:p>
+            <a:pPr algn="l">
+              <a:defRPr sz="2200" b="0">
                 <a:solidFill>
                   <a:srgbClr val="F0F0F0"/>
                 </a:solidFill>
@@ -4232,12 +4852,35 @@
               </a:defRPr>
             </a:pPr>
             <a:r>
-              <a:t>Paper 2 (Complexity): Intelligence as a staged bounded ascent at the inner boundary of polynomial-time reachability</a:t>
-            </a:r>
-          </a:p>
-          <a:p>
-            <a:pPr>
-              <a:defRPr sz="2800">
+              <a:t>• Paper 3 (Scaling Laws): How abstract scaling drives progress and enforces a race for hidden efficiency</a:t>
+            </a:r>
+          </a:p>
+        </p:txBody>
+      </p:sp>
+      <p:sp>
+        <p:nvSpPr>
+          <p:cNvPr id="8" name="TextBox 7"/>
+          <p:cNvSpPr txBox="1"/>
+          <p:nvPr/>
+        </p:nvSpPr>
+        <p:spPr>
+          <a:xfrm>
+            <a:off x="1371600" y="6675120"/>
+            <a:ext cx="9902952" cy="1005840"/>
+          </a:xfrm>
+          <a:prstGeom prst="rect">
+            <a:avLst/>
+          </a:prstGeom>
+          <a:noFill/>
+        </p:spPr>
+        <p:txBody>
+          <a:bodyPr wrap="square">
+            <a:spAutoFit/>
+          </a:bodyPr>
+          <a:lstStyle/>
+          <a:p>
+            <a:pPr algn="l">
+              <a:defRPr sz="2200" b="0">
                 <a:solidFill>
                   <a:srgbClr val="F0F0F0"/>
                 </a:solidFill>
@@ -4245,33 +4888,7 @@
               </a:defRPr>
             </a:pPr>
             <a:r>
-              <a:t>Pair 2: The Empirical and Architectural Bridge</a:t>
-            </a:r>
-          </a:p>
-          <a:p>
-            <a:pPr lvl="1">
-              <a:defRPr sz="2400">
-                <a:solidFill>
-                  <a:srgbClr val="F0F0F0"/>
-                </a:solidFill>
-                <a:latin typeface="Arial"/>
-              </a:defRPr>
-            </a:pPr>
-            <a:r>
-              <a:t>Paper 3 (Scaling Laws): How abstract scaling drives progress and enforces a race for hidden efficiency</a:t>
-            </a:r>
-          </a:p>
-          <a:p>
-            <a:pPr lvl="1">
-              <a:defRPr sz="2400">
-                <a:solidFill>
-                  <a:srgbClr val="F0F0F0"/>
-                </a:solidFill>
-                <a:latin typeface="Arial"/>
-              </a:defRPr>
-            </a:pPr>
-            <a:r>
-              <a:t>Paper 4 (Modernized Amdahl): How the pressure of scaling reshapes the hardware allocation between specialized and programmable compute</a:t>
+              <a:t>• Paper 4 (Modernized Amdahl): How the pressure of scaling reshapes the hardware allocation between specialized and programmable compute</a:t>
             </a:r>
           </a:p>
         </p:txBody>
@@ -4290,7 +4907,7 @@
     <p:bg>
       <p:bgPr>
         <a:solidFill>
-          <a:srgbClr val="141E30"/>
+          <a:srgbClr val="0A1929"/>
         </a:solidFill>
         <a:effectLst/>
       </p:bgPr>
@@ -4304,23 +4921,30 @@
       <p:grpSpPr/>
       <p:sp>
         <p:nvSpPr>
-          <p:cNvPr id="2" name="Title 1"/>
-          <p:cNvSpPr>
-            <a:spLocks noGrp="1"/>
-          </p:cNvSpPr>
-          <p:nvPr>
-            <p:ph type="title"/>
-          </p:nvPr>
-        </p:nvSpPr>
-        <p:spPr/>
-        <p:txBody>
-          <a:bodyPr/>
-          <a:lstStyle/>
-          <a:p>
-            <a:pPr>
-              <a:defRPr b="1" sz="4000">
-                <a:solidFill>
-                  <a:srgbClr val="FFD700"/>
+          <p:cNvPr id="2" name="TextBox 1"/>
+          <p:cNvSpPr txBox="1"/>
+          <p:nvPr/>
+        </p:nvSpPr>
+        <p:spPr>
+          <a:xfrm>
+            <a:off x="731520" y="457200"/>
+            <a:ext cx="10725912" cy="914400"/>
+          </a:xfrm>
+          <a:prstGeom prst="rect">
+            <a:avLst/>
+          </a:prstGeom>
+          <a:noFill/>
+        </p:spPr>
+        <p:txBody>
+          <a:bodyPr wrap="square">
+            <a:spAutoFit/>
+          </a:bodyPr>
+          <a:lstStyle/>
+          <a:p>
+            <a:pPr algn="l">
+              <a:defRPr sz="3600" b="1">
+                <a:solidFill>
+                  <a:srgbClr val="00FFFF"/>
                 </a:solidFill>
                 <a:latin typeface="Arial"/>
               </a:defRPr>
@@ -4333,21 +4957,28 @@
       </p:sp>
       <p:sp>
         <p:nvSpPr>
-          <p:cNvPr id="3" name="Content Placeholder 2"/>
-          <p:cNvSpPr>
-            <a:spLocks noGrp="1"/>
-          </p:cNvSpPr>
-          <p:nvPr>
-            <p:ph idx="1"/>
-          </p:nvPr>
-        </p:nvSpPr>
-        <p:spPr/>
-        <p:txBody>
-          <a:bodyPr wrap="square"/>
-          <a:lstStyle/>
-          <a:p>
-            <a:pPr>
-              <a:defRPr sz="2800">
+          <p:cNvPr id="3" name="TextBox 2"/>
+          <p:cNvSpPr txBox="1"/>
+          <p:nvPr/>
+        </p:nvSpPr>
+        <p:spPr>
+          <a:xfrm>
+            <a:off x="1097280" y="1645920"/>
+            <a:ext cx="10177272" cy="1005840"/>
+          </a:xfrm>
+          <a:prstGeom prst="rect">
+            <a:avLst/>
+          </a:prstGeom>
+          <a:noFill/>
+        </p:spPr>
+        <p:txBody>
+          <a:bodyPr wrap="square">
+            <a:spAutoFit/>
+          </a:bodyPr>
+          <a:lstStyle/>
+          <a:p>
+            <a:pPr algn="l">
+              <a:defRPr sz="2400" b="0">
                 <a:solidFill>
                   <a:srgbClr val="F0F0F0"/>
                 </a:solidFill>
@@ -4355,12 +4986,35 @@
               </a:defRPr>
             </a:pPr>
             <a:r>
-              <a:t>Beyond a Fixed Closure: Intelligence is not one finitely specifiable, fixed rule-governed procedure</a:t>
-            </a:r>
-          </a:p>
-          <a:p>
-            <a:pPr>
-              <a:defRPr sz="2800">
+              <a:t>• Beyond a Fixed Closure: Intelligence is not one finitely specifiable, fixed rule-governed procedure</a:t>
+            </a:r>
+          </a:p>
+        </p:txBody>
+      </p:sp>
+      <p:sp>
+        <p:nvSpPr>
+          <p:cNvPr id="4" name="TextBox 3"/>
+          <p:cNvSpPr txBox="1"/>
+          <p:nvPr/>
+        </p:nvSpPr>
+        <p:spPr>
+          <a:xfrm>
+            <a:off x="1097280" y="2743200"/>
+            <a:ext cx="10177272" cy="1417320"/>
+          </a:xfrm>
+          <a:prstGeom prst="rect">
+            <a:avLst/>
+          </a:prstGeom>
+          <a:noFill/>
+        </p:spPr>
+        <p:txBody>
+          <a:bodyPr wrap="square">
+            <a:spAutoFit/>
+          </a:bodyPr>
+          <a:lstStyle/>
+          <a:p>
+            <a:pPr algn="l">
+              <a:defRPr sz="2400" b="0">
                 <a:solidFill>
                   <a:srgbClr val="F0F0F0"/>
                 </a:solidFill>
@@ -4368,12 +5022,35 @@
               </a:defRPr>
             </a:pPr>
             <a:r>
-              <a:t>The Limiting-Process Structure: When a process is mechanized, the higher-order task of guiding, specifying, and evaluating that mechanization is displaced upward to a new level</a:t>
-            </a:r>
-          </a:p>
-          <a:p>
-            <a:pPr>
-              <a:defRPr sz="2800">
+              <a:t>• The Limiting-Process Structure: When a process is mechanized, the higher-order task of guiding, specifying, and evaluating that mechanization is displaced upward to a new level</a:t>
+            </a:r>
+          </a:p>
+        </p:txBody>
+      </p:sp>
+      <p:sp>
+        <p:nvSpPr>
+          <p:cNvPr id="5" name="TextBox 4"/>
+          <p:cNvSpPr txBox="1"/>
+          <p:nvPr/>
+        </p:nvSpPr>
+        <p:spPr>
+          <a:xfrm>
+            <a:off x="1097280" y="4251960"/>
+            <a:ext cx="10177272" cy="1417320"/>
+          </a:xfrm>
+          <a:prstGeom prst="rect">
+            <a:avLst/>
+          </a:prstGeom>
+          <a:noFill/>
+        </p:spPr>
+        <p:txBody>
+          <a:bodyPr wrap="square">
+            <a:spAutoFit/>
+          </a:bodyPr>
+          <a:lstStyle/>
+          <a:p>
+            <a:pPr algn="l">
+              <a:defRPr sz="2400" b="0">
                 <a:solidFill>
                   <a:srgbClr val="F0F0F0"/>
                 </a:solidFill>
@@ -4381,7 +5058,7 @@
               </a:defRPr>
             </a:pPr>
             <a:r>
-              <a:t>Local Mechanization vs. Open Boundary: Every established, mechanized computational layer possesses a canonical, relatively uncomputable open boundary</a:t>
+              <a:t>• Local Mechanization vs. Open Boundary: Every established, mechanized computational layer possesses a canonical, relatively uncomputable open boundary</a:t>
             </a:r>
           </a:p>
         </p:txBody>
@@ -4400,7 +5077,7 @@
     <p:bg>
       <p:bgPr>
         <a:solidFill>
-          <a:srgbClr val="141E30"/>
+          <a:srgbClr val="0A1929"/>
         </a:solidFill>
         <a:effectLst/>
       </p:bgPr>
@@ -4414,21 +5091,64 @@
       <p:grpSpPr/>
       <p:sp>
         <p:nvSpPr>
-          <p:cNvPr id="2" name="Title 1"/>
-          <p:cNvSpPr>
-            <a:spLocks noGrp="1"/>
-          </p:cNvSpPr>
-          <p:nvPr>
-            <p:ph type="title"/>
-          </p:nvPr>
-        </p:nvSpPr>
-        <p:spPr/>
-        <p:txBody>
-          <a:bodyPr/>
-          <a:lstStyle/>
-          <a:p>
-            <a:pPr>
-              <a:defRPr b="1" sz="4000">
+          <p:cNvPr id="2" name="TextBox 1"/>
+          <p:cNvSpPr txBox="1"/>
+          <p:nvPr/>
+        </p:nvSpPr>
+        <p:spPr>
+          <a:xfrm>
+            <a:off x="731520" y="457200"/>
+            <a:ext cx="10725912" cy="914400"/>
+          </a:xfrm>
+          <a:prstGeom prst="rect">
+            <a:avLst/>
+          </a:prstGeom>
+          <a:noFill/>
+        </p:spPr>
+        <p:txBody>
+          <a:bodyPr wrap="square">
+            <a:spAutoFit/>
+          </a:bodyPr>
+          <a:lstStyle/>
+          <a:p>
+            <a:pPr algn="l">
+              <a:defRPr sz="3600" b="1">
+                <a:solidFill>
+                  <a:srgbClr val="00FFFF"/>
+                </a:solidFill>
+                <a:latin typeface="Arial"/>
+              </a:defRPr>
+            </a:pPr>
+            <a:r>
+              <a:t>Paper 1: The Mechanics of Ascent</a:t>
+            </a:r>
+          </a:p>
+        </p:txBody>
+      </p:sp>
+      <p:sp>
+        <p:nvSpPr>
+          <p:cNvPr id="3" name="TextBox 2"/>
+          <p:cNvSpPr txBox="1"/>
+          <p:nvPr/>
+        </p:nvSpPr>
+        <p:spPr>
+          <a:xfrm>
+            <a:off x="914400" y="1645920"/>
+            <a:ext cx="10360152" cy="1325880"/>
+          </a:xfrm>
+          <a:prstGeom prst="rect">
+            <a:avLst/>
+          </a:prstGeom>
+          <a:noFill/>
+        </p:spPr>
+        <p:txBody>
+          <a:bodyPr wrap="square">
+            <a:spAutoFit/>
+          </a:bodyPr>
+          <a:lstStyle/>
+          <a:p>
+            <a:pPr algn="l">
+              <a:defRPr sz="2000" b="1">
                 <a:solidFill>
                   <a:srgbClr val="FFD700"/>
                 </a:solidFill>
@@ -4436,41 +5156,35 @@
               </a:defRPr>
             </a:pPr>
             <a:r>
-              <a:t>Paper 1: The Mechanics of Ascent</a:t>
-            </a:r>
-          </a:p>
-        </p:txBody>
-      </p:sp>
-      <p:sp>
-        <p:nvSpPr>
-          <p:cNvPr id="3" name="Content Placeholder 2"/>
-          <p:cNvSpPr>
-            <a:spLocks noGrp="1"/>
-          </p:cNvSpPr>
-          <p:nvPr>
-            <p:ph idx="1"/>
-          </p:nvPr>
-        </p:nvSpPr>
-        <p:spPr/>
-        <p:txBody>
-          <a:bodyPr wrap="square"/>
-          <a:lstStyle/>
-          <a:p>
-            <a:pPr lvl="1">
-              <a:defRPr i="1" sz="2000">
-                <a:solidFill>
-                  <a:srgbClr val="6496FF"/>
-                </a:solidFill>
-                <a:latin typeface="Arial"/>
-              </a:defRPr>
-            </a:pPr>
-            <a:r>
               <a:t>[Visual Concept: A blueprint-style diagram showing a foundational layer A_n, ascending through an intermediate step, toward an open ceiling A'_n]</a:t>
             </a:r>
           </a:p>
-          <a:p>
-            <a:pPr>
-              <a:defRPr sz="2800">
+        </p:txBody>
+      </p:sp>
+      <p:sp>
+        <p:nvSpPr>
+          <p:cNvPr id="4" name="TextBox 3"/>
+          <p:cNvSpPr txBox="1"/>
+          <p:nvPr/>
+        </p:nvSpPr>
+        <p:spPr>
+          <a:xfrm>
+            <a:off x="1097280" y="3063240"/>
+            <a:ext cx="10177272" cy="1005840"/>
+          </a:xfrm>
+          <a:prstGeom prst="rect">
+            <a:avLst/>
+          </a:prstGeom>
+          <a:noFill/>
+        </p:spPr>
+        <p:txBody>
+          <a:bodyPr wrap="square">
+            <a:spAutoFit/>
+          </a:bodyPr>
+          <a:lstStyle/>
+          <a:p>
+            <a:pPr algn="l">
+              <a:defRPr sz="2400" b="0">
                 <a:solidFill>
                   <a:srgbClr val="F0F0F0"/>
                 </a:solidFill>
@@ -4478,12 +5192,35 @@
               </a:defRPr>
             </a:pPr>
             <a:r>
-              <a:t>The Turing Jump as a Ceiling: The absolute boundary of any mechanized layer is its Turing jump (A')</a:t>
-            </a:r>
-          </a:p>
-          <a:p>
-            <a:pPr>
-              <a:defRPr sz="2800">
+              <a:t>• The Turing Jump as a Ceiling: The absolute boundary of any mechanized layer is its Turing jump (A')</a:t>
+            </a:r>
+          </a:p>
+        </p:txBody>
+      </p:sp>
+      <p:sp>
+        <p:nvSpPr>
+          <p:cNvPr id="5" name="TextBox 4"/>
+          <p:cNvSpPr txBox="1"/>
+          <p:nvPr/>
+        </p:nvSpPr>
+        <p:spPr>
+          <a:xfrm>
+            <a:off x="1097280" y="4160520"/>
+            <a:ext cx="10177272" cy="1417320"/>
+          </a:xfrm>
+          <a:prstGeom prst="rect">
+            <a:avLst/>
+          </a:prstGeom>
+          <a:noFill/>
+        </p:spPr>
+        <p:txBody>
+          <a:bodyPr wrap="square">
+            <a:spAutoFit/>
+          </a:bodyPr>
+          <a:lstStyle/>
+          <a:p>
+            <a:pPr algn="l">
+              <a:defRPr sz="2400" b="0">
                 <a:solidFill>
                   <a:srgbClr val="F0F0F0"/>
                 </a:solidFill>
@@ -4491,12 +5228,35 @@
               </a:defRPr>
             </a:pPr>
             <a:r>
-              <a:t>Progressive Layers: Real progress occurs through intermediate strengthenings (A &lt;_T B &lt;_T A'), mechanizing steps strictly below the absolute jump</a:t>
-            </a:r>
-          </a:p>
-          <a:p>
-            <a:pPr>
-              <a:defRPr sz="2800">
+              <a:t>• Progressive Layers: Real progress occurs through intermediate strengthenings (A &lt;_T B &lt;_T A'), mechanizing steps strictly below the absolute jump</a:t>
+            </a:r>
+          </a:p>
+        </p:txBody>
+      </p:sp>
+      <p:sp>
+        <p:nvSpPr>
+          <p:cNvPr id="6" name="TextBox 5"/>
+          <p:cNvSpPr txBox="1"/>
+          <p:nvPr/>
+        </p:nvSpPr>
+        <p:spPr>
+          <a:xfrm>
+            <a:off x="1097280" y="5669280"/>
+            <a:ext cx="10177272" cy="1005840"/>
+          </a:xfrm>
+          <a:prstGeom prst="rect">
+            <a:avLst/>
+          </a:prstGeom>
+          <a:noFill/>
+        </p:spPr>
+        <p:txBody>
+          <a:bodyPr wrap="square">
+            <a:spAutoFit/>
+          </a:bodyPr>
+          <a:lstStyle/>
+          <a:p>
+            <a:pPr algn="l">
+              <a:defRPr sz="2400" b="0">
                 <a:solidFill>
                   <a:srgbClr val="F0F0F0"/>
                 </a:solidFill>
@@ -4504,7 +5264,7 @@
               </a:defRPr>
             </a:pPr>
             <a:r>
-              <a:t>Non-Capture: No single settled layer captures the entire open-ended process of intelligence</a:t>
+              <a:t>• Non-Capture: No single settled layer captures the entire open-ended process of intelligence</a:t>
             </a:r>
           </a:p>
         </p:txBody>
@@ -4523,7 +5283,7 @@
     <p:bg>
       <p:bgPr>
         <a:solidFill>
-          <a:srgbClr val="141E30"/>
+          <a:srgbClr val="0A1929"/>
         </a:solidFill>
         <a:effectLst/>
       </p:bgPr>
@@ -4537,23 +5297,30 @@
       <p:grpSpPr/>
       <p:sp>
         <p:nvSpPr>
-          <p:cNvPr id="2" name="Title 1"/>
-          <p:cNvSpPr>
-            <a:spLocks noGrp="1"/>
-          </p:cNvSpPr>
-          <p:nvPr>
-            <p:ph type="title"/>
-          </p:nvPr>
-        </p:nvSpPr>
-        <p:spPr/>
-        <p:txBody>
-          <a:bodyPr/>
-          <a:lstStyle/>
-          <a:p>
-            <a:pPr>
-              <a:defRPr b="1" sz="4000">
-                <a:solidFill>
-                  <a:srgbClr val="FFD700"/>
+          <p:cNvPr id="2" name="TextBox 1"/>
+          <p:cNvSpPr txBox="1"/>
+          <p:nvPr/>
+        </p:nvSpPr>
+        <p:spPr>
+          <a:xfrm>
+            <a:off x="731520" y="457200"/>
+            <a:ext cx="10725912" cy="914400"/>
+          </a:xfrm>
+          <a:prstGeom prst="rect">
+            <a:avLst/>
+          </a:prstGeom>
+          <a:noFill/>
+        </p:spPr>
+        <p:txBody>
+          <a:bodyPr wrap="square">
+            <a:spAutoFit/>
+          </a:bodyPr>
+          <a:lstStyle/>
+          <a:p>
+            <a:pPr algn="l">
+              <a:defRPr sz="3600" b="1">
+                <a:solidFill>
+                  <a:srgbClr val="00FFFF"/>
                 </a:solidFill>
                 <a:latin typeface="Arial"/>
               </a:defRPr>
@@ -4566,21 +5333,28 @@
       </p:sp>
       <p:sp>
         <p:nvSpPr>
-          <p:cNvPr id="3" name="Content Placeholder 2"/>
-          <p:cNvSpPr>
-            <a:spLocks noGrp="1"/>
-          </p:cNvSpPr>
-          <p:nvPr>
-            <p:ph idx="1"/>
-          </p:nvPr>
-        </p:nvSpPr>
-        <p:spPr/>
-        <p:txBody>
-          <a:bodyPr wrap="square"/>
-          <a:lstStyle/>
-          <a:p>
-            <a:pPr>
-              <a:defRPr sz="2800">
+          <p:cNvPr id="3" name="TextBox 2"/>
+          <p:cNvSpPr txBox="1"/>
+          <p:nvPr/>
+        </p:nvSpPr>
+        <p:spPr>
+          <a:xfrm>
+            <a:off x="1097280" y="1645920"/>
+            <a:ext cx="10177272" cy="1005840"/>
+          </a:xfrm>
+          <a:prstGeom prst="rect">
+            <a:avLst/>
+          </a:prstGeom>
+          <a:noFill/>
+        </p:spPr>
+        <p:txBody>
+          <a:bodyPr wrap="square">
+            <a:spAutoFit/>
+          </a:bodyPr>
+          <a:lstStyle/>
+          <a:p>
+            <a:pPr algn="l">
+              <a:defRPr sz="2400" b="0">
                 <a:solidFill>
                   <a:srgbClr val="F0F0F0"/>
                 </a:solidFill>
@@ -4588,12 +5362,35 @@
               </a:defRPr>
             </a:pPr>
             <a:r>
-              <a:t>Redefining Feasibility: The practical reach of intelligence is not a binary “P = NP or nothing” scenario</a:t>
-            </a:r>
-          </a:p>
-          <a:p>
-            <a:pPr>
-              <a:defRPr sz="2800">
+              <a:t>• Redefining Feasibility: The practical reach of intelligence is not a binary “P = NP or nothing” scenario</a:t>
+            </a:r>
+          </a:p>
+        </p:txBody>
+      </p:sp>
+      <p:sp>
+        <p:nvSpPr>
+          <p:cNvPr id="4" name="TextBox 3"/>
+          <p:cNvSpPr txBox="1"/>
+          <p:nvPr/>
+        </p:nvSpPr>
+        <p:spPr>
+          <a:xfrm>
+            <a:off x="1097280" y="2743200"/>
+            <a:ext cx="10177272" cy="1005840"/>
+          </a:xfrm>
+          <a:prstGeom prst="rect">
+            <a:avLst/>
+          </a:prstGeom>
+          <a:noFill/>
+        </p:spPr>
+        <p:txBody>
+          <a:bodyPr wrap="square">
+            <a:spAutoFit/>
+          </a:bodyPr>
+          <a:lstStyle/>
+          <a:p>
+            <a:pPr algn="l">
+              <a:defRPr sz="2400" b="0">
                 <a:solidFill>
                   <a:srgbClr val="F0F0F0"/>
                 </a:solidFill>
@@ -4601,12 +5398,35 @@
               </a:defRPr>
             </a:pPr>
             <a:r>
-              <a:t>Expanding Reachability: Progress manifests as progressively wider polynomial-time reach across difficult search tasks</a:t>
-            </a:r>
-          </a:p>
-          <a:p>
-            <a:pPr>
-              <a:defRPr sz="2800">
+              <a:t>• Expanding Reachability: Progress manifests as progressively wider polynomial-time reach across difficult search tasks</a:t>
+            </a:r>
+          </a:p>
+        </p:txBody>
+      </p:sp>
+      <p:sp>
+        <p:nvSpPr>
+          <p:cNvPr id="5" name="TextBox 4"/>
+          <p:cNvSpPr txBox="1"/>
+          <p:nvPr/>
+        </p:nvSpPr>
+        <p:spPr>
+          <a:xfrm>
+            <a:off x="1097280" y="3840480"/>
+            <a:ext cx="10177272" cy="1417320"/>
+          </a:xfrm>
+          <a:prstGeom prst="rect">
+            <a:avLst/>
+          </a:prstGeom>
+          <a:noFill/>
+        </p:spPr>
+        <p:txBody>
+          <a:bodyPr wrap="square">
+            <a:spAutoFit/>
+          </a:bodyPr>
+          <a:lstStyle/>
+          <a:p>
+            <a:pPr algn="l">
+              <a:defRPr sz="2400" b="0">
                 <a:solidFill>
                   <a:srgbClr val="F0F0F0"/>
                 </a:solidFill>
@@ -4614,7 +5434,7 @@
               </a:defRPr>
             </a:pPr>
             <a:r>
-              <a:t>Staged Bounded Ascent: Moving upward by internalizing richer structures of guided search while remaining feasible under strict polynomial-time constraints</a:t>
+              <a:t>• Staged Bounded Ascent: Moving upward by internalizing richer structures of guided search while remaining feasible under strict polynomial-time constraints</a:t>
             </a:r>
           </a:p>
         </p:txBody>
@@ -4633,7 +5453,7 @@
     <p:bg>
       <p:bgPr>
         <a:solidFill>
-          <a:srgbClr val="141E30"/>
+          <a:srgbClr val="0A1929"/>
         </a:solidFill>
         <a:effectLst/>
       </p:bgPr>
@@ -4647,21 +5467,64 @@
       <p:grpSpPr/>
       <p:sp>
         <p:nvSpPr>
-          <p:cNvPr id="2" name="Title 1"/>
-          <p:cNvSpPr>
-            <a:spLocks noGrp="1"/>
-          </p:cNvSpPr>
-          <p:nvPr>
-            <p:ph type="title"/>
-          </p:nvPr>
-        </p:nvSpPr>
-        <p:spPr/>
-        <p:txBody>
-          <a:bodyPr/>
-          <a:lstStyle/>
-          <a:p>
-            <a:pPr>
-              <a:defRPr b="1" sz="4000">
+          <p:cNvPr id="2" name="TextBox 1"/>
+          <p:cNvSpPr txBox="1"/>
+          <p:nvPr/>
+        </p:nvSpPr>
+        <p:spPr>
+          <a:xfrm>
+            <a:off x="731520" y="457200"/>
+            <a:ext cx="10725912" cy="914400"/>
+          </a:xfrm>
+          <a:prstGeom prst="rect">
+            <a:avLst/>
+          </a:prstGeom>
+          <a:noFill/>
+        </p:spPr>
+        <p:txBody>
+          <a:bodyPr wrap="square">
+            <a:spAutoFit/>
+          </a:bodyPr>
+          <a:lstStyle/>
+          <a:p>
+            <a:pPr algn="l">
+              <a:defRPr sz="3600" b="1">
+                <a:solidFill>
+                  <a:srgbClr val="00FFFF"/>
+                </a:solidFill>
+                <a:latin typeface="Arial"/>
+              </a:defRPr>
+            </a:pPr>
+            <a:r>
+              <a:t>Paper 2: The Polynomial Hierarchy as Limiting Process</a:t>
+            </a:r>
+          </a:p>
+        </p:txBody>
+      </p:sp>
+      <p:sp>
+        <p:nvSpPr>
+          <p:cNvPr id="3" name="TextBox 2"/>
+          <p:cNvSpPr txBox="1"/>
+          <p:nvPr/>
+        </p:nvSpPr>
+        <p:spPr>
+          <a:xfrm>
+            <a:off x="914400" y="1645920"/>
+            <a:ext cx="10360152" cy="914400"/>
+          </a:xfrm>
+          <a:prstGeom prst="rect">
+            <a:avLst/>
+          </a:prstGeom>
+          <a:noFill/>
+        </p:spPr>
+        <p:txBody>
+          <a:bodyPr wrap="square">
+            <a:spAutoFit/>
+          </a:bodyPr>
+          <a:lstStyle/>
+          <a:p>
+            <a:pPr algn="l">
+              <a:defRPr sz="2000" b="1">
                 <a:solidFill>
                   <a:srgbClr val="FFD700"/>
                 </a:solidFill>
@@ -4669,41 +5532,35 @@
               </a:defRPr>
             </a:pPr>
             <a:r>
-              <a:t>Paper 2: The Polynomial Hierarchy as Limiting Process</a:t>
-            </a:r>
-          </a:p>
-        </p:txBody>
-      </p:sp>
-      <p:sp>
-        <p:nvSpPr>
-          <p:cNvPr id="3" name="Content Placeholder 2"/>
-          <p:cNvSpPr>
-            <a:spLocks noGrp="1"/>
-          </p:cNvSpPr>
-          <p:nvPr>
-            <p:ph idx="1"/>
-          </p:nvPr>
-        </p:nvSpPr>
-        <p:spPr/>
-        <p:txBody>
-          <a:bodyPr wrap="square"/>
-          <a:lstStyle/>
-          <a:p>
-            <a:pPr lvl="1">
-              <a:defRPr i="1" sz="2000">
-                <a:solidFill>
-                  <a:srgbClr val="6496FF"/>
-                </a:solidFill>
-                <a:latin typeface="Arial"/>
-              </a:defRPr>
-            </a:pPr>
-            <a:r>
               <a:t>[Visual Concept: A finite-depth ladder expanding upward, showing P→NP→PH]</a:t>
             </a:r>
           </a:p>
-          <a:p>
-            <a:pPr>
-              <a:defRPr sz="2800">
+        </p:txBody>
+      </p:sp>
+      <p:sp>
+        <p:nvSpPr>
+          <p:cNvPr id="4" name="TextBox 3"/>
+          <p:cNvSpPr txBox="1"/>
+          <p:nvPr/>
+        </p:nvSpPr>
+        <p:spPr>
+          <a:xfrm>
+            <a:off x="1097280" y="2651760"/>
+            <a:ext cx="10177272" cy="1005840"/>
+          </a:xfrm>
+          <a:prstGeom prst="rect">
+            <a:avLst/>
+          </a:prstGeom>
+          <a:noFill/>
+        </p:spPr>
+        <p:txBody>
+          <a:bodyPr wrap="square">
+            <a:spAutoFit/>
+          </a:bodyPr>
+          <a:lstStyle/>
+          <a:p>
+            <a:pPr algn="l">
+              <a:defRPr sz="2400" b="0">
                 <a:solidFill>
                   <a:srgbClr val="F0F0F0"/>
                 </a:solidFill>
@@ -4711,12 +5568,35 @@
               </a:defRPr>
             </a:pPr>
             <a:r>
-              <a:t>Bounded Verification Games: The Polynomial Hierarchy provides a finite-depth ladder of structured proposal, challenge, and repair</a:t>
-            </a:r>
-          </a:p>
-          <a:p>
-            <a:pPr>
-              <a:defRPr sz="2800">
+              <a:t>• Bounded Verification Games: The Polynomial Hierarchy provides a finite-depth ladder of structured proposal, challenge, and repair</a:t>
+            </a:r>
+          </a:p>
+        </p:txBody>
+      </p:sp>
+      <p:sp>
+        <p:nvSpPr>
+          <p:cNvPr id="5" name="TextBox 4"/>
+          <p:cNvSpPr txBox="1"/>
+          <p:nvPr/>
+        </p:nvSpPr>
+        <p:spPr>
+          <a:xfrm>
+            <a:off x="1097280" y="3749040"/>
+            <a:ext cx="10177272" cy="1417320"/>
+          </a:xfrm>
+          <a:prstGeom prst="rect">
+            <a:avLst/>
+          </a:prstGeom>
+          <a:noFill/>
+        </p:spPr>
+        <p:txBody>
+          <a:bodyPr wrap="square">
+            <a:spAutoFit/>
+          </a:bodyPr>
+          <a:lstStyle/>
+          <a:p>
+            <a:pPr algn="l">
+              <a:defRPr sz="2400" b="0">
                 <a:solidFill>
                   <a:srgbClr val="F0F0F0"/>
                 </a:solidFill>
@@ -4724,7 +5604,7 @@
               </a:defRPr>
             </a:pPr>
             <a:r>
-              <a:t>Internalizing Search: Moving up the hierarchy allows a system to absorb what was previously external search into a stronger—but still explicitly bounded—verification framework</a:t>
+              <a:t>• Internalizing Search: Moving up the hierarchy allows a system to absorb what was previously external search into a stronger—but still explicitly bounded—verification framework</a:t>
             </a:r>
           </a:p>
         </p:txBody>
@@ -4743,7 +5623,7 @@
     <p:bg>
       <p:bgPr>
         <a:solidFill>
-          <a:srgbClr val="141E30"/>
+          <a:srgbClr val="0A1929"/>
         </a:solidFill>
         <a:effectLst/>
       </p:bgPr>
@@ -4757,21 +5637,64 @@
       <p:grpSpPr/>
       <p:sp>
         <p:nvSpPr>
-          <p:cNvPr id="2" name="Title 1"/>
-          <p:cNvSpPr>
-            <a:spLocks noGrp="1"/>
-          </p:cNvSpPr>
-          <p:nvPr>
-            <p:ph type="title"/>
-          </p:nvPr>
-        </p:nvSpPr>
-        <p:spPr/>
-        <p:txBody>
-          <a:bodyPr/>
-          <a:lstStyle/>
-          <a:p>
-            <a:pPr>
-              <a:defRPr b="1" sz="4000">
+          <p:cNvPr id="2" name="TextBox 1"/>
+          <p:cNvSpPr txBox="1"/>
+          <p:nvPr/>
+        </p:nvSpPr>
+        <p:spPr>
+          <a:xfrm>
+            <a:off x="731520" y="457200"/>
+            <a:ext cx="10725912" cy="914400"/>
+          </a:xfrm>
+          <a:prstGeom prst="rect">
+            <a:avLst/>
+          </a:prstGeom>
+          <a:noFill/>
+        </p:spPr>
+        <p:txBody>
+          <a:bodyPr wrap="square">
+            <a:spAutoFit/>
+          </a:bodyPr>
+          <a:lstStyle/>
+          <a:p>
+            <a:pPr algn="l">
+              <a:defRPr sz="3600" b="1">
+                <a:solidFill>
+                  <a:srgbClr val="00FFFF"/>
+                </a:solidFill>
+                <a:latin typeface="Arial"/>
+              </a:defRPr>
+            </a:pPr>
+            <a:r>
+              <a:t>Synthesis of Pair 1: The Map of Formal Boundaries</a:t>
+            </a:r>
+          </a:p>
+        </p:txBody>
+      </p:sp>
+      <p:sp>
+        <p:nvSpPr>
+          <p:cNvPr id="3" name="TextBox 2"/>
+          <p:cNvSpPr txBox="1"/>
+          <p:nvPr/>
+        </p:nvSpPr>
+        <p:spPr>
+          <a:xfrm>
+            <a:off x="914400" y="1645920"/>
+            <a:ext cx="10360152" cy="914400"/>
+          </a:xfrm>
+          <a:prstGeom prst="rect">
+            <a:avLst/>
+          </a:prstGeom>
+          <a:noFill/>
+        </p:spPr>
+        <p:txBody>
+          <a:bodyPr wrap="square">
+            <a:spAutoFit/>
+          </a:bodyPr>
+          <a:lstStyle/>
+          <a:p>
+            <a:pPr algn="l">
+              <a:defRPr sz="2000" b="1">
                 <a:solidFill>
                   <a:srgbClr val="FFD700"/>
                 </a:solidFill>
@@ -4779,41 +5702,35 @@
               </a:defRPr>
             </a:pPr>
             <a:r>
-              <a:t>Synthesis of Pair 1: The Map of Formal Boundaries</a:t>
-            </a:r>
-          </a:p>
-        </p:txBody>
-      </p:sp>
-      <p:sp>
-        <p:nvSpPr>
-          <p:cNvPr id="3" name="Content Placeholder 2"/>
-          <p:cNvSpPr>
-            <a:spLocks noGrp="1"/>
-          </p:cNvSpPr>
-          <p:nvPr>
-            <p:ph idx="1"/>
-          </p:nvPr>
-        </p:nvSpPr>
-        <p:spPr/>
-        <p:txBody>
-          <a:bodyPr wrap="square"/>
-          <a:lstStyle/>
-          <a:p>
-            <a:pPr lvl="1">
-              <a:defRPr i="1" sz="2000">
-                <a:solidFill>
-                  <a:srgbClr val="6496FF"/>
-                </a:solidFill>
-                <a:latin typeface="Arial"/>
-              </a:defRPr>
-            </a:pPr>
-            <a:r>
               <a:t>[Visual Concept: A nested boundary map showing Well-defined tasks → Computable tasks → Polynomial-time tasks]</a:t>
             </a:r>
           </a:p>
-          <a:p>
-            <a:pPr>
-              <a:defRPr sz="2800">
+        </p:txBody>
+      </p:sp>
+      <p:sp>
+        <p:nvSpPr>
+          <p:cNvPr id="4" name="TextBox 3"/>
+          <p:cNvSpPr txBox="1"/>
+          <p:nvPr/>
+        </p:nvSpPr>
+        <p:spPr>
+          <a:xfrm>
+            <a:off x="1097280" y="2651760"/>
+            <a:ext cx="10177272" cy="1005840"/>
+          </a:xfrm>
+          <a:prstGeom prst="rect">
+            <a:avLst/>
+          </a:prstGeom>
+          <a:noFill/>
+        </p:spPr>
+        <p:txBody>
+          <a:bodyPr wrap="square">
+            <a:spAutoFit/>
+          </a:bodyPr>
+          <a:lstStyle/>
+          <a:p>
+            <a:pPr algn="l">
+              <a:defRPr sz="2400" b="0">
                 <a:solidFill>
                   <a:srgbClr val="F0F0F0"/>
                 </a:solidFill>
@@ -4821,12 +5738,35 @@
               </a:defRPr>
             </a:pPr>
             <a:r>
-              <a:t>The Outer Boundary (Computability): The divide between computable tasks and uncomputable, open-ended well-defined tasks</a:t>
-            </a:r>
-          </a:p>
-          <a:p>
-            <a:pPr>
-              <a:defRPr sz="2800">
+              <a:t>• The Outer Boundary (Computability): The divide between computable tasks and uncomputable, open-ended well-defined tasks</a:t>
+            </a:r>
+          </a:p>
+        </p:txBody>
+      </p:sp>
+      <p:sp>
+        <p:nvSpPr>
+          <p:cNvPr id="5" name="TextBox 4"/>
+          <p:cNvSpPr txBox="1"/>
+          <p:nvPr/>
+        </p:nvSpPr>
+        <p:spPr>
+          <a:xfrm>
+            <a:off x="1097280" y="3749040"/>
+            <a:ext cx="10177272" cy="1417320"/>
+          </a:xfrm>
+          <a:prstGeom prst="rect">
+            <a:avLst/>
+          </a:prstGeom>
+          <a:noFill/>
+        </p:spPr>
+        <p:txBody>
+          <a:bodyPr wrap="square">
+            <a:spAutoFit/>
+          </a:bodyPr>
+          <a:lstStyle/>
+          <a:p>
+            <a:pPr algn="l">
+              <a:defRPr sz="2400" b="0">
                 <a:solidFill>
                   <a:srgbClr val="F0F0F0"/>
                 </a:solidFill>
@@ -4834,7 +5774,7 @@
               </a:defRPr>
             </a:pPr>
             <a:r>
-              <a:t>The Inner Boundary (Feasibility): The divide between what is merely computable in principle and what is polynomial-time reachable in practice</a:t>
+              <a:t>• The Inner Boundary (Feasibility): The divide between what is merely computable in principle and what is polynomial-time reachable in practice</a:t>
             </a:r>
           </a:p>
         </p:txBody>
@@ -4853,7 +5793,7 @@
     <p:bg>
       <p:bgPr>
         <a:solidFill>
-          <a:srgbClr val="141E30"/>
+          <a:srgbClr val="0A1929"/>
         </a:solidFill>
         <a:effectLst/>
       </p:bgPr>
@@ -4867,23 +5807,30 @@
       <p:grpSpPr/>
       <p:sp>
         <p:nvSpPr>
-          <p:cNvPr id="2" name="Title 1"/>
-          <p:cNvSpPr>
-            <a:spLocks noGrp="1"/>
-          </p:cNvSpPr>
-          <p:nvPr>
-            <p:ph type="title"/>
-          </p:nvPr>
-        </p:nvSpPr>
-        <p:spPr/>
-        <p:txBody>
-          <a:bodyPr/>
-          <a:lstStyle/>
-          <a:p>
-            <a:pPr>
-              <a:defRPr b="1" sz="4000">
-                <a:solidFill>
-                  <a:srgbClr val="FFD700"/>
+          <p:cNvPr id="2" name="TextBox 1"/>
+          <p:cNvSpPr txBox="1"/>
+          <p:nvPr/>
+        </p:nvSpPr>
+        <p:spPr>
+          <a:xfrm>
+            <a:off x="731520" y="457200"/>
+            <a:ext cx="10725912" cy="914400"/>
+          </a:xfrm>
+          <a:prstGeom prst="rect">
+            <a:avLst/>
+          </a:prstGeom>
+          <a:noFill/>
+        </p:spPr>
+        <p:txBody>
+          <a:bodyPr wrap="square">
+            <a:spAutoFit/>
+          </a:bodyPr>
+          <a:lstStyle/>
+          <a:p>
+            <a:pPr algn="l">
+              <a:defRPr sz="3600" b="1">
+                <a:solidFill>
+                  <a:srgbClr val="00FFFF"/>
                 </a:solidFill>
                 <a:latin typeface="Arial"/>
               </a:defRPr>
@@ -4896,21 +5843,28 @@
       </p:sp>
       <p:sp>
         <p:nvSpPr>
-          <p:cNvPr id="3" name="Content Placeholder 2"/>
-          <p:cNvSpPr>
-            <a:spLocks noGrp="1"/>
-          </p:cNvSpPr>
-          <p:nvPr>
-            <p:ph idx="1"/>
-          </p:nvPr>
-        </p:nvSpPr>
-        <p:spPr/>
-        <p:txBody>
-          <a:bodyPr wrap="square"/>
-          <a:lstStyle/>
-          <a:p>
-            <a:pPr>
-              <a:defRPr sz="2800">
+          <p:cNvPr id="3" name="TextBox 2"/>
+          <p:cNvSpPr txBox="1"/>
+          <p:nvPr/>
+        </p:nvSpPr>
+        <p:spPr>
+          <a:xfrm>
+            <a:off x="1097280" y="1645920"/>
+            <a:ext cx="10177272" cy="1005840"/>
+          </a:xfrm>
+          <a:prstGeom prst="rect">
+            <a:avLst/>
+          </a:prstGeom>
+          <a:noFill/>
+        </p:spPr>
+        <p:txBody>
+          <a:bodyPr wrap="square">
+            <a:spAutoFit/>
+          </a:bodyPr>
+          <a:lstStyle/>
+          <a:p>
+            <a:pPr algn="l">
+              <a:defRPr sz="2400" b="0">
                 <a:solidFill>
                   <a:srgbClr val="F0F0F0"/>
                 </a:solidFill>
@@ -4921,9 +5875,32 @@
               <a:t>The Transition: Pair 1 provides the formal structure, explaining exactly what progress means mathematically</a:t>
             </a:r>
           </a:p>
-          <a:p>
-            <a:pPr>
-              <a:defRPr sz="2800">
+        </p:txBody>
+      </p:sp>
+      <p:sp>
+        <p:nvSpPr>
+          <p:cNvPr id="4" name="TextBox 3"/>
+          <p:cNvSpPr txBox="1"/>
+          <p:nvPr/>
+        </p:nvSpPr>
+        <p:spPr>
+          <a:xfrm>
+            <a:off x="1097280" y="2743200"/>
+            <a:ext cx="10177272" cy="1005840"/>
+          </a:xfrm>
+          <a:prstGeom prst="rect">
+            <a:avLst/>
+          </a:prstGeom>
+          <a:noFill/>
+        </p:spPr>
+        <p:txBody>
+          <a:bodyPr wrap="square">
+            <a:spAutoFit/>
+          </a:bodyPr>
+          <a:lstStyle/>
+          <a:p>
+            <a:pPr algn="l">
+              <a:defRPr sz="2400" b="0">
                 <a:solidFill>
                   <a:srgbClr val="F0F0F0"/>
                 </a:solidFill>
@@ -4931,12 +5908,35 @@
               </a:defRPr>
             </a:pPr>
             <a:r>
-              <a:t>The Missing Engine: Formal limits alone do not explain why progress continually appears in real-world systems</a:t>
-            </a:r>
-          </a:p>
-          <a:p>
-            <a:pPr>
-              <a:defRPr sz="2800">
+              <a:t>• The Missing Engine: Formal limits alone do not explain why progress continually appears in real-world systems</a:t>
+            </a:r>
+          </a:p>
+        </p:txBody>
+      </p:sp>
+      <p:sp>
+        <p:nvSpPr>
+          <p:cNvPr id="5" name="TextBox 4"/>
+          <p:cNvSpPr txBox="1"/>
+          <p:nvPr/>
+        </p:nvSpPr>
+        <p:spPr>
+          <a:xfrm>
+            <a:off x="1097280" y="3840480"/>
+            <a:ext cx="10177272" cy="914400"/>
+          </a:xfrm>
+          <a:prstGeom prst="rect">
+            <a:avLst/>
+          </a:prstGeom>
+          <a:noFill/>
+        </p:spPr>
+        <p:txBody>
+          <a:bodyPr wrap="square">
+            <a:spAutoFit/>
+          </a:bodyPr>
+          <a:lstStyle/>
+          <a:p>
+            <a:pPr algn="l">
+              <a:defRPr sz="2400" b="0">
                 <a:solidFill>
                   <a:srgbClr val="F0F0F0"/>
                 </a:solidFill>
@@ -4944,7 +5944,7 @@
               </a:defRPr>
             </a:pPr>
             <a:r>
-              <a:t>We must bridge the gap between formal structure and empirical hardware realities</a:t>
+              <a:t>• We must bridge the gap between formal structure and empirical hardware realities</a:t>
             </a:r>
           </a:p>
         </p:txBody>

</xml_diff>

<commit_message>
Add native shape drawing logic for Visual Concepts
</commit_message>
<xml_diff>
--- a/The_AI_Progress_Blueprint.pptx
+++ b/The_AI_Progress_Blueprint.pptx
@@ -3417,14 +3417,314 @@
       </p:sp>
       <p:sp>
         <p:nvSpPr>
-          <p:cNvPr id="3" name="TextBox 2"/>
+          <p:cNvPr id="3" name="Rectangle 2"/>
+          <p:cNvSpPr/>
+          <p:nvPr/>
+        </p:nvSpPr>
+        <p:spPr>
+          <a:xfrm>
+            <a:off x="1828800" y="2103120"/>
+            <a:ext cx="2743200" cy="914400"/>
+          </a:xfrm>
+          <a:prstGeom prst="rect">
+            <a:avLst/>
+          </a:prstGeom>
+          <a:solidFill>
+            <a:srgbClr val="0A1929"/>
+          </a:solidFill>
+          <a:ln w="25400">
+            <a:solidFill>
+              <a:srgbClr val="00FFFF"/>
+            </a:solidFill>
+          </a:ln>
+        </p:spPr>
+        <p:style>
+          <a:lnRef idx="1">
+            <a:schemeClr val="accent1"/>
+          </a:lnRef>
+          <a:fillRef idx="3">
+            <a:schemeClr val="accent1"/>
+          </a:fillRef>
+          <a:effectRef idx="2">
+            <a:schemeClr val="accent1"/>
+          </a:effectRef>
+          <a:fontRef idx="minor">
+            <a:schemeClr val="lt1"/>
+          </a:fontRef>
+        </p:style>
+        <p:txBody>
+          <a:bodyPr rtlCol="0" anchor="ctr" wrap="square"/>
+          <a:lstStyle/>
+          <a:p>
+            <a:pPr algn="ctr">
+              <a:defRPr sz="1600" b="1">
+                <a:solidFill>
+                  <a:srgbClr val="F0F0F0"/>
+                </a:solidFill>
+                <a:latin typeface="Arial"/>
+              </a:defRPr>
+            </a:pPr>
+            <a:r>
+              <a:t>Logical Compute Demand</a:t>
+            </a:r>
+          </a:p>
+        </p:txBody>
+      </p:sp>
+      <p:sp>
+        <p:nvSpPr>
+          <p:cNvPr id="4" name="Right Arrow 3"/>
+          <p:cNvSpPr/>
+          <p:nvPr/>
+        </p:nvSpPr>
+        <p:spPr>
+          <a:xfrm>
+            <a:off x="4754880" y="2377440"/>
+            <a:ext cx="731520" cy="365760"/>
+          </a:xfrm>
+          <a:prstGeom prst="rightArrow">
+            <a:avLst/>
+          </a:prstGeom>
+          <a:solidFill>
+            <a:srgbClr val="FFD700"/>
+          </a:solidFill>
+          <a:ln w="25400">
+            <a:solidFill>
+              <a:srgbClr val="FFD700"/>
+            </a:solidFill>
+          </a:ln>
+        </p:spPr>
+        <p:style>
+          <a:lnRef idx="1">
+            <a:schemeClr val="accent1"/>
+          </a:lnRef>
+          <a:fillRef idx="3">
+            <a:schemeClr val="accent1"/>
+          </a:fillRef>
+          <a:effectRef idx="2">
+            <a:schemeClr val="accent1"/>
+          </a:effectRef>
+          <a:fontRef idx="minor">
+            <a:schemeClr val="lt1"/>
+          </a:fontRef>
+        </p:style>
+        <p:txBody>
+          <a:bodyPr rtlCol="0" anchor="ctr"/>
+          <a:lstStyle/>
+          <a:p>
+            <a:pPr algn="ctr"/>
+          </a:p>
+        </p:txBody>
+      </p:sp>
+      <p:sp>
+        <p:nvSpPr>
+          <p:cNvPr id="5" name="Rectangle 4"/>
+          <p:cNvSpPr/>
+          <p:nvPr/>
+        </p:nvSpPr>
+        <p:spPr>
+          <a:xfrm>
+            <a:off x="5669280" y="2103120"/>
+            <a:ext cx="2286000" cy="914400"/>
+          </a:xfrm>
+          <a:prstGeom prst="rect">
+            <a:avLst/>
+          </a:prstGeom>
+          <a:solidFill>
+            <a:srgbClr val="0A1929"/>
+          </a:solidFill>
+          <a:ln w="25400">
+            <a:solidFill>
+              <a:srgbClr val="00FFFF"/>
+            </a:solidFill>
+          </a:ln>
+        </p:spPr>
+        <p:style>
+          <a:lnRef idx="1">
+            <a:schemeClr val="accent1"/>
+          </a:lnRef>
+          <a:fillRef idx="3">
+            <a:schemeClr val="accent1"/>
+          </a:fillRef>
+          <a:effectRef idx="2">
+            <a:schemeClr val="accent1"/>
+          </a:effectRef>
+          <a:fontRef idx="minor">
+            <a:schemeClr val="lt1"/>
+          </a:fontRef>
+        </p:style>
+        <p:txBody>
+          <a:bodyPr rtlCol="0" anchor="ctr" wrap="square"/>
+          <a:lstStyle/>
+          <a:p>
+            <a:pPr algn="ctr">
+              <a:defRPr sz="1600" b="1">
+                <a:solidFill>
+                  <a:srgbClr val="F0F0F0"/>
+                </a:solidFill>
+                <a:latin typeface="Arial"/>
+              </a:defRPr>
+            </a:pPr>
+            <a:r>
+              <a:t>Physical Burden</a:t>
+            </a:r>
+          </a:p>
+        </p:txBody>
+      </p:sp>
+      <p:sp>
+        <p:nvSpPr>
+          <p:cNvPr id="6" name="Right Arrow 5"/>
+          <p:cNvSpPr/>
+          <p:nvPr/>
+        </p:nvSpPr>
+        <p:spPr>
+          <a:xfrm>
+            <a:off x="8138160" y="2377440"/>
+            <a:ext cx="731520" cy="365760"/>
+          </a:xfrm>
+          <a:prstGeom prst="rightArrow">
+            <a:avLst/>
+          </a:prstGeom>
+          <a:solidFill>
+            <a:srgbClr val="FFD700"/>
+          </a:solidFill>
+          <a:ln w="25400">
+            <a:solidFill>
+              <a:srgbClr val="FFD700"/>
+            </a:solidFill>
+          </a:ln>
+        </p:spPr>
+        <p:style>
+          <a:lnRef idx="1">
+            <a:schemeClr val="accent1"/>
+          </a:lnRef>
+          <a:fillRef idx="3">
+            <a:schemeClr val="accent1"/>
+          </a:fillRef>
+          <a:effectRef idx="2">
+            <a:schemeClr val="accent1"/>
+          </a:effectRef>
+          <a:fontRef idx="minor">
+            <a:schemeClr val="lt1"/>
+          </a:fontRef>
+        </p:style>
+        <p:txBody>
+          <a:bodyPr rtlCol="0" anchor="ctr"/>
+          <a:lstStyle/>
+          <a:p>
+            <a:pPr algn="ctr"/>
+          </a:p>
+        </p:txBody>
+      </p:sp>
+      <p:sp>
+        <p:nvSpPr>
+          <p:cNvPr id="7" name="Rectangle 6"/>
+          <p:cNvSpPr/>
+          <p:nvPr/>
+        </p:nvSpPr>
+        <p:spPr>
+          <a:xfrm>
+            <a:off x="9052560" y="2103120"/>
+            <a:ext cx="2286000" cy="914400"/>
+          </a:xfrm>
+          <a:prstGeom prst="rect">
+            <a:avLst/>
+          </a:prstGeom>
+          <a:solidFill>
+            <a:srgbClr val="0A1929"/>
+          </a:solidFill>
+          <a:ln w="25400">
+            <a:solidFill>
+              <a:srgbClr val="00FFFF"/>
+            </a:solidFill>
+          </a:ln>
+        </p:spPr>
+        <p:style>
+          <a:lnRef idx="1">
+            <a:schemeClr val="accent1"/>
+          </a:lnRef>
+          <a:fillRef idx="3">
+            <a:schemeClr val="accent1"/>
+          </a:fillRef>
+          <a:effectRef idx="2">
+            <a:schemeClr val="accent1"/>
+          </a:effectRef>
+          <a:fontRef idx="minor">
+            <a:schemeClr val="lt1"/>
+          </a:fontRef>
+        </p:style>
+        <p:txBody>
+          <a:bodyPr rtlCol="0" anchor="ctr" wrap="square"/>
+          <a:lstStyle/>
+          <a:p>
+            <a:pPr algn="ctr">
+              <a:defRPr sz="1600" b="1">
+                <a:solidFill>
+                  <a:srgbClr val="F0F0F0"/>
+                </a:solidFill>
+                <a:latin typeface="Arial"/>
+              </a:defRPr>
+            </a:pPr>
+            <a:r>
+              <a:t>Efficiency Optimization</a:t>
+            </a:r>
+          </a:p>
+        </p:txBody>
+      </p:sp>
+      <p:sp>
+        <p:nvSpPr>
+          <p:cNvPr id="8" name="Left Arrow 7"/>
+          <p:cNvSpPr/>
+          <p:nvPr/>
+        </p:nvSpPr>
+        <p:spPr>
+          <a:xfrm>
+            <a:off x="3200400" y="3291840"/>
+            <a:ext cx="6858000" cy="274320"/>
+          </a:xfrm>
+          <a:prstGeom prst="leftArrow">
+            <a:avLst/>
+          </a:prstGeom>
+          <a:solidFill>
+            <a:srgbClr val="00FFFF"/>
+          </a:solidFill>
+          <a:ln>
+            <a:solidFill>
+              <a:srgbClr val="00FFFF"/>
+            </a:solidFill>
+          </a:ln>
+        </p:spPr>
+        <p:style>
+          <a:lnRef idx="1">
+            <a:schemeClr val="accent1"/>
+          </a:lnRef>
+          <a:fillRef idx="3">
+            <a:schemeClr val="accent1"/>
+          </a:fillRef>
+          <a:effectRef idx="2">
+            <a:schemeClr val="accent1"/>
+          </a:effectRef>
+          <a:fontRef idx="minor">
+            <a:schemeClr val="lt1"/>
+          </a:fontRef>
+        </p:style>
+        <p:txBody>
+          <a:bodyPr rtlCol="0" anchor="ctr"/>
+          <a:lstStyle/>
+          <a:p>
+            <a:pPr algn="ctr"/>
+          </a:p>
+        </p:txBody>
+      </p:sp>
+      <p:sp>
+        <p:nvSpPr>
+          <p:cNvPr id="9" name="TextBox 8"/>
           <p:cNvSpPr txBox="1"/>
           <p:nvPr/>
         </p:nvSpPr>
         <p:spPr>
           <a:xfrm>
-            <a:off x="914400" y="1645920"/>
-            <a:ext cx="10360152" cy="914400"/>
+            <a:off x="1097280" y="3931920"/>
+            <a:ext cx="10177272" cy="1417320"/>
           </a:xfrm>
           <a:prstGeom prst="rect">
             <a:avLst/>
@@ -3438,64 +3738,28 @@
           <a:lstStyle/>
           <a:p>
             <a:pPr algn="l">
-              <a:defRPr sz="2000" b="1">
-                <a:solidFill>
-                  <a:srgbClr val="FFD700"/>
-                </a:solidFill>
-                <a:latin typeface="Arial"/>
-              </a:defRPr>
-            </a:pPr>
-            <a:r>
-              <a:t>[Visual Concept: A pressure-conversion loop showing logical compute demand driving efficiency optimization across the stack]</a:t>
-            </a:r>
-          </a:p>
-        </p:txBody>
-      </p:sp>
-      <p:sp>
-        <p:nvSpPr>
-          <p:cNvPr id="4" name="TextBox 3"/>
+              <a:defRPr sz="2400" b="0">
+                <a:solidFill>
+                  <a:srgbClr val="F0F0F0"/>
+                </a:solidFill>
+                <a:latin typeface="Arial"/>
+              </a:defRPr>
+            </a:pPr>
+            <a:r>
+              <a:t>• The Efficiency Race: Progress persists because of repeated, compounding efficiency gains in algorithms, low-precision software, systems, and hardware</a:t>
+            </a:r>
+          </a:p>
+        </p:txBody>
+      </p:sp>
+      <p:sp>
+        <p:nvSpPr>
+          <p:cNvPr id="10" name="TextBox 9"/>
           <p:cNvSpPr txBox="1"/>
           <p:nvPr/>
         </p:nvSpPr>
         <p:spPr>
           <a:xfrm>
-            <a:off x="1097280" y="2651760"/>
-            <a:ext cx="10177272" cy="1417320"/>
-          </a:xfrm>
-          <a:prstGeom prst="rect">
-            <a:avLst/>
-          </a:prstGeom>
-          <a:noFill/>
-        </p:spPr>
-        <p:txBody>
-          <a:bodyPr wrap="square">
-            <a:spAutoFit/>
-          </a:bodyPr>
-          <a:lstStyle/>
-          <a:p>
-            <a:pPr algn="l">
-              <a:defRPr sz="2400" b="0">
-                <a:solidFill>
-                  <a:srgbClr val="F0F0F0"/>
-                </a:solidFill>
-                <a:latin typeface="Arial"/>
-              </a:defRPr>
-            </a:pPr>
-            <a:r>
-              <a:t>• The Efficiency Race: Progress persists because of repeated, compounding efficiency gains in algorithms, low-precision software, systems, and hardware</a:t>
-            </a:r>
-          </a:p>
-        </p:txBody>
-      </p:sp>
-      <p:sp>
-        <p:nvSpPr>
-          <p:cNvPr id="5" name="TextBox 4"/>
-          <p:cNvSpPr txBox="1"/>
-          <p:nvPr/>
-        </p:nvSpPr>
-        <p:spPr>
-          <a:xfrm>
-            <a:off x="1097280" y="4160520"/>
+            <a:off x="1097280" y="5440680"/>
             <a:ext cx="10177272" cy="1417320"/>
           </a:xfrm>
           <a:prstGeom prst="rect">
@@ -3757,14 +4021,52 @@
       </p:sp>
       <p:sp>
         <p:nvSpPr>
-          <p:cNvPr id="3" name="TextBox 2"/>
+          <p:cNvPr id="3" name="Up Arrow 2"/>
+          <p:cNvSpPr/>
+          <p:nvPr/>
+        </p:nvSpPr>
+        <p:spPr>
+          <a:xfrm>
+            <a:off x="1828800" y="1645920"/>
+            <a:ext cx="91440" cy="2286000"/>
+          </a:xfrm>
+          <a:prstGeom prst="upArrow">
+            <a:avLst/>
+          </a:prstGeom>
+          <a:solidFill/>
+        </p:spPr>
+        <p:style>
+          <a:lnRef idx="1">
+            <a:schemeClr val="accent1"/>
+          </a:lnRef>
+          <a:fillRef idx="3">
+            <a:schemeClr val="accent1"/>
+          </a:fillRef>
+          <a:effectRef idx="2">
+            <a:schemeClr val="accent1"/>
+          </a:effectRef>
+          <a:fontRef idx="minor">
+            <a:schemeClr val="lt1"/>
+          </a:fontRef>
+        </p:style>
+        <p:txBody>
+          <a:bodyPr rtlCol="0" anchor="ctr"/>
+          <a:lstStyle/>
+          <a:p>
+            <a:pPr algn="ctr"/>
+          </a:p>
+        </p:txBody>
+      </p:sp>
+      <p:sp>
+        <p:nvSpPr>
+          <p:cNvPr id="4" name="TextBox 3"/>
           <p:cNvSpPr txBox="1"/>
           <p:nvPr/>
         </p:nvSpPr>
         <p:spPr>
           <a:xfrm>
-            <a:off x="914400" y="1645920"/>
-            <a:ext cx="10360152" cy="914400"/>
+            <a:off x="91440" y="2103120"/>
+            <a:ext cx="1828800" cy="914400"/>
           </a:xfrm>
           <a:prstGeom prst="rect">
             <a:avLst/>
@@ -3778,7 +4080,7 @@
           <a:lstStyle/>
           <a:p>
             <a:pPr algn="l">
-              <a:defRPr sz="2000" b="1">
+              <a:defRPr sz="1400" b="0">
                 <a:solidFill>
                   <a:srgbClr val="FFD700"/>
                 </a:solidFill>
@@ -3786,21 +4088,59 @@
               </a:defRPr>
             </a:pPr>
             <a:r>
-              <a:t>[Visual Concept: A phase-boundary graph showing the race between Specialization Efficiency (R) and Scalable Fraction (S)]</a:t>
-            </a:r>
-          </a:p>
-        </p:txBody>
-      </p:sp>
-      <p:sp>
-        <p:nvSpPr>
-          <p:cNvPr id="4" name="TextBox 3"/>
+              <a:t>Specialization Efficiency (R)</a:t>
+            </a:r>
+          </a:p>
+        </p:txBody>
+      </p:sp>
+      <p:sp>
+        <p:nvSpPr>
+          <p:cNvPr id="5" name="Right Arrow 4"/>
+          <p:cNvSpPr/>
+          <p:nvPr/>
+        </p:nvSpPr>
+        <p:spPr>
+          <a:xfrm>
+            <a:off x="1828800" y="3931920"/>
+            <a:ext cx="5486400" cy="91440"/>
+          </a:xfrm>
+          <a:prstGeom prst="rightArrow">
+            <a:avLst/>
+          </a:prstGeom>
+          <a:solidFill/>
+        </p:spPr>
+        <p:style>
+          <a:lnRef idx="1">
+            <a:schemeClr val="accent1"/>
+          </a:lnRef>
+          <a:fillRef idx="3">
+            <a:schemeClr val="accent1"/>
+          </a:fillRef>
+          <a:effectRef idx="2">
+            <a:schemeClr val="accent1"/>
+          </a:effectRef>
+          <a:fontRef idx="minor">
+            <a:schemeClr val="lt1"/>
+          </a:fontRef>
+        </p:style>
+        <p:txBody>
+          <a:bodyPr rtlCol="0" anchor="ctr"/>
+          <a:lstStyle/>
+          <a:p>
+            <a:pPr algn="ctr"/>
+          </a:p>
+        </p:txBody>
+      </p:sp>
+      <p:sp>
+        <p:nvSpPr>
+          <p:cNvPr id="6" name="TextBox 5"/>
           <p:cNvSpPr txBox="1"/>
           <p:nvPr/>
         </p:nvSpPr>
         <p:spPr>
           <a:xfrm>
-            <a:off x="1097280" y="2651760"/>
-            <a:ext cx="10177272" cy="1005840"/>
+            <a:off x="3657600" y="4023360"/>
+            <a:ext cx="2743200" cy="457200"/>
           </a:xfrm>
           <a:prstGeom prst="rect">
             <a:avLst/>
@@ -3814,29 +4154,71 @@
           <a:lstStyle/>
           <a:p>
             <a:pPr algn="l">
-              <a:defRPr sz="2400" b="0">
-                <a:solidFill>
-                  <a:srgbClr val="F0F0F0"/>
-                </a:solidFill>
-                <a:latin typeface="Arial"/>
-              </a:defRPr>
-            </a:pPr>
-            <a:r>
-              <a:t>• The Rising Bar: As the value-scalable workload (S) grows, fixed-function specialization faces a strict collapse threshold</a:t>
-            </a:r>
-          </a:p>
-        </p:txBody>
-      </p:sp>
-      <p:sp>
-        <p:nvSpPr>
-          <p:cNvPr id="5" name="TextBox 4"/>
+              <a:defRPr sz="1400" b="0">
+                <a:solidFill>
+                  <a:srgbClr val="FFD700"/>
+                </a:solidFill>
+                <a:latin typeface="Arial"/>
+              </a:defRPr>
+            </a:pPr>
+            <a:r>
+              <a:t>Scalable Fraction (S)</a:t>
+            </a:r>
+          </a:p>
+        </p:txBody>
+      </p:sp>
+      <p:sp>
+        <p:nvSpPr>
+          <p:cNvPr id="7" name="Straight Connector 6"/>
+          <p:cNvSpPr/>
+          <p:nvPr/>
+        </p:nvSpPr>
+        <p:spPr>
+          <a:xfrm>
+            <a:off x="1828800" y="3931920"/>
+            <a:ext cx="4572000" cy="1828800"/>
+          </a:xfrm>
+          <a:prstGeom prst="lineInv">
+            <a:avLst/>
+          </a:prstGeom>
+          <a:ln w="50800">
+            <a:solidFill>
+              <a:srgbClr val="00FFFF"/>
+            </a:solidFill>
+          </a:ln>
+        </p:spPr>
+        <p:style>
+          <a:lnRef idx="1">
+            <a:schemeClr val="accent1"/>
+          </a:lnRef>
+          <a:fillRef idx="3">
+            <a:schemeClr val="accent1"/>
+          </a:fillRef>
+          <a:effectRef idx="2">
+            <a:schemeClr val="accent1"/>
+          </a:effectRef>
+          <a:fontRef idx="minor">
+            <a:schemeClr val="lt1"/>
+          </a:fontRef>
+        </p:style>
+        <p:txBody>
+          <a:bodyPr rtlCol="0" anchor="ctr"/>
+          <a:lstStyle/>
+          <a:p>
+            <a:pPr algn="ctr"/>
+          </a:p>
+        </p:txBody>
+      </p:sp>
+      <p:sp>
+        <p:nvSpPr>
+          <p:cNvPr id="8" name="TextBox 7"/>
           <p:cNvSpPr txBox="1"/>
           <p:nvPr/>
         </p:nvSpPr>
         <p:spPr>
           <a:xfrm>
-            <a:off x="1097280" y="3749040"/>
-            <a:ext cx="10177272" cy="1417320"/>
+            <a:off x="4572000" y="2103120"/>
+            <a:ext cx="3657600" cy="914400"/>
           </a:xfrm>
           <a:prstGeom prst="rect">
             <a:avLst/>
@@ -3850,6 +4232,42 @@
           <a:lstStyle/>
           <a:p>
             <a:pPr algn="l">
+              <a:defRPr sz="1800" b="1">
+                <a:solidFill>
+                  <a:srgbClr val="00FFFF"/>
+                </a:solidFill>
+                <a:latin typeface="Arial"/>
+              </a:defRPr>
+            </a:pPr>
+            <a:r>
+              <a:t>Collapse Threshold: R_c = 1 / (1-S)</a:t>
+            </a:r>
+          </a:p>
+        </p:txBody>
+      </p:sp>
+      <p:sp>
+        <p:nvSpPr>
+          <p:cNvPr id="9" name="TextBox 8"/>
+          <p:cNvSpPr txBox="1"/>
+          <p:nvPr/>
+        </p:nvSpPr>
+        <p:spPr>
+          <a:xfrm>
+            <a:off x="1097280" y="4389120"/>
+            <a:ext cx="10177272" cy="1005840"/>
+          </a:xfrm>
+          <a:prstGeom prst="rect">
+            <a:avLst/>
+          </a:prstGeom>
+          <a:noFill/>
+        </p:spPr>
+        <p:txBody>
+          <a:bodyPr wrap="square">
+            <a:spAutoFit/>
+          </a:bodyPr>
+          <a:lstStyle/>
+          <a:p>
+            <a:pPr algn="l">
               <a:defRPr sz="2400" b="0">
                 <a:solidFill>
                   <a:srgbClr val="F0F0F0"/>
@@ -3858,6 +4276,42 @@
               </a:defRPr>
             </a:pPr>
             <a:r>
+              <a:t>• The Rising Bar: As the value-scalable workload (S) grows, fixed-function specialization faces a strict collapse threshold</a:t>
+            </a:r>
+          </a:p>
+        </p:txBody>
+      </p:sp>
+      <p:sp>
+        <p:nvSpPr>
+          <p:cNvPr id="10" name="TextBox 9"/>
+          <p:cNvSpPr txBox="1"/>
+          <p:nvPr/>
+        </p:nvSpPr>
+        <p:spPr>
+          <a:xfrm>
+            <a:off x="1097280" y="5486400"/>
+            <a:ext cx="10177272" cy="1417320"/>
+          </a:xfrm>
+          <a:prstGeom prst="rect">
+            <a:avLst/>
+          </a:prstGeom>
+          <a:noFill/>
+        </p:spPr>
+        <p:txBody>
+          <a:bodyPr wrap="square">
+            <a:spAutoFit/>
+          </a:bodyPr>
+          <a:lstStyle/>
+          <a:p>
+            <a:pPr algn="l">
+              <a:defRPr sz="2400" b="0">
+                <a:solidFill>
+                  <a:srgbClr val="F0F0F0"/>
+                </a:solidFill>
+                <a:latin typeface="Arial"/>
+              </a:defRPr>
+            </a:pPr>
+            <a:r>
               <a:t>• The Key Equation: For a given scalable fraction S, specialized hardware must achieve a relative efficiency ratio of R_c = 1/(1−S) to justify its inclusion</a:t>
             </a:r>
           </a:p>
@@ -3865,13 +4319,13 @@
       </p:sp>
       <p:sp>
         <p:nvSpPr>
-          <p:cNvPr id="6" name="TextBox 5"/>
+          <p:cNvPr id="11" name="TextBox 10"/>
           <p:cNvSpPr txBox="1"/>
           <p:nvPr/>
         </p:nvSpPr>
         <p:spPr>
           <a:xfrm>
-            <a:off x="1097280" y="5257800"/>
+            <a:off x="1097280" y="6995160"/>
             <a:ext cx="10177272" cy="502920"/>
           </a:xfrm>
           <a:prstGeom prst="rect">
@@ -4064,7 +4518,7 @@
               </a:defRPr>
             </a:pPr>
             <a:r>
-              <a:t>• The Accelerator Dynamic: AI domain-specific accelerators matter, but they do not simply displace the GPU; they must continually displace as the dominant value-producing workload evolves</a:t>
+              <a:t>• The Accelerator Dynamic: AI domain-specific accelerators matter, but they do not simply displace the GPU; they must continually adapt as the dominant value-producing workload evolves</a:t>
             </a:r>
           </a:p>
         </p:txBody>
@@ -4133,14 +4587,369 @@
       </p:sp>
       <p:sp>
         <p:nvSpPr>
-          <p:cNvPr id="3" name="TextBox 2"/>
+          <p:cNvPr id="3" name="Rectangle 2"/>
+          <p:cNvSpPr/>
+          <p:nvPr/>
+        </p:nvSpPr>
+        <p:spPr>
+          <a:xfrm>
+            <a:off x="914400" y="1645920"/>
+            <a:ext cx="2286000" cy="914400"/>
+          </a:xfrm>
+          <a:prstGeom prst="rect">
+            <a:avLst/>
+          </a:prstGeom>
+          <a:solidFill>
+            <a:srgbClr val="0A1929"/>
+          </a:solidFill>
+          <a:ln w="25400">
+            <a:solidFill>
+              <a:srgbClr val="FFD700"/>
+            </a:solidFill>
+          </a:ln>
+        </p:spPr>
+        <p:style>
+          <a:lnRef idx="1">
+            <a:schemeClr val="accent1"/>
+          </a:lnRef>
+          <a:fillRef idx="3">
+            <a:schemeClr val="accent1"/>
+          </a:fillRef>
+          <a:effectRef idx="2">
+            <a:schemeClr val="accent1"/>
+          </a:effectRef>
+          <a:fontRef idx="minor">
+            <a:schemeClr val="lt1"/>
+          </a:fontRef>
+        </p:style>
+        <p:txBody>
+          <a:bodyPr rtlCol="0" anchor="ctr" wrap="square"/>
+          <a:lstStyle/>
+          <a:p>
+            <a:pPr algn="ctr">
+              <a:defRPr sz="1600" b="1">
+                <a:solidFill>
+                  <a:srgbClr val="F0F0F0"/>
+                </a:solidFill>
+                <a:latin typeface="Arial"/>
+              </a:defRPr>
+            </a:pPr>
+            <a:r>
+              <a:t>1. Formal Limits</a:t>
+            </a:r>
+          </a:p>
+        </p:txBody>
+      </p:sp>
+      <p:sp>
+        <p:nvSpPr>
+          <p:cNvPr id="4" name="Right Arrow 3"/>
+          <p:cNvSpPr/>
+          <p:nvPr/>
+        </p:nvSpPr>
+        <p:spPr>
+          <a:xfrm>
+            <a:off x="3291840" y="2011680"/>
+            <a:ext cx="365760" cy="182880"/>
+          </a:xfrm>
+          <a:prstGeom prst="rightArrow">
+            <a:avLst/>
+          </a:prstGeom>
+          <a:solidFill>
+            <a:srgbClr val="F0F0F0"/>
+          </a:solidFill>
+          <a:ln w="25400">
+            <a:solidFill>
+              <a:srgbClr val="F0F0F0"/>
+            </a:solidFill>
+          </a:ln>
+        </p:spPr>
+        <p:style>
+          <a:lnRef idx="1">
+            <a:schemeClr val="accent1"/>
+          </a:lnRef>
+          <a:fillRef idx="3">
+            <a:schemeClr val="accent1"/>
+          </a:fillRef>
+          <a:effectRef idx="2">
+            <a:schemeClr val="accent1"/>
+          </a:effectRef>
+          <a:fontRef idx="minor">
+            <a:schemeClr val="lt1"/>
+          </a:fontRef>
+        </p:style>
+        <p:txBody>
+          <a:bodyPr rtlCol="0" anchor="ctr"/>
+          <a:lstStyle/>
+          <a:p>
+            <a:pPr algn="ctr"/>
+          </a:p>
+        </p:txBody>
+      </p:sp>
+      <p:sp>
+        <p:nvSpPr>
+          <p:cNvPr id="5" name="Rectangle 4"/>
+          <p:cNvSpPr/>
+          <p:nvPr/>
+        </p:nvSpPr>
+        <p:spPr>
+          <a:xfrm>
+            <a:off x="3749039" y="1645920"/>
+            <a:ext cx="2286000" cy="914400"/>
+          </a:xfrm>
+          <a:prstGeom prst="rect">
+            <a:avLst/>
+          </a:prstGeom>
+          <a:solidFill>
+            <a:srgbClr val="0A1929"/>
+          </a:solidFill>
+          <a:ln w="25400">
+            <a:solidFill>
+              <a:srgbClr val="00FFFF"/>
+            </a:solidFill>
+          </a:ln>
+        </p:spPr>
+        <p:style>
+          <a:lnRef idx="1">
+            <a:schemeClr val="accent1"/>
+          </a:lnRef>
+          <a:fillRef idx="3">
+            <a:schemeClr val="accent1"/>
+          </a:fillRef>
+          <a:effectRef idx="2">
+            <a:schemeClr val="accent1"/>
+          </a:effectRef>
+          <a:fontRef idx="minor">
+            <a:schemeClr val="lt1"/>
+          </a:fontRef>
+        </p:style>
+        <p:txBody>
+          <a:bodyPr rtlCol="0" anchor="ctr" wrap="square"/>
+          <a:lstStyle/>
+          <a:p>
+            <a:pPr algn="ctr">
+              <a:defRPr sz="1600" b="1">
+                <a:solidFill>
+                  <a:srgbClr val="F0F0F0"/>
+                </a:solidFill>
+                <a:latin typeface="Arial"/>
+              </a:defRPr>
+            </a:pPr>
+            <a:r>
+              <a:t>2. Bounded Feasibility</a:t>
+            </a:r>
+          </a:p>
+        </p:txBody>
+      </p:sp>
+      <p:sp>
+        <p:nvSpPr>
+          <p:cNvPr id="6" name="Right Arrow 5"/>
+          <p:cNvSpPr/>
+          <p:nvPr/>
+        </p:nvSpPr>
+        <p:spPr>
+          <a:xfrm>
+            <a:off x="6126480" y="2011680"/>
+            <a:ext cx="365760" cy="182880"/>
+          </a:xfrm>
+          <a:prstGeom prst="rightArrow">
+            <a:avLst/>
+          </a:prstGeom>
+          <a:solidFill>
+            <a:srgbClr val="F0F0F0"/>
+          </a:solidFill>
+          <a:ln w="25400">
+            <a:solidFill>
+              <a:srgbClr val="F0F0F0"/>
+            </a:solidFill>
+          </a:ln>
+        </p:spPr>
+        <p:style>
+          <a:lnRef idx="1">
+            <a:schemeClr val="accent1"/>
+          </a:lnRef>
+          <a:fillRef idx="3">
+            <a:schemeClr val="accent1"/>
+          </a:fillRef>
+          <a:effectRef idx="2">
+            <a:schemeClr val="accent1"/>
+          </a:effectRef>
+          <a:fontRef idx="minor">
+            <a:schemeClr val="lt1"/>
+          </a:fontRef>
+        </p:style>
+        <p:txBody>
+          <a:bodyPr rtlCol="0" anchor="ctr"/>
+          <a:lstStyle/>
+          <a:p>
+            <a:pPr algn="ctr"/>
+          </a:p>
+        </p:txBody>
+      </p:sp>
+      <p:sp>
+        <p:nvSpPr>
+          <p:cNvPr id="7" name="Rectangle 6"/>
+          <p:cNvSpPr/>
+          <p:nvPr/>
+        </p:nvSpPr>
+        <p:spPr>
+          <a:xfrm>
+            <a:off x="6583680" y="1645920"/>
+            <a:ext cx="2286000" cy="914400"/>
+          </a:xfrm>
+          <a:prstGeom prst="rect">
+            <a:avLst/>
+          </a:prstGeom>
+          <a:solidFill>
+            <a:srgbClr val="0A1929"/>
+          </a:solidFill>
+          <a:ln w="25400">
+            <a:solidFill>
+              <a:srgbClr val="FFD700"/>
+            </a:solidFill>
+          </a:ln>
+        </p:spPr>
+        <p:style>
+          <a:lnRef idx="1">
+            <a:schemeClr val="accent1"/>
+          </a:lnRef>
+          <a:fillRef idx="3">
+            <a:schemeClr val="accent1"/>
+          </a:fillRef>
+          <a:effectRef idx="2">
+            <a:schemeClr val="accent1"/>
+          </a:effectRef>
+          <a:fontRef idx="minor">
+            <a:schemeClr val="lt1"/>
+          </a:fontRef>
+        </p:style>
+        <p:txBody>
+          <a:bodyPr rtlCol="0" anchor="ctr" wrap="square"/>
+          <a:lstStyle/>
+          <a:p>
+            <a:pPr algn="ctr">
+              <a:defRPr sz="1600" b="1">
+                <a:solidFill>
+                  <a:srgbClr val="F0F0F0"/>
+                </a:solidFill>
+                <a:latin typeface="Arial"/>
+              </a:defRPr>
+            </a:pPr>
+            <a:r>
+              <a:t>3. Empirical Scaling</a:t>
+            </a:r>
+          </a:p>
+        </p:txBody>
+      </p:sp>
+      <p:sp>
+        <p:nvSpPr>
+          <p:cNvPr id="8" name="Right Arrow 7"/>
+          <p:cNvSpPr/>
+          <p:nvPr/>
+        </p:nvSpPr>
+        <p:spPr>
+          <a:xfrm>
+            <a:off x="8961120" y="2011680"/>
+            <a:ext cx="365760" cy="182880"/>
+          </a:xfrm>
+          <a:prstGeom prst="rightArrow">
+            <a:avLst/>
+          </a:prstGeom>
+          <a:solidFill>
+            <a:srgbClr val="F0F0F0"/>
+          </a:solidFill>
+          <a:ln w="25400">
+            <a:solidFill>
+              <a:srgbClr val="F0F0F0"/>
+            </a:solidFill>
+          </a:ln>
+        </p:spPr>
+        <p:style>
+          <a:lnRef idx="1">
+            <a:schemeClr val="accent1"/>
+          </a:lnRef>
+          <a:fillRef idx="3">
+            <a:schemeClr val="accent1"/>
+          </a:fillRef>
+          <a:effectRef idx="2">
+            <a:schemeClr val="accent1"/>
+          </a:effectRef>
+          <a:fontRef idx="minor">
+            <a:schemeClr val="lt1"/>
+          </a:fontRef>
+        </p:style>
+        <p:txBody>
+          <a:bodyPr rtlCol="0" anchor="ctr"/>
+          <a:lstStyle/>
+          <a:p>
+            <a:pPr algn="ctr"/>
+          </a:p>
+        </p:txBody>
+      </p:sp>
+      <p:sp>
+        <p:nvSpPr>
+          <p:cNvPr id="9" name="Rectangle 8"/>
+          <p:cNvSpPr/>
+          <p:nvPr/>
+        </p:nvSpPr>
+        <p:spPr>
+          <a:xfrm>
+            <a:off x="9418320" y="1645920"/>
+            <a:ext cx="2286000" cy="914400"/>
+          </a:xfrm>
+          <a:prstGeom prst="rect">
+            <a:avLst/>
+          </a:prstGeom>
+          <a:solidFill>
+            <a:srgbClr val="0A1929"/>
+          </a:solidFill>
+          <a:ln w="25400">
+            <a:solidFill>
+              <a:srgbClr val="00FFFF"/>
+            </a:solidFill>
+          </a:ln>
+        </p:spPr>
+        <p:style>
+          <a:lnRef idx="1">
+            <a:schemeClr val="accent1"/>
+          </a:lnRef>
+          <a:fillRef idx="3">
+            <a:schemeClr val="accent1"/>
+          </a:fillRef>
+          <a:effectRef idx="2">
+            <a:schemeClr val="accent1"/>
+          </a:effectRef>
+          <a:fontRef idx="minor">
+            <a:schemeClr val="lt1"/>
+          </a:fontRef>
+        </p:style>
+        <p:txBody>
+          <a:bodyPr rtlCol="0" anchor="ctr" wrap="square"/>
+          <a:lstStyle/>
+          <a:p>
+            <a:pPr algn="ctr">
+              <a:defRPr sz="1600" b="1">
+                <a:solidFill>
+                  <a:srgbClr val="F0F0F0"/>
+                </a:solidFill>
+                <a:latin typeface="Arial"/>
+              </a:defRPr>
+            </a:pPr>
+            <a:r>
+              <a:t>4. Hardware Architecture</a:t>
+            </a:r>
+          </a:p>
+        </p:txBody>
+      </p:sp>
+      <p:sp>
+        <p:nvSpPr>
+          <p:cNvPr id="10" name="TextBox 9"/>
           <p:cNvSpPr txBox="1"/>
           <p:nvPr/>
         </p:nvSpPr>
         <p:spPr>
           <a:xfrm>
-            <a:off x="914400" y="1645920"/>
-            <a:ext cx="10360152" cy="1325880"/>
+            <a:off x="1097280" y="3017520"/>
+            <a:ext cx="10177272" cy="594360"/>
           </a:xfrm>
           <a:prstGeom prst="rect">
             <a:avLst/>
@@ -4154,29 +4963,29 @@
           <a:lstStyle/>
           <a:p>
             <a:pPr algn="l">
-              <a:defRPr sz="2000" b="1">
-                <a:solidFill>
-                  <a:srgbClr val="FFD700"/>
-                </a:solidFill>
-                <a:latin typeface="Arial"/>
-              </a:defRPr>
-            </a:pPr>
-            <a:r>
-              <a:t>[Visual Concept: A single clean structural diagram linking formal limits, bounded feasibility, empirical scaling, and hardware architecture]</a:t>
-            </a:r>
-          </a:p>
-        </p:txBody>
-      </p:sp>
-      <p:sp>
-        <p:nvSpPr>
-          <p:cNvPr id="4" name="TextBox 3"/>
+              <a:defRPr sz="2400" b="0">
+                <a:solidFill>
+                  <a:srgbClr val="F0F0F0"/>
+                </a:solidFill>
+                <a:latin typeface="Arial"/>
+              </a:defRPr>
+            </a:pPr>
+            <a:r>
+              <a:t>• 1. Computability: Open-ended ascent across relative boundaries</a:t>
+            </a:r>
+          </a:p>
+        </p:txBody>
+      </p:sp>
+      <p:sp>
+        <p:nvSpPr>
+          <p:cNvPr id="11" name="TextBox 10"/>
           <p:cNvSpPr txBox="1"/>
           <p:nvPr/>
         </p:nvSpPr>
         <p:spPr>
           <a:xfrm>
-            <a:off x="1097280" y="3063240"/>
-            <a:ext cx="10177272" cy="594360"/>
+            <a:off x="1097280" y="3703320"/>
+            <a:ext cx="10177272" cy="1005840"/>
           </a:xfrm>
           <a:prstGeom prst="rect">
             <a:avLst/>
@@ -4198,20 +5007,20 @@
               </a:defRPr>
             </a:pPr>
             <a:r>
-              <a:t>• 1. Computability: Open-ended ascent across relative boundaries</a:t>
-            </a:r>
-          </a:p>
-        </p:txBody>
-      </p:sp>
-      <p:sp>
-        <p:nvSpPr>
-          <p:cNvPr id="5" name="TextBox 4"/>
+              <a:t>• 2. Feasibility: Staged reachability through polynomial-time verification</a:t>
+            </a:r>
+          </a:p>
+        </p:txBody>
+      </p:sp>
+      <p:sp>
+        <p:nvSpPr>
+          <p:cNvPr id="12" name="TextBox 11"/>
           <p:cNvSpPr txBox="1"/>
           <p:nvPr/>
         </p:nvSpPr>
         <p:spPr>
           <a:xfrm>
-            <a:off x="1097280" y="3749040"/>
+            <a:off x="1097280" y="4800600"/>
             <a:ext cx="10177272" cy="1005840"/>
           </a:xfrm>
           <a:prstGeom prst="rect">
@@ -4234,56 +5043,20 @@
               </a:defRPr>
             </a:pPr>
             <a:r>
-              <a:t>• 2. Feasibility: Staged reachability through polynomial-time verification</a:t>
-            </a:r>
-          </a:p>
-        </p:txBody>
-      </p:sp>
-      <p:sp>
-        <p:nvSpPr>
-          <p:cNvPr id="6" name="TextBox 5"/>
+              <a:t>• 3. Empirical Drivers: Logical scaling sustained by compounding hidden efficiency</a:t>
+            </a:r>
+          </a:p>
+        </p:txBody>
+      </p:sp>
+      <p:sp>
+        <p:nvSpPr>
+          <p:cNvPr id="13" name="TextBox 12"/>
           <p:cNvSpPr txBox="1"/>
           <p:nvPr/>
         </p:nvSpPr>
         <p:spPr>
           <a:xfrm>
-            <a:off x="1097280" y="4846320"/>
-            <a:ext cx="10177272" cy="1005840"/>
-          </a:xfrm>
-          <a:prstGeom prst="rect">
-            <a:avLst/>
-          </a:prstGeom>
-          <a:noFill/>
-        </p:spPr>
-        <p:txBody>
-          <a:bodyPr wrap="square">
-            <a:spAutoFit/>
-          </a:bodyPr>
-          <a:lstStyle/>
-          <a:p>
-            <a:pPr algn="l">
-              <a:defRPr sz="2400" b="0">
-                <a:solidFill>
-                  <a:srgbClr val="F0F0F0"/>
-                </a:solidFill>
-                <a:latin typeface="Arial"/>
-              </a:defRPr>
-            </a:pPr>
-            <a:r>
-              <a:t>• 3. Empirical Drivers: Logical scaling sustained by compounding hidden efficiency</a:t>
-            </a:r>
-          </a:p>
-        </p:txBody>
-      </p:sp>
-      <p:sp>
-        <p:nvSpPr>
-          <p:cNvPr id="7" name="TextBox 6"/>
-          <p:cNvSpPr txBox="1"/>
-          <p:nvPr/>
-        </p:nvSpPr>
-        <p:spPr>
-          <a:xfrm>
-            <a:off x="1097280" y="5943600"/>
+            <a:off x="1097280" y="5897880"/>
             <a:ext cx="10177272" cy="1005840"/>
           </a:xfrm>
           <a:prstGeom prst="rect">
@@ -4708,7 +5481,7 @@
               </a:defRPr>
             </a:pPr>
             <a:r>
-              <a:t>Pair 1: The Formal Foundation</a:t>
+              <a:t>•  The Formal Foundation</a:t>
             </a:r>
           </a:p>
         </p:txBody>
@@ -4816,7 +5589,7 @@
               </a:defRPr>
             </a:pPr>
             <a:r>
-              <a:t>Pair 2: The Empirical and Architectural Bridge</a:t>
+              <a:t>•  The Empirical and Architectural Bridge</a:t>
             </a:r>
           </a:p>
         </p:txBody>
@@ -5127,14 +5900,270 @@
       </p:sp>
       <p:sp>
         <p:nvSpPr>
-          <p:cNvPr id="3" name="TextBox 2"/>
+          <p:cNvPr id="3" name="Rectangle 2"/>
+          <p:cNvSpPr/>
+          <p:nvPr/>
+        </p:nvSpPr>
+        <p:spPr>
+          <a:xfrm>
+            <a:off x="3657600" y="3474720"/>
+            <a:ext cx="4572000" cy="731520"/>
+          </a:xfrm>
+          <a:prstGeom prst="rect">
+            <a:avLst/>
+          </a:prstGeom>
+          <a:solidFill>
+            <a:srgbClr val="0A1929"/>
+          </a:solidFill>
+          <a:ln w="25400">
+            <a:solidFill>
+              <a:srgbClr val="00FFFF"/>
+            </a:solidFill>
+          </a:ln>
+        </p:spPr>
+        <p:style>
+          <a:lnRef idx="1">
+            <a:schemeClr val="accent1"/>
+          </a:lnRef>
+          <a:fillRef idx="3">
+            <a:schemeClr val="accent1"/>
+          </a:fillRef>
+          <a:effectRef idx="2">
+            <a:schemeClr val="accent1"/>
+          </a:effectRef>
+          <a:fontRef idx="minor">
+            <a:schemeClr val="lt1"/>
+          </a:fontRef>
+        </p:style>
+        <p:txBody>
+          <a:bodyPr rtlCol="0" anchor="ctr" wrap="square"/>
+          <a:lstStyle/>
+          <a:p>
+            <a:pPr algn="ctr">
+              <a:defRPr sz="1600" b="1">
+                <a:solidFill>
+                  <a:srgbClr val="F0F0F0"/>
+                </a:solidFill>
+                <a:latin typeface="Arial"/>
+              </a:defRPr>
+            </a:pPr>
+            <a:r>
+              <a:t>A_n (Foundational Layer)</a:t>
+            </a:r>
+          </a:p>
+        </p:txBody>
+      </p:sp>
+      <p:sp>
+        <p:nvSpPr>
+          <p:cNvPr id="4" name="Up Arrow 3"/>
+          <p:cNvSpPr/>
+          <p:nvPr/>
+        </p:nvSpPr>
+        <p:spPr>
+          <a:xfrm>
+            <a:off x="5486400" y="2560320"/>
+            <a:ext cx="914400" cy="731520"/>
+          </a:xfrm>
+          <a:prstGeom prst="upArrow">
+            <a:avLst/>
+          </a:prstGeom>
+          <a:solidFill>
+            <a:srgbClr val="FFD700"/>
+          </a:solidFill>
+          <a:ln w="25400">
+            <a:solidFill>
+              <a:srgbClr val="FFD700"/>
+            </a:solidFill>
+          </a:ln>
+        </p:spPr>
+        <p:style>
+          <a:lnRef idx="1">
+            <a:schemeClr val="accent1"/>
+          </a:lnRef>
+          <a:fillRef idx="3">
+            <a:schemeClr val="accent1"/>
+          </a:fillRef>
+          <a:effectRef idx="2">
+            <a:schemeClr val="accent1"/>
+          </a:effectRef>
+          <a:fontRef idx="minor">
+            <a:schemeClr val="lt1"/>
+          </a:fontRef>
+        </p:style>
+        <p:txBody>
+          <a:bodyPr rtlCol="0" anchor="ctr"/>
+          <a:lstStyle/>
+          <a:p>
+            <a:pPr algn="ctr"/>
+          </a:p>
+        </p:txBody>
+      </p:sp>
+      <p:sp>
+        <p:nvSpPr>
+          <p:cNvPr id="5" name="Rectangle 4"/>
+          <p:cNvSpPr/>
+          <p:nvPr/>
+        </p:nvSpPr>
+        <p:spPr>
+          <a:xfrm>
+            <a:off x="3657600" y="1645920"/>
+            <a:ext cx="4572000" cy="731520"/>
+          </a:xfrm>
+          <a:prstGeom prst="rect">
+            <a:avLst/>
+          </a:prstGeom>
+          <a:solidFill>
+            <a:srgbClr val="0A1929"/>
+          </a:solidFill>
+          <a:ln w="25400">
+            <a:solidFill>
+              <a:srgbClr val="00FFFF"/>
+            </a:solidFill>
+          </a:ln>
+        </p:spPr>
+        <p:style>
+          <a:lnRef idx="1">
+            <a:schemeClr val="accent1"/>
+          </a:lnRef>
+          <a:fillRef idx="3">
+            <a:schemeClr val="accent1"/>
+          </a:fillRef>
+          <a:effectRef idx="2">
+            <a:schemeClr val="accent1"/>
+          </a:effectRef>
+          <a:fontRef idx="minor">
+            <a:schemeClr val="lt1"/>
+          </a:fontRef>
+        </p:style>
+        <p:txBody>
+          <a:bodyPr rtlCol="0" anchor="ctr" wrap="square"/>
+          <a:lstStyle/>
+          <a:p>
+            <a:pPr algn="ctr">
+              <a:defRPr sz="1600" b="1">
+                <a:solidFill>
+                  <a:srgbClr val="F0F0F0"/>
+                </a:solidFill>
+                <a:latin typeface="Arial"/>
+              </a:defRPr>
+            </a:pPr>
+            <a:r>
+              <a:t>Intermediate Step (B)</a:t>
+            </a:r>
+          </a:p>
+        </p:txBody>
+      </p:sp>
+      <p:sp>
+        <p:nvSpPr>
+          <p:cNvPr id="6" name="Up Arrow 5"/>
+          <p:cNvSpPr/>
+          <p:nvPr/>
+        </p:nvSpPr>
+        <p:spPr>
+          <a:xfrm>
+            <a:off x="5486400" y="914400"/>
+            <a:ext cx="914400" cy="548640"/>
+          </a:xfrm>
+          <a:prstGeom prst="upArrow">
+            <a:avLst/>
+          </a:prstGeom>
+          <a:solidFill>
+            <a:srgbClr val="FFD700"/>
+          </a:solidFill>
+          <a:ln w="25400">
+            <a:solidFill>
+              <a:srgbClr val="FFD700"/>
+            </a:solidFill>
+          </a:ln>
+        </p:spPr>
+        <p:style>
+          <a:lnRef idx="1">
+            <a:schemeClr val="accent1"/>
+          </a:lnRef>
+          <a:fillRef idx="3">
+            <a:schemeClr val="accent1"/>
+          </a:fillRef>
+          <a:effectRef idx="2">
+            <a:schemeClr val="accent1"/>
+          </a:effectRef>
+          <a:fontRef idx="minor">
+            <a:schemeClr val="lt1"/>
+          </a:fontRef>
+        </p:style>
+        <p:txBody>
+          <a:bodyPr rtlCol="0" anchor="ctr"/>
+          <a:lstStyle/>
+          <a:p>
+            <a:pPr algn="ctr"/>
+          </a:p>
+        </p:txBody>
+      </p:sp>
+      <p:sp>
+        <p:nvSpPr>
+          <p:cNvPr id="7" name="Rectangle 6"/>
+          <p:cNvSpPr/>
+          <p:nvPr/>
+        </p:nvSpPr>
+        <p:spPr>
+          <a:xfrm>
+            <a:off x="3200400" y="274320"/>
+            <a:ext cx="5486400" cy="457200"/>
+          </a:xfrm>
+          <a:prstGeom prst="rect">
+            <a:avLst/>
+          </a:prstGeom>
+          <a:solidFill>
+            <a:srgbClr val="0A1929"/>
+          </a:solidFill>
+          <a:ln w="25400">
+            <a:solidFill>
+              <a:srgbClr val="00FFFF"/>
+            </a:solidFill>
+            <a:prstDash val="dash"/>
+          </a:ln>
+        </p:spPr>
+        <p:style>
+          <a:lnRef idx="1">
+            <a:schemeClr val="accent1"/>
+          </a:lnRef>
+          <a:fillRef idx="3">
+            <a:schemeClr val="accent1"/>
+          </a:fillRef>
+          <a:effectRef idx="2">
+            <a:schemeClr val="accent1"/>
+          </a:effectRef>
+          <a:fontRef idx="minor">
+            <a:schemeClr val="lt1"/>
+          </a:fontRef>
+        </p:style>
+        <p:txBody>
+          <a:bodyPr rtlCol="0" anchor="ctr" wrap="square"/>
+          <a:lstStyle/>
+          <a:p>
+            <a:pPr algn="ctr">
+              <a:defRPr sz="1600" b="1">
+                <a:solidFill>
+                  <a:srgbClr val="00FFFF"/>
+                </a:solidFill>
+                <a:latin typeface="Arial"/>
+              </a:defRPr>
+            </a:pPr>
+            <a:r>
+              <a:t>A'_n (Turing Jump / Open Ceiling)</a:t>
+            </a:r>
+          </a:p>
+        </p:txBody>
+      </p:sp>
+      <p:sp>
+        <p:nvSpPr>
+          <p:cNvPr id="8" name="TextBox 7"/>
           <p:cNvSpPr txBox="1"/>
           <p:nvPr/>
         </p:nvSpPr>
         <p:spPr>
           <a:xfrm>
-            <a:off x="914400" y="1645920"/>
-            <a:ext cx="10360152" cy="1325880"/>
+            <a:off x="1097280" y="4389120"/>
+            <a:ext cx="10177272" cy="1005840"/>
           </a:xfrm>
           <a:prstGeom prst="rect">
             <a:avLst/>
@@ -5148,29 +6177,29 @@
           <a:lstStyle/>
           <a:p>
             <a:pPr algn="l">
-              <a:defRPr sz="2000" b="1">
-                <a:solidFill>
-                  <a:srgbClr val="FFD700"/>
-                </a:solidFill>
-                <a:latin typeface="Arial"/>
-              </a:defRPr>
-            </a:pPr>
-            <a:r>
-              <a:t>[Visual Concept: A blueprint-style diagram showing a foundational layer A_n, ascending through an intermediate step, toward an open ceiling A'_n]</a:t>
-            </a:r>
-          </a:p>
-        </p:txBody>
-      </p:sp>
-      <p:sp>
-        <p:nvSpPr>
-          <p:cNvPr id="4" name="TextBox 3"/>
+              <a:defRPr sz="2400" b="0">
+                <a:solidFill>
+                  <a:srgbClr val="F0F0F0"/>
+                </a:solidFill>
+                <a:latin typeface="Arial"/>
+              </a:defRPr>
+            </a:pPr>
+            <a:r>
+              <a:t>• The Turing Jump as a Ceiling: The absolute boundary of any mechanized layer is its Turing jump (A')</a:t>
+            </a:r>
+          </a:p>
+        </p:txBody>
+      </p:sp>
+      <p:sp>
+        <p:nvSpPr>
+          <p:cNvPr id="9" name="TextBox 8"/>
           <p:cNvSpPr txBox="1"/>
           <p:nvPr/>
         </p:nvSpPr>
         <p:spPr>
           <a:xfrm>
-            <a:off x="1097280" y="3063240"/>
-            <a:ext cx="10177272" cy="1005840"/>
+            <a:off x="1097280" y="5486400"/>
+            <a:ext cx="10177272" cy="1417320"/>
           </a:xfrm>
           <a:prstGeom prst="rect">
             <a:avLst/>
@@ -5192,56 +6221,20 @@
               </a:defRPr>
             </a:pPr>
             <a:r>
-              <a:t>• The Turing Jump as a Ceiling: The absolute boundary of any mechanized layer is its Turing jump (A')</a:t>
-            </a:r>
-          </a:p>
-        </p:txBody>
-      </p:sp>
-      <p:sp>
-        <p:nvSpPr>
-          <p:cNvPr id="5" name="TextBox 4"/>
+              <a:t>• Progressive Layers: Real progress occurs through intermediate strengthenings (A &lt;_T B &lt;_T A'), mechanizing steps strictly below the absolute jump</a:t>
+            </a:r>
+          </a:p>
+        </p:txBody>
+      </p:sp>
+      <p:sp>
+        <p:nvSpPr>
+          <p:cNvPr id="10" name="TextBox 9"/>
           <p:cNvSpPr txBox="1"/>
           <p:nvPr/>
         </p:nvSpPr>
         <p:spPr>
           <a:xfrm>
-            <a:off x="1097280" y="4160520"/>
-            <a:ext cx="10177272" cy="1417320"/>
-          </a:xfrm>
-          <a:prstGeom prst="rect">
-            <a:avLst/>
-          </a:prstGeom>
-          <a:noFill/>
-        </p:spPr>
-        <p:txBody>
-          <a:bodyPr wrap="square">
-            <a:spAutoFit/>
-          </a:bodyPr>
-          <a:lstStyle/>
-          <a:p>
-            <a:pPr algn="l">
-              <a:defRPr sz="2400" b="0">
-                <a:solidFill>
-                  <a:srgbClr val="F0F0F0"/>
-                </a:solidFill>
-                <a:latin typeface="Arial"/>
-              </a:defRPr>
-            </a:pPr>
-            <a:r>
-              <a:t>• Progressive Layers: Real progress occurs through intermediate strengthenings (A &lt;_T B &lt;_T A'), mechanizing steps strictly below the absolute jump</a:t>
-            </a:r>
-          </a:p>
-        </p:txBody>
-      </p:sp>
-      <p:sp>
-        <p:nvSpPr>
-          <p:cNvPr id="6" name="TextBox 5"/>
-          <p:cNvSpPr txBox="1"/>
-          <p:nvPr/>
-        </p:nvSpPr>
-        <p:spPr>
-          <a:xfrm>
-            <a:off x="1097280" y="5669280"/>
+            <a:off x="1097280" y="6995160"/>
             <a:ext cx="10177272" cy="1005840"/>
           </a:xfrm>
           <a:prstGeom prst="rect">
@@ -5503,14 +6496,269 @@
       </p:sp>
       <p:sp>
         <p:nvSpPr>
-          <p:cNvPr id="3" name="TextBox 2"/>
+          <p:cNvPr id="3" name="Rectangle 2"/>
+          <p:cNvSpPr/>
+          <p:nvPr/>
+        </p:nvSpPr>
+        <p:spPr>
+          <a:xfrm>
+            <a:off x="1371600" y="3108960"/>
+            <a:ext cx="2743200" cy="548640"/>
+          </a:xfrm>
+          <a:prstGeom prst="rect">
+            <a:avLst/>
+          </a:prstGeom>
+          <a:solidFill>
+            <a:srgbClr val="0A1929"/>
+          </a:solidFill>
+          <a:ln w="25400">
+            <a:solidFill>
+              <a:srgbClr val="00FFFF"/>
+            </a:solidFill>
+          </a:ln>
+        </p:spPr>
+        <p:style>
+          <a:lnRef idx="1">
+            <a:schemeClr val="accent1"/>
+          </a:lnRef>
+          <a:fillRef idx="3">
+            <a:schemeClr val="accent1"/>
+          </a:fillRef>
+          <a:effectRef idx="2">
+            <a:schemeClr val="accent1"/>
+          </a:effectRef>
+          <a:fontRef idx="minor">
+            <a:schemeClr val="lt1"/>
+          </a:fontRef>
+        </p:style>
+        <p:txBody>
+          <a:bodyPr rtlCol="0" anchor="ctr" wrap="square"/>
+          <a:lstStyle/>
+          <a:p>
+            <a:pPr algn="ctr">
+              <a:defRPr sz="1600" b="1">
+                <a:solidFill>
+                  <a:srgbClr val="F0F0F0"/>
+                </a:solidFill>
+                <a:latin typeface="Arial"/>
+              </a:defRPr>
+            </a:pPr>
+            <a:r>
+              <a:t>P (Direct Decision)</a:t>
+            </a:r>
+          </a:p>
+        </p:txBody>
+      </p:sp>
+      <p:sp>
+        <p:nvSpPr>
+          <p:cNvPr id="4" name="Right Arrow 3"/>
+          <p:cNvSpPr/>
+          <p:nvPr/>
+        </p:nvSpPr>
+        <p:spPr>
+          <a:xfrm>
+            <a:off x="4297680" y="3200400"/>
+            <a:ext cx="548640" cy="365760"/>
+          </a:xfrm>
+          <a:prstGeom prst="rightArrow">
+            <a:avLst/>
+          </a:prstGeom>
+          <a:solidFill>
+            <a:srgbClr val="FFD700"/>
+          </a:solidFill>
+          <a:ln w="25400">
+            <a:solidFill>
+              <a:srgbClr val="FFD700"/>
+            </a:solidFill>
+          </a:ln>
+        </p:spPr>
+        <p:style>
+          <a:lnRef idx="1">
+            <a:schemeClr val="accent1"/>
+          </a:lnRef>
+          <a:fillRef idx="3">
+            <a:schemeClr val="accent1"/>
+          </a:fillRef>
+          <a:effectRef idx="2">
+            <a:schemeClr val="accent1"/>
+          </a:effectRef>
+          <a:fontRef idx="minor">
+            <a:schemeClr val="lt1"/>
+          </a:fontRef>
+        </p:style>
+        <p:txBody>
+          <a:bodyPr rtlCol="0" anchor="ctr"/>
+          <a:lstStyle/>
+          <a:p>
+            <a:pPr algn="ctr"/>
+          </a:p>
+        </p:txBody>
+      </p:sp>
+      <p:sp>
+        <p:nvSpPr>
+          <p:cNvPr id="5" name="Rectangle 4"/>
+          <p:cNvSpPr/>
+          <p:nvPr/>
+        </p:nvSpPr>
+        <p:spPr>
+          <a:xfrm>
+            <a:off x="5029200" y="2377440"/>
+            <a:ext cx="3200400" cy="548640"/>
+          </a:xfrm>
+          <a:prstGeom prst="rect">
+            <a:avLst/>
+          </a:prstGeom>
+          <a:solidFill>
+            <a:srgbClr val="0A1929"/>
+          </a:solidFill>
+          <a:ln w="25400">
+            <a:solidFill>
+              <a:srgbClr val="00FFFF"/>
+            </a:solidFill>
+          </a:ln>
+        </p:spPr>
+        <p:style>
+          <a:lnRef idx="1">
+            <a:schemeClr val="accent1"/>
+          </a:lnRef>
+          <a:fillRef idx="3">
+            <a:schemeClr val="accent1"/>
+          </a:fillRef>
+          <a:effectRef idx="2">
+            <a:schemeClr val="accent1"/>
+          </a:effectRef>
+          <a:fontRef idx="minor">
+            <a:schemeClr val="lt1"/>
+          </a:fontRef>
+        </p:style>
+        <p:txBody>
+          <a:bodyPr rtlCol="0" anchor="ctr" wrap="square"/>
+          <a:lstStyle/>
+          <a:p>
+            <a:pPr algn="ctr">
+              <a:defRPr sz="1600" b="1">
+                <a:solidFill>
+                  <a:srgbClr val="F0F0F0"/>
+                </a:solidFill>
+                <a:latin typeface="Arial"/>
+              </a:defRPr>
+            </a:pPr>
+            <a:r>
+              <a:t>NP (Certificate Verification)</a:t>
+            </a:r>
+          </a:p>
+        </p:txBody>
+      </p:sp>
+      <p:sp>
+        <p:nvSpPr>
+          <p:cNvPr id="6" name="Right Arrow 5"/>
+          <p:cNvSpPr/>
+          <p:nvPr/>
+        </p:nvSpPr>
+        <p:spPr>
+          <a:xfrm>
+            <a:off x="8412480" y="2468880"/>
+            <a:ext cx="548640" cy="365760"/>
+          </a:xfrm>
+          <a:prstGeom prst="rightArrow">
+            <a:avLst/>
+          </a:prstGeom>
+          <a:solidFill>
+            <a:srgbClr val="FFD700"/>
+          </a:solidFill>
+          <a:ln w="25400">
+            <a:solidFill>
+              <a:srgbClr val="FFD700"/>
+            </a:solidFill>
+          </a:ln>
+        </p:spPr>
+        <p:style>
+          <a:lnRef idx="1">
+            <a:schemeClr val="accent1"/>
+          </a:lnRef>
+          <a:fillRef idx="3">
+            <a:schemeClr val="accent1"/>
+          </a:fillRef>
+          <a:effectRef idx="2">
+            <a:schemeClr val="accent1"/>
+          </a:effectRef>
+          <a:fontRef idx="minor">
+            <a:schemeClr val="lt1"/>
+          </a:fontRef>
+        </p:style>
+        <p:txBody>
+          <a:bodyPr rtlCol="0" anchor="ctr"/>
+          <a:lstStyle/>
+          <a:p>
+            <a:pPr algn="ctr"/>
+          </a:p>
+        </p:txBody>
+      </p:sp>
+      <p:sp>
+        <p:nvSpPr>
+          <p:cNvPr id="7" name="Rectangle 6"/>
+          <p:cNvSpPr/>
+          <p:nvPr/>
+        </p:nvSpPr>
+        <p:spPr>
+          <a:xfrm>
+            <a:off x="9144000" y="1645920"/>
+            <a:ext cx="2743200" cy="548640"/>
+          </a:xfrm>
+          <a:prstGeom prst="rect">
+            <a:avLst/>
+          </a:prstGeom>
+          <a:solidFill>
+            <a:srgbClr val="0A1929"/>
+          </a:solidFill>
+          <a:ln w="25400">
+            <a:solidFill>
+              <a:srgbClr val="00FFFF"/>
+            </a:solidFill>
+          </a:ln>
+        </p:spPr>
+        <p:style>
+          <a:lnRef idx="1">
+            <a:schemeClr val="accent1"/>
+          </a:lnRef>
+          <a:fillRef idx="3">
+            <a:schemeClr val="accent1"/>
+          </a:fillRef>
+          <a:effectRef idx="2">
+            <a:schemeClr val="accent1"/>
+          </a:effectRef>
+          <a:fontRef idx="minor">
+            <a:schemeClr val="lt1"/>
+          </a:fontRef>
+        </p:style>
+        <p:txBody>
+          <a:bodyPr rtlCol="0" anchor="ctr" wrap="square"/>
+          <a:lstStyle/>
+          <a:p>
+            <a:pPr algn="ctr">
+              <a:defRPr sz="1600" b="1">
+                <a:solidFill>
+                  <a:srgbClr val="F0F0F0"/>
+                </a:solidFill>
+                <a:latin typeface="Arial"/>
+              </a:defRPr>
+            </a:pPr>
+            <a:r>
+              <a:t>PH (Guided Search)</a:t>
+            </a:r>
+          </a:p>
+        </p:txBody>
+      </p:sp>
+      <p:sp>
+        <p:nvSpPr>
+          <p:cNvPr id="8" name="TextBox 7"/>
           <p:cNvSpPr txBox="1"/>
           <p:nvPr/>
         </p:nvSpPr>
         <p:spPr>
           <a:xfrm>
-            <a:off x="914400" y="1645920"/>
-            <a:ext cx="10360152" cy="914400"/>
+            <a:off x="1097280" y="3931920"/>
+            <a:ext cx="10177272" cy="1005840"/>
           </a:xfrm>
           <a:prstGeom prst="rect">
             <a:avLst/>
@@ -5524,64 +6772,28 @@
           <a:lstStyle/>
           <a:p>
             <a:pPr algn="l">
-              <a:defRPr sz="2000" b="1">
-                <a:solidFill>
-                  <a:srgbClr val="FFD700"/>
-                </a:solidFill>
-                <a:latin typeface="Arial"/>
-              </a:defRPr>
-            </a:pPr>
-            <a:r>
-              <a:t>[Visual Concept: A finite-depth ladder expanding upward, showing P→NP→PH]</a:t>
-            </a:r>
-          </a:p>
-        </p:txBody>
-      </p:sp>
-      <p:sp>
-        <p:nvSpPr>
-          <p:cNvPr id="4" name="TextBox 3"/>
+              <a:defRPr sz="2400" b="0">
+                <a:solidFill>
+                  <a:srgbClr val="F0F0F0"/>
+                </a:solidFill>
+                <a:latin typeface="Arial"/>
+              </a:defRPr>
+            </a:pPr>
+            <a:r>
+              <a:t>• Bounded Verification Games: The Polynomial Hierarchy provides a finite-depth ladder of structured proposal, challenge, and repair</a:t>
+            </a:r>
+          </a:p>
+        </p:txBody>
+      </p:sp>
+      <p:sp>
+        <p:nvSpPr>
+          <p:cNvPr id="9" name="TextBox 8"/>
           <p:cNvSpPr txBox="1"/>
           <p:nvPr/>
         </p:nvSpPr>
         <p:spPr>
           <a:xfrm>
-            <a:off x="1097280" y="2651760"/>
-            <a:ext cx="10177272" cy="1005840"/>
-          </a:xfrm>
-          <a:prstGeom prst="rect">
-            <a:avLst/>
-          </a:prstGeom>
-          <a:noFill/>
-        </p:spPr>
-        <p:txBody>
-          <a:bodyPr wrap="square">
-            <a:spAutoFit/>
-          </a:bodyPr>
-          <a:lstStyle/>
-          <a:p>
-            <a:pPr algn="l">
-              <a:defRPr sz="2400" b="0">
-                <a:solidFill>
-                  <a:srgbClr val="F0F0F0"/>
-                </a:solidFill>
-                <a:latin typeface="Arial"/>
-              </a:defRPr>
-            </a:pPr>
-            <a:r>
-              <a:t>• Bounded Verification Games: The Polynomial Hierarchy provides a finite-depth ladder of structured proposal, challenge, and repair</a:t>
-            </a:r>
-          </a:p>
-        </p:txBody>
-      </p:sp>
-      <p:sp>
-        <p:nvSpPr>
-          <p:cNvPr id="5" name="TextBox 4"/>
-          <p:cNvSpPr txBox="1"/>
-          <p:nvPr/>
-        </p:nvSpPr>
-        <p:spPr>
-          <a:xfrm>
-            <a:off x="1097280" y="3749040"/>
+            <a:off x="1097280" y="5029200"/>
             <a:ext cx="10177272" cy="1417320"/>
           </a:xfrm>
           <a:prstGeom prst="rect">
@@ -5673,14 +6885,69 @@
       </p:sp>
       <p:sp>
         <p:nvSpPr>
-          <p:cNvPr id="3" name="TextBox 2"/>
+          <p:cNvPr id="3" name="Rounded Rectangle 2"/>
+          <p:cNvSpPr/>
+          <p:nvPr/>
+        </p:nvSpPr>
+        <p:spPr>
+          <a:xfrm>
+            <a:off x="1828800" y="1645920"/>
+            <a:ext cx="8531352" cy="2286000"/>
+          </a:xfrm>
+          <a:prstGeom prst="roundRect">
+            <a:avLst/>
+          </a:prstGeom>
+          <a:solidFill>
+            <a:srgbClr val="0A1929"/>
+          </a:solidFill>
+          <a:ln w="25400">
+            <a:solidFill>
+              <a:srgbClr val="00FFFF"/>
+            </a:solidFill>
+          </a:ln>
+        </p:spPr>
+        <p:style>
+          <a:lnRef idx="1">
+            <a:schemeClr val="accent1"/>
+          </a:lnRef>
+          <a:fillRef idx="3">
+            <a:schemeClr val="accent1"/>
+          </a:fillRef>
+          <a:effectRef idx="2">
+            <a:schemeClr val="accent1"/>
+          </a:effectRef>
+          <a:fontRef idx="minor">
+            <a:schemeClr val="lt1"/>
+          </a:fontRef>
+        </p:style>
+        <p:txBody>
+          <a:bodyPr rtlCol="0" anchor="ctr" wrap="square"/>
+          <a:lstStyle/>
+          <a:p>
+            <a:pPr algn="ctr">
+              <a:defRPr sz="1600" b="1">
+                <a:solidFill>
+                  <a:srgbClr val="F0F0F0"/>
+                </a:solidFill>
+                <a:latin typeface="Arial"/>
+              </a:defRPr>
+            </a:pPr>
+            <a:r>
+              <a:t>Well-defined tasks (Open-ended)</a:t>
+            </a:r>
+          </a:p>
+        </p:txBody>
+      </p:sp>
+      <p:sp>
+        <p:nvSpPr>
+          <p:cNvPr id="4" name="TextBox 3"/>
           <p:cNvSpPr txBox="1"/>
           <p:nvPr/>
         </p:nvSpPr>
         <p:spPr>
           <a:xfrm>
-            <a:off x="914400" y="1645920"/>
-            <a:ext cx="10360152" cy="914400"/>
+            <a:off x="2011680" y="1737360"/>
+            <a:ext cx="3657600" cy="457200"/>
           </a:xfrm>
           <a:prstGeom prst="rect">
             <a:avLst/>
@@ -5694,29 +6961,74 @@
           <a:lstStyle/>
           <a:p>
             <a:pPr algn="l">
-              <a:defRPr sz="2000" b="1">
-                <a:solidFill>
-                  <a:srgbClr val="FFD700"/>
-                </a:solidFill>
-                <a:latin typeface="Arial"/>
-              </a:defRPr>
-            </a:pPr>
-            <a:r>
-              <a:t>[Visual Concept: A nested boundary map showing Well-defined tasks → Computable tasks → Polynomial-time tasks]</a:t>
-            </a:r>
-          </a:p>
-        </p:txBody>
-      </p:sp>
-      <p:sp>
-        <p:nvSpPr>
-          <p:cNvPr id="4" name="TextBox 3"/>
+              <a:defRPr sz="1800" b="1">
+                <a:solidFill>
+                  <a:srgbClr val="00FFFF"/>
+                </a:solidFill>
+                <a:latin typeface="Arial"/>
+              </a:defRPr>
+            </a:pPr>
+            <a:r>
+              <a:t>Well-defined tasks (Open-ended)</a:t>
+            </a:r>
+          </a:p>
+        </p:txBody>
+      </p:sp>
+      <p:sp>
+        <p:nvSpPr>
+          <p:cNvPr id="5" name="Rounded Rectangle 4"/>
+          <p:cNvSpPr/>
+          <p:nvPr/>
+        </p:nvSpPr>
+        <p:spPr>
+          <a:xfrm>
+            <a:off x="1828800" y="1645920"/>
+            <a:ext cx="8531352" cy="2286000"/>
+          </a:xfrm>
+          <a:prstGeom prst="roundRect">
+            <a:avLst/>
+          </a:prstGeom>
+          <a:solidFill>
+            <a:srgbClr val="0A1929"/>
+          </a:solidFill>
+          <a:ln>
+            <a:solidFill>
+              <a:srgbClr val="00FFFF"/>
+            </a:solidFill>
+          </a:ln>
+        </p:spPr>
+        <p:style>
+          <a:lnRef idx="1">
+            <a:schemeClr val="accent1"/>
+          </a:lnRef>
+          <a:fillRef idx="3">
+            <a:schemeClr val="accent1"/>
+          </a:fillRef>
+          <a:effectRef idx="2">
+            <a:schemeClr val="accent1"/>
+          </a:effectRef>
+          <a:fontRef idx="minor">
+            <a:schemeClr val="lt1"/>
+          </a:fontRef>
+        </p:style>
+        <p:txBody>
+          <a:bodyPr rtlCol="0" anchor="ctr"/>
+          <a:lstStyle/>
+          <a:p>
+            <a:pPr algn="ctr"/>
+          </a:p>
+        </p:txBody>
+      </p:sp>
+      <p:sp>
+        <p:nvSpPr>
+          <p:cNvPr id="6" name="TextBox 5"/>
           <p:cNvSpPr txBox="1"/>
           <p:nvPr/>
         </p:nvSpPr>
         <p:spPr>
           <a:xfrm>
-            <a:off x="1097280" y="2651760"/>
-            <a:ext cx="10177272" cy="1005840"/>
+            <a:off x="2011680" y="1737360"/>
+            <a:ext cx="7315200" cy="457200"/>
           </a:xfrm>
           <a:prstGeom prst="rect">
             <a:avLst/>
@@ -5730,6 +7042,204 @@
           <a:lstStyle/>
           <a:p>
             <a:pPr algn="l">
+              <a:defRPr sz="1600" b="1">
+                <a:solidFill>
+                  <a:srgbClr val="00FFFF"/>
+                </a:solidFill>
+                <a:latin typeface="Arial"/>
+              </a:defRPr>
+            </a:pPr>
+            <a:r>
+              <a:t>Well-Defined Tasks (Open-Ended)</a:t>
+            </a:r>
+          </a:p>
+        </p:txBody>
+      </p:sp>
+      <p:sp>
+        <p:nvSpPr>
+          <p:cNvPr id="7" name="Rounded Rectangle 6"/>
+          <p:cNvSpPr/>
+          <p:nvPr/>
+        </p:nvSpPr>
+        <p:spPr>
+          <a:xfrm>
+            <a:off x="2743200" y="2103120"/>
+            <a:ext cx="6702552" cy="1645920"/>
+          </a:xfrm>
+          <a:prstGeom prst="roundRect">
+            <a:avLst/>
+          </a:prstGeom>
+          <a:solidFill>
+            <a:srgbClr val="0A1929"/>
+          </a:solidFill>
+          <a:ln>
+            <a:solidFill>
+              <a:srgbClr val="FFD700"/>
+            </a:solidFill>
+          </a:ln>
+        </p:spPr>
+        <p:style>
+          <a:lnRef idx="1">
+            <a:schemeClr val="accent1"/>
+          </a:lnRef>
+          <a:fillRef idx="3">
+            <a:schemeClr val="accent1"/>
+          </a:fillRef>
+          <a:effectRef idx="2">
+            <a:schemeClr val="accent1"/>
+          </a:effectRef>
+          <a:fontRef idx="minor">
+            <a:schemeClr val="lt1"/>
+          </a:fontRef>
+        </p:style>
+        <p:txBody>
+          <a:bodyPr rtlCol="0" anchor="ctr"/>
+          <a:lstStyle/>
+          <a:p>
+            <a:pPr algn="ctr"/>
+          </a:p>
+        </p:txBody>
+      </p:sp>
+      <p:sp>
+        <p:nvSpPr>
+          <p:cNvPr id="8" name="TextBox 7"/>
+          <p:cNvSpPr txBox="1"/>
+          <p:nvPr/>
+        </p:nvSpPr>
+        <p:spPr>
+          <a:xfrm>
+            <a:off x="2926080" y="2194560"/>
+            <a:ext cx="5486400" cy="457200"/>
+          </a:xfrm>
+          <a:prstGeom prst="rect">
+            <a:avLst/>
+          </a:prstGeom>
+          <a:noFill/>
+        </p:spPr>
+        <p:txBody>
+          <a:bodyPr wrap="square">
+            <a:spAutoFit/>
+          </a:bodyPr>
+          <a:lstStyle/>
+          <a:p>
+            <a:pPr algn="l">
+              <a:defRPr sz="1600" b="1">
+                <a:solidFill>
+                  <a:srgbClr val="FFD700"/>
+                </a:solidFill>
+                <a:latin typeface="Arial"/>
+              </a:defRPr>
+            </a:pPr>
+            <a:r>
+              <a:t>Computable Tasks</a:t>
+            </a:r>
+          </a:p>
+        </p:txBody>
+      </p:sp>
+      <p:sp>
+        <p:nvSpPr>
+          <p:cNvPr id="9" name="Rounded Rectangle 8"/>
+          <p:cNvSpPr/>
+          <p:nvPr/>
+        </p:nvSpPr>
+        <p:spPr>
+          <a:xfrm>
+            <a:off x="3657600" y="2560320"/>
+            <a:ext cx="4873752" cy="1005840"/>
+          </a:xfrm>
+          <a:prstGeom prst="roundRect">
+            <a:avLst/>
+          </a:prstGeom>
+          <a:solidFill>
+            <a:srgbClr val="0A1929"/>
+          </a:solidFill>
+          <a:ln>
+            <a:solidFill>
+              <a:srgbClr val="F0F0F0"/>
+            </a:solidFill>
+          </a:ln>
+        </p:spPr>
+        <p:style>
+          <a:lnRef idx="1">
+            <a:schemeClr val="accent1"/>
+          </a:lnRef>
+          <a:fillRef idx="3">
+            <a:schemeClr val="accent1"/>
+          </a:fillRef>
+          <a:effectRef idx="2">
+            <a:schemeClr val="accent1"/>
+          </a:effectRef>
+          <a:fontRef idx="minor">
+            <a:schemeClr val="lt1"/>
+          </a:fontRef>
+        </p:style>
+        <p:txBody>
+          <a:bodyPr rtlCol="0" anchor="ctr"/>
+          <a:lstStyle/>
+          <a:p>
+            <a:pPr algn="ctr"/>
+          </a:p>
+        </p:txBody>
+      </p:sp>
+      <p:sp>
+        <p:nvSpPr>
+          <p:cNvPr id="10" name="TextBox 9"/>
+          <p:cNvSpPr txBox="1"/>
+          <p:nvPr/>
+        </p:nvSpPr>
+        <p:spPr>
+          <a:xfrm>
+            <a:off x="3840480" y="2926080"/>
+            <a:ext cx="4572000" cy="457200"/>
+          </a:xfrm>
+          <a:prstGeom prst="rect">
+            <a:avLst/>
+          </a:prstGeom>
+          <a:noFill/>
+        </p:spPr>
+        <p:txBody>
+          <a:bodyPr wrap="square">
+            <a:spAutoFit/>
+          </a:bodyPr>
+          <a:lstStyle/>
+          <a:p>
+            <a:pPr algn="ctr">
+              <a:defRPr sz="1600" b="1">
+                <a:solidFill>
+                  <a:srgbClr val="F0F0F0"/>
+                </a:solidFill>
+                <a:latin typeface="Arial"/>
+              </a:defRPr>
+            </a:pPr>
+            <a:r>
+              <a:t>Polynomial-Time Feasible Tasks</a:t>
+            </a:r>
+          </a:p>
+        </p:txBody>
+      </p:sp>
+      <p:sp>
+        <p:nvSpPr>
+          <p:cNvPr id="11" name="TextBox 10"/>
+          <p:cNvSpPr txBox="1"/>
+          <p:nvPr/>
+        </p:nvSpPr>
+        <p:spPr>
+          <a:xfrm>
+            <a:off x="1097280" y="4206240"/>
+            <a:ext cx="10177272" cy="1005840"/>
+          </a:xfrm>
+          <a:prstGeom prst="rect">
+            <a:avLst/>
+          </a:prstGeom>
+          <a:noFill/>
+        </p:spPr>
+        <p:txBody>
+          <a:bodyPr wrap="square">
+            <a:spAutoFit/>
+          </a:bodyPr>
+          <a:lstStyle/>
+          <a:p>
+            <a:pPr algn="l">
               <a:defRPr sz="2400" b="0">
                 <a:solidFill>
                   <a:srgbClr val="F0F0F0"/>
@@ -5745,13 +7255,13 @@
       </p:sp>
       <p:sp>
         <p:nvSpPr>
-          <p:cNvPr id="5" name="TextBox 4"/>
+          <p:cNvPr id="12" name="TextBox 11"/>
           <p:cNvSpPr txBox="1"/>
           <p:nvPr/>
         </p:nvSpPr>
         <p:spPr>
           <a:xfrm>
-            <a:off x="1097280" y="3749040"/>
+            <a:off x="1097280" y="5303520"/>
             <a:ext cx="10177272" cy="1417320"/>
           </a:xfrm>
           <a:prstGeom prst="rect">
@@ -5872,7 +7382,7 @@
               </a:defRPr>
             </a:pPr>
             <a:r>
-              <a:t>The Transition: Pair 1 provides the formal structure, explaining exactly what progress means mathematically</a:t>
+              <a:t>• The Transition: Pair 1 provides the formal structure, explaining exactly what progress means mathematically</a:t>
             </a:r>
           </a:p>
         </p:txBody>

</xml_diff>